<commit_message>
docs: update mentor evidence in submission deck
</commit_message>
<xml_diff>
--- a/docs/TEAM30_SUBMISSION.pptx
+++ b/docs/TEAM30_SUBMISSION.pptx
@@ -2,18 +2,18 @@
 <file path=ppt/presentation.xml><?xml version="1.0" encoding="utf-8"?>
 <p:presentation xmlns:p="http://schemas.openxmlformats.org/presentationml/2006/main">
   <p:sldMasterIdLst>
-    <p:sldMasterId xmlns:r="http://schemas.openxmlformats.org/officeDocument/2006/relationships" id="2147483648" r:id="R4b859b1e840843f5"/>
+    <p:sldMasterId xmlns:r="http://schemas.openxmlformats.org/officeDocument/2006/relationships" id="2147483648" r:id="Rd03ec769591b401e"/>
   </p:sldMasterIdLst>
   <p:notesMasterIdLst>
-    <p:notesMasterId xmlns:r="http://schemas.openxmlformats.org/officeDocument/2006/relationships" r:id="Ra02dc69a68e74a13"/>
+    <p:notesMasterId xmlns:r="http://schemas.openxmlformats.org/officeDocument/2006/relationships" r:id="Rbe105a4c4b0343b5"/>
   </p:notesMasterIdLst>
   <p:sldIdLst>
-    <p:sldId xmlns:r="http://schemas.openxmlformats.org/officeDocument/2006/relationships" id="256" r:id="R83e64d9cbfa64b34"/>
-    <p:sldId xmlns:r="http://schemas.openxmlformats.org/officeDocument/2006/relationships" id="257" r:id="R49bd2fcf79a14f75"/>
-    <p:sldId xmlns:r="http://schemas.openxmlformats.org/officeDocument/2006/relationships" id="258" r:id="R141f345adbbb4557"/>
-    <p:sldId xmlns:r="http://schemas.openxmlformats.org/officeDocument/2006/relationships" id="259" r:id="R5ea0633db4ce4f85"/>
-    <p:sldId xmlns:r="http://schemas.openxmlformats.org/officeDocument/2006/relationships" id="260" r:id="Re68defbc30b64911"/>
-    <p:sldId xmlns:r="http://schemas.openxmlformats.org/officeDocument/2006/relationships" id="261" r:id="Rfc5c90e9a9d54881"/>
+    <p:sldId xmlns:r="http://schemas.openxmlformats.org/officeDocument/2006/relationships" id="256" r:id="Rfaca620380bf4ccf"/>
+    <p:sldId xmlns:r="http://schemas.openxmlformats.org/officeDocument/2006/relationships" id="257" r:id="R6bac2286ef3845b6"/>
+    <p:sldId xmlns:r="http://schemas.openxmlformats.org/officeDocument/2006/relationships" id="258" r:id="R22a57be18632484b"/>
+    <p:sldId xmlns:r="http://schemas.openxmlformats.org/officeDocument/2006/relationships" id="259" r:id="R8eaffb0886a2492b"/>
+    <p:sldId xmlns:r="http://schemas.openxmlformats.org/officeDocument/2006/relationships" id="260" r:id="R6f7fc07e68144ba0"/>
+    <p:sldId xmlns:r="http://schemas.openxmlformats.org/officeDocument/2006/relationships" id="261" r:id="R97b173afa08c471f"/>
   </p:sldIdLst>
   <p:sldSz cx="12192000" cy="6858000"/>
   <p:notesSz cx="6858000" cy="9144000"/>
@@ -587,7 +587,7 @@
           <a:lstStyle xmlns:a="http://schemas.openxmlformats.org/drawingml/2006/main"/>
           <a:p xmlns:a="http://schemas.openxmlformats.org/drawingml/2006/main">
             <a:r>
-              <a:t>Architecture: app Compose/Kotlin, Room, Nearby Connections, Tink and Android Keystore. Extras source docs/evidence/extras-phone-test.md; laptop and dashboard through USB adb reverse, not phone-to-laptop Wi-Fi. AI was off.</a:t>
+              <a:t>Architecture and tested mentor changes: docs/evidence/mentor-fixes.md. Extras: docs/evidence/extras-phone-test.md. Laptop and dashboard used USB adb reverse. AI was off.</a:t>
             </a:r>
           </a:p>
         </p:txBody>
@@ -657,7 +657,7 @@
           <a:lstStyle xmlns:a="http://schemas.openxmlformats.org/drawingml/2006/main"/>
           <a:p xmlns:a="http://schemas.openxmlformats.org/drawingml/2006/main">
             <a:r>
-              <a:t>Sources: docs/evidence/final-build.md, required-features.md, extras-phone-test.md. Three phones, 119/119 tests for the final core build. Do not claim all extras were fully offline.</a:t>
+              <a:t>Sources: docs/evidence/mentor-fixes.md, final-build.md, required-features.md, extras-phone-test.md. The mentor changes test used indoor debug locations on three phones.</a:t>
             </a:r>
           </a:p>
         </p:txBody>
@@ -797,7 +797,7 @@
           <a:lstStyle xmlns:a="http://schemas.openxmlformats.org/drawingml/2006/main"/>
           <a:p xmlns:a="http://schemas.openxmlformats.org/drawingml/2006/main">
             <a:r>
-              <a:t>Routing and User/Responder/Admin area roles are being built on separate branches. Verify merged final APK on phones before presenting them as completed. Status timeline was tested in final-build.md.</a:t>
+              <a:t>Source: docs/evidence/mentor-fixes.md. Routing: verified traffic, five-minute expiration, removed on disconnect, eight-second fallback, floods for SOS and area alerts. Role logins offline with public keys only. Admin uses distance and direction without maps. Call-Out, Talk-Back, Last Breath, no-app SOS intake and laptop node are prototype extras. No-app test still used an app-installed phone.</a:t>
             </a:r>
           </a:p>
         </p:txBody>
@@ -844,7 +844,7 @@
           <p:cNvPr id="3" name="Title">
             <a:extLst xmlns:a="http://schemas.openxmlformats.org/drawingml/2006/main">
               <a:ext uri="{FF2B5EF4-FFF2-40B4-BE49-F238E27FC236}">
-                <a16:creationId xmlns:a16="http://schemas.microsoft.com/office/drawing/2014/main" id="{0CC413F8-8F81-4745-9B6F-C3D40A6ACD69}"/>
+                <a16:creationId xmlns:a16="http://schemas.microsoft.com/office/drawing/2014/main" id="{7B12A351-C688-4339-8457-203E08F113A6}"/>
               </a:ext>
             </a:extLst>
           </p:cNvPr>
@@ -1073,7 +1073,7 @@
           <p:cNvPr id="2" name="Subtitle">
             <a:extLst xmlns:a="http://schemas.openxmlformats.org/drawingml/2006/main">
               <a:ext uri="{FF2B5EF4-FFF2-40B4-BE49-F238E27FC236}">
-                <a16:creationId xmlns:a16="http://schemas.microsoft.com/office/drawing/2014/main" id="{6AB37D95-F8DB-4D70-839F-72006236E717}"/>
+                <a16:creationId xmlns:a16="http://schemas.microsoft.com/office/drawing/2014/main" id="{E78040B8-124A-430F-B08F-817159A77FEB}"/>
               </a:ext>
             </a:extLst>
           </p:cNvPr>
@@ -1319,7 +1319,7 @@
           <p:cNvPr id="2" name="Section title">
             <a:extLst xmlns:a="http://schemas.openxmlformats.org/drawingml/2006/main">
               <a:ext uri="{FF2B5EF4-FFF2-40B4-BE49-F238E27FC236}">
-                <a16:creationId xmlns:a16="http://schemas.microsoft.com/office/drawing/2014/main" id="{2AF8714E-ED3D-46B6-BC81-3F3DBCA05523}"/>
+                <a16:creationId xmlns:a16="http://schemas.microsoft.com/office/drawing/2014/main" id="{BD6E12A2-C405-40DA-9E3B-0509502A9508}"/>
               </a:ext>
             </a:extLst>
           </p:cNvPr>
@@ -1565,7 +1565,7 @@
           <p:cNvPr id="3" name="Title">
             <a:extLst xmlns:a="http://schemas.openxmlformats.org/drawingml/2006/main">
               <a:ext uri="{FF2B5EF4-FFF2-40B4-BE49-F238E27FC236}">
-                <a16:creationId xmlns:a16="http://schemas.microsoft.com/office/drawing/2014/main" id="{D922D2D7-E383-49EE-B39F-FF74669A8C5B}"/>
+                <a16:creationId xmlns:a16="http://schemas.microsoft.com/office/drawing/2014/main" id="{19EA0527-902F-45D8-A97A-2A0EB78BF83D}"/>
               </a:ext>
             </a:extLst>
           </p:cNvPr>
@@ -1794,7 +1794,7 @@
           <p:cNvPr id="2" name="Body">
             <a:extLst xmlns:a="http://schemas.openxmlformats.org/drawingml/2006/main">
               <a:ext uri="{FF2B5EF4-FFF2-40B4-BE49-F238E27FC236}">
-                <a16:creationId xmlns:a16="http://schemas.microsoft.com/office/drawing/2014/main" id="{4B157BBB-F590-4F90-A69A-9FB35FC43D2B}"/>
+                <a16:creationId xmlns:a16="http://schemas.microsoft.com/office/drawing/2014/main" id="{8C246976-C6A1-4EAC-AE89-15A9457C803D}"/>
               </a:ext>
             </a:extLst>
           </p:cNvPr>
@@ -2040,7 +2040,7 @@
           <p:cNvPr id="4" name="Title">
             <a:extLst xmlns:a="http://schemas.openxmlformats.org/drawingml/2006/main">
               <a:ext uri="{FF2B5EF4-FFF2-40B4-BE49-F238E27FC236}">
-                <a16:creationId xmlns:a16="http://schemas.microsoft.com/office/drawing/2014/main" id="{1953E0D1-7DC5-4280-8DB1-F75803A87653}"/>
+                <a16:creationId xmlns:a16="http://schemas.microsoft.com/office/drawing/2014/main" id="{469718CA-3FBE-4EDD-B43D-A280894326EB}"/>
               </a:ext>
             </a:extLst>
           </p:cNvPr>
@@ -2269,7 +2269,7 @@
           <p:cNvPr id="2" name="Left column">
             <a:extLst xmlns:a="http://schemas.openxmlformats.org/drawingml/2006/main">
               <a:ext uri="{FF2B5EF4-FFF2-40B4-BE49-F238E27FC236}">
-                <a16:creationId xmlns:a16="http://schemas.microsoft.com/office/drawing/2014/main" id="{5B016984-3DF6-40CE-9B8D-5F4E5C23416B}"/>
+                <a16:creationId xmlns:a16="http://schemas.microsoft.com/office/drawing/2014/main" id="{7405A5DD-F2AC-4F00-9C7F-E1FB5CEE7E3D}"/>
               </a:ext>
             </a:extLst>
           </p:cNvPr>
@@ -2498,7 +2498,7 @@
           <p:cNvPr id="3" name="Right column">
             <a:extLst xmlns:a="http://schemas.openxmlformats.org/drawingml/2006/main">
               <a:ext uri="{FF2B5EF4-FFF2-40B4-BE49-F238E27FC236}">
-                <a16:creationId xmlns:a16="http://schemas.microsoft.com/office/drawing/2014/main" id="{70170979-9773-405D-B436-891D03776B9B}"/>
+                <a16:creationId xmlns:a16="http://schemas.microsoft.com/office/drawing/2014/main" id="{5BED7D0C-0DE2-4C78-BC6C-D1D802233051}"/>
               </a:ext>
             </a:extLst>
           </p:cNvPr>
@@ -2744,7 +2744,7 @@
           <p:cNvPr id="3" name="Title">
             <a:extLst xmlns:a="http://schemas.openxmlformats.org/drawingml/2006/main">
               <a:ext uri="{FF2B5EF4-FFF2-40B4-BE49-F238E27FC236}">
-                <a16:creationId xmlns:a16="http://schemas.microsoft.com/office/drawing/2014/main" id="{93C196FA-FEB7-4210-94F1-DA42DF65D33F}"/>
+                <a16:creationId xmlns:a16="http://schemas.microsoft.com/office/drawing/2014/main" id="{C9FFB1B8-0B62-4E25-8FCD-9710697CEFC6}"/>
               </a:ext>
             </a:extLst>
           </p:cNvPr>
@@ -2973,7 +2973,7 @@
           <p:cNvPr id="2" name="Left column">
             <a:extLst xmlns:a="http://schemas.openxmlformats.org/drawingml/2006/main">
               <a:ext uri="{FF2B5EF4-FFF2-40B4-BE49-F238E27FC236}">
-                <a16:creationId xmlns:a16="http://schemas.microsoft.com/office/drawing/2014/main" id="{7832B7F6-C758-47D6-902D-618DEE1093D4}"/>
+                <a16:creationId xmlns:a16="http://schemas.microsoft.com/office/drawing/2014/main" id="{9E1FF30D-B351-4A6F-BAE8-B8FA735527EB}"/>
               </a:ext>
             </a:extLst>
           </p:cNvPr>
@@ -3240,12 +3240,12 @@
   </p:cSld>
   <p:clrMap bg1="lt1" tx1="dk1" bg2="lt2" tx2="dk2" accent1="accent1" accent2="accent2" accent3="accent3" accent4="accent4" accent5="accent5" accent6="accent6" hlink="hlink" folHlink="folHlink"/>
   <p:sldLayoutIdLst>
-    <p:sldLayoutId xmlns:r="http://schemas.openxmlformats.org/officeDocument/2006/relationships" id="2147483649" r:id="R8f1bc46e8ef94ff1"/>
-    <p:sldLayoutId xmlns:r="http://schemas.openxmlformats.org/officeDocument/2006/relationships" id="2147483650" r:id="R933ad6cc13f54f62"/>
-    <p:sldLayoutId xmlns:r="http://schemas.openxmlformats.org/officeDocument/2006/relationships" id="2147483651" r:id="Rdc3e6cfd533448c2"/>
-    <p:sldLayoutId xmlns:r="http://schemas.openxmlformats.org/officeDocument/2006/relationships" id="2147483652" r:id="R114f812a6cd84cca"/>
-    <p:sldLayoutId xmlns:r="http://schemas.openxmlformats.org/officeDocument/2006/relationships" id="2147483653" r:id="R54dbad12eb554711"/>
-    <p:sldLayoutId xmlns:r="http://schemas.openxmlformats.org/officeDocument/2006/relationships" id="2147483654" r:id="R8ff35dbf0ddc449a"/>
+    <p:sldLayoutId xmlns:r="http://schemas.openxmlformats.org/officeDocument/2006/relationships" id="2147483649" r:id="Rdc931311c5b64def"/>
+    <p:sldLayoutId xmlns:r="http://schemas.openxmlformats.org/officeDocument/2006/relationships" id="2147483650" r:id="Rd4cdce5bd51a4fc8"/>
+    <p:sldLayoutId xmlns:r="http://schemas.openxmlformats.org/officeDocument/2006/relationships" id="2147483651" r:id="R278b9e681a7e4b38"/>
+    <p:sldLayoutId xmlns:r="http://schemas.openxmlformats.org/officeDocument/2006/relationships" id="2147483652" r:id="R1b8d9860e31f4a74"/>
+    <p:sldLayoutId xmlns:r="http://schemas.openxmlformats.org/officeDocument/2006/relationships" id="2147483653" r:id="R949ff1d840dc43e3"/>
+    <p:sldLayoutId xmlns:r="http://schemas.openxmlformats.org/officeDocument/2006/relationships" id="2147483654" r:id="R4ffe234de6d74403"/>
   </p:sldLayoutIdLst>
   <p:txStyles>
     <p:titleStyle>
@@ -3796,7 +3796,7 @@
           <p:cNvPr id="6" name="">
             <a:extLst xmlns:a="http://schemas.openxmlformats.org/drawingml/2006/main">
               <a:ext uri="{FF2B5EF4-FFF2-40B4-BE49-F238E27FC236}">
-                <a16:creationId xmlns:a16="http://schemas.microsoft.com/office/drawing/2014/main" id="{D024DE28-8408-41CE-9D64-146DCFD9ED7D}"/>
+                <a16:creationId xmlns:a16="http://schemas.microsoft.com/office/drawing/2014/main" id="{F058AA9F-CF3B-481F-8178-20A1A44B1310}"/>
               </a:ext>
             </a:extLst>
           </p:cNvPr>
@@ -3953,7 +3953,7 @@
           <p:cNvPr id="2" name="">
             <a:extLst xmlns:a="http://schemas.openxmlformats.org/drawingml/2006/main">
               <a:ext uri="{FF2B5EF4-FFF2-40B4-BE49-F238E27FC236}">
-                <a16:creationId xmlns:a16="http://schemas.microsoft.com/office/drawing/2014/main" id="{C3C4CF21-8599-4ED5-814A-41BBAD289078}"/>
+                <a16:creationId xmlns:a16="http://schemas.microsoft.com/office/drawing/2014/main" id="{7B91812A-3364-4870-9431-D34284D8AE3E}"/>
               </a:ext>
             </a:extLst>
           </p:cNvPr>
@@ -4110,7 +4110,7 @@
           <p:cNvPr id="3" name="">
             <a:extLst xmlns:a="http://schemas.openxmlformats.org/drawingml/2006/main">
               <a:ext uri="{FF2B5EF4-FFF2-40B4-BE49-F238E27FC236}">
-                <a16:creationId xmlns:a16="http://schemas.microsoft.com/office/drawing/2014/main" id="{6F9FCDBF-83C5-4EA7-80CB-F2477A461BD9}"/>
+                <a16:creationId xmlns:a16="http://schemas.microsoft.com/office/drawing/2014/main" id="{85AF7E3B-7034-41DB-AD2C-399627639DC8}"/>
               </a:ext>
             </a:extLst>
           </p:cNvPr>
@@ -4267,7 +4267,7 @@
           <p:cNvPr id="4" name="">
             <a:extLst xmlns:a="http://schemas.openxmlformats.org/drawingml/2006/main">
               <a:ext uri="{FF2B5EF4-FFF2-40B4-BE49-F238E27FC236}">
-                <a16:creationId xmlns:a16="http://schemas.microsoft.com/office/drawing/2014/main" id="{34CA8230-6AF3-45B6-B7BC-6AB3261DE468}"/>
+                <a16:creationId xmlns:a16="http://schemas.microsoft.com/office/drawing/2014/main" id="{01B75782-DF73-4B41-9B5F-43EE330DB382}"/>
               </a:ext>
             </a:extLst>
           </p:cNvPr>
@@ -4424,7 +4424,7 @@
           <p:cNvPr id="5" name="">
             <a:extLst xmlns:a="http://schemas.openxmlformats.org/drawingml/2006/main">
               <a:ext uri="{FF2B5EF4-FFF2-40B4-BE49-F238E27FC236}">
-                <a16:creationId xmlns:a16="http://schemas.microsoft.com/office/drawing/2014/main" id="{F1698DA2-E4E5-4796-972B-87756CF2464E}"/>
+                <a16:creationId xmlns:a16="http://schemas.microsoft.com/office/drawing/2014/main" id="{E40B5309-DDB0-4DBB-B74E-218A46B6A92E}"/>
               </a:ext>
             </a:extLst>
           </p:cNvPr>
@@ -4579,7 +4579,7 @@
     </p:spTree>
     <p:extLst>
       <p:ext uri="{BB962C8B-B14F-4D97-AF65-F5344CB8AC3E}">
-        <p14:creationId xmlns:p14="http://schemas.microsoft.com/office/powerpoint/2010/main" val="666583008"/>
+        <p14:creationId xmlns:p14="http://schemas.microsoft.com/office/powerpoint/2010/main" val="450349545"/>
       </p:ext>
     </p:extLst>
   </p:cSld>
@@ -4610,7 +4610,7 @@
           <p:cNvPr id="7" name="">
             <a:extLst xmlns:a="http://schemas.openxmlformats.org/drawingml/2006/main">
               <a:ext uri="{FF2B5EF4-FFF2-40B4-BE49-F238E27FC236}">
-                <a16:creationId xmlns:a16="http://schemas.microsoft.com/office/drawing/2014/main" id="{9744D387-3C24-4196-BB52-49941FDD6CE3}"/>
+                <a16:creationId xmlns:a16="http://schemas.microsoft.com/office/drawing/2014/main" id="{8BC044CE-B01F-42A4-B223-A60F142A25ED}"/>
               </a:ext>
             </a:extLst>
           </p:cNvPr>
@@ -4767,7 +4767,7 @@
           <p:cNvPr id="2" name="">
             <a:extLst xmlns:a="http://schemas.openxmlformats.org/drawingml/2006/main">
               <a:ext uri="{FF2B5EF4-FFF2-40B4-BE49-F238E27FC236}">
-                <a16:creationId xmlns:a16="http://schemas.microsoft.com/office/drawing/2014/main" id="{C75B37A0-0571-475C-A584-8BAA105670D1}"/>
+                <a16:creationId xmlns:a16="http://schemas.microsoft.com/office/drawing/2014/main" id="{5BC86180-E7B2-4C8B-8869-1DC6C0E23B7F}"/>
               </a:ext>
             </a:extLst>
           </p:cNvPr>
@@ -4924,7 +4924,7 @@
           <p:cNvPr id="3" name="">
             <a:extLst xmlns:a="http://schemas.openxmlformats.org/drawingml/2006/main">
               <a:ext uri="{FF2B5EF4-FFF2-40B4-BE49-F238E27FC236}">
-                <a16:creationId xmlns:a16="http://schemas.microsoft.com/office/drawing/2014/main" id="{D91AAD83-8CD4-4EED-9439-C968E43BD005}"/>
+                <a16:creationId xmlns:a16="http://schemas.microsoft.com/office/drawing/2014/main" id="{0C9632E7-8CCD-4A19-8DD4-0FD1932A790E}"/>
               </a:ext>
             </a:extLst>
           </p:cNvPr>
@@ -5081,7 +5081,7 @@
           <p:cNvPr id="4" name="">
             <a:extLst xmlns:a="http://schemas.openxmlformats.org/drawingml/2006/main">
               <a:ext uri="{FF2B5EF4-FFF2-40B4-BE49-F238E27FC236}">
-                <a16:creationId xmlns:a16="http://schemas.microsoft.com/office/drawing/2014/main" id="{BD0D3212-8A41-4855-BECC-4FBA6CC733CE}"/>
+                <a16:creationId xmlns:a16="http://schemas.microsoft.com/office/drawing/2014/main" id="{F6EDB940-623A-41FA-98BB-B46B1FF32482}"/>
               </a:ext>
             </a:extLst>
           </p:cNvPr>
@@ -5238,7 +5238,7 @@
           <p:cNvPr id="5" name="">
             <a:extLst xmlns:a="http://schemas.openxmlformats.org/drawingml/2006/main">
               <a:ext uri="{FF2B5EF4-FFF2-40B4-BE49-F238E27FC236}">
-                <a16:creationId xmlns:a16="http://schemas.microsoft.com/office/drawing/2014/main" id="{1D9F3A11-766D-447C-8D3E-A4ED8BB76DF5}"/>
+                <a16:creationId xmlns:a16="http://schemas.microsoft.com/office/drawing/2014/main" id="{DCF3E20E-4CD4-4CC2-90A1-116F7983052C}"/>
               </a:ext>
             </a:extLst>
           </p:cNvPr>
@@ -5395,7 +5395,7 @@
           <p:cNvPr id="6" name="">
             <a:extLst xmlns:a="http://schemas.openxmlformats.org/drawingml/2006/main">
               <a:ext uri="{FF2B5EF4-FFF2-40B4-BE49-F238E27FC236}">
-                <a16:creationId xmlns:a16="http://schemas.microsoft.com/office/drawing/2014/main" id="{3C091223-DBA2-4D4E-BC12-23E66062A4B9}"/>
+                <a16:creationId xmlns:a16="http://schemas.microsoft.com/office/drawing/2014/main" id="{4CC00052-A70C-4B23-8C5C-4B230B05A78A}"/>
               </a:ext>
             </a:extLst>
           </p:cNvPr>
@@ -5550,7 +5550,7 @@
     </p:spTree>
     <p:extLst>
       <p:ext uri="{BB962C8B-B14F-4D97-AF65-F5344CB8AC3E}">
-        <p14:creationId xmlns:p14="http://schemas.microsoft.com/office/powerpoint/2010/main" val="963018195"/>
+        <p14:creationId xmlns:p14="http://schemas.microsoft.com/office/powerpoint/2010/main" val="1288733491"/>
       </p:ext>
     </p:extLst>
   </p:cSld>
@@ -5578,10 +5578,10 @@
       </p:grpSpPr>
       <p:sp>
         <p:nvSpPr>
-          <p:cNvPr id="7" name="">
+          <p:cNvPr id="8" name="">
             <a:extLst xmlns:a="http://schemas.openxmlformats.org/drawingml/2006/main">
               <a:ext uri="{FF2B5EF4-FFF2-40B4-BE49-F238E27FC236}">
-                <a16:creationId xmlns:a16="http://schemas.microsoft.com/office/drawing/2014/main" id="{244155D8-89A4-4850-B712-4C6F79E93E9E}"/>
+                <a16:creationId xmlns:a16="http://schemas.microsoft.com/office/drawing/2014/main" id="{3C91896A-75C2-4D1C-8BD3-FCE6184B0D91}"/>
               </a:ext>
             </a:extLst>
           </p:cNvPr>
@@ -5738,7 +5738,7 @@
           <p:cNvPr id="2" name="">
             <a:extLst xmlns:a="http://schemas.openxmlformats.org/drawingml/2006/main">
               <a:ext uri="{FF2B5EF4-FFF2-40B4-BE49-F238E27FC236}">
-                <a16:creationId xmlns:a16="http://schemas.microsoft.com/office/drawing/2014/main" id="{018EC181-FDD7-42AF-B710-0B90ABDC7720}"/>
+                <a16:creationId xmlns:a16="http://schemas.microsoft.com/office/drawing/2014/main" id="{18F43A82-827A-4AE5-9CD8-A8CBE3C71245}"/>
               </a:ext>
             </a:extLst>
           </p:cNvPr>
@@ -5895,7 +5895,7 @@
           <p:cNvPr id="3" name="">
             <a:extLst xmlns:a="http://schemas.openxmlformats.org/drawingml/2006/main">
               <a:ext uri="{FF2B5EF4-FFF2-40B4-BE49-F238E27FC236}">
-                <a16:creationId xmlns:a16="http://schemas.microsoft.com/office/drawing/2014/main" id="{4693F5D8-16FD-4923-8521-D3BC3F5F0EDF}"/>
+                <a16:creationId xmlns:a16="http://schemas.microsoft.com/office/drawing/2014/main" id="{419C9199-B3EA-4D63-B040-47925FAC53C5}"/>
               </a:ext>
             </a:extLst>
           </p:cNvPr>
@@ -5906,8 +5906,8 @@
         </p:nvSpPr>
         <p:spPr>
           <a:xfrm xmlns:a="http://schemas.openxmlformats.org/drawingml/2006/main">
-            <a:off x="619125" y="1714500"/>
-            <a:ext cx="10096500" cy="552450"/>
+            <a:off x="619125" y="1666875"/>
+            <a:ext cx="10572750" cy="628650"/>
           </a:xfrm>
           <a:prstGeom xmlns:a="http://schemas.openxmlformats.org/drawingml/2006/main" prst="rect">
             <a:avLst/>
@@ -5922,7 +5922,7 @@
           <a:bodyPr xmlns:a="http://schemas.openxmlformats.org/drawingml/2006/main"/>
           <a:lstStyle xmlns:a="http://schemas.openxmlformats.org/drawingml/2006/main">
             <a:defPPr>
-              <a:defRPr sz="2175" b="0">
+              <a:defRPr sz="2025" b="0">
                 <a:solidFill>
                   <a:srgbClr val="F4F6FA"/>
                 </a:solidFill>
@@ -5932,7 +5932,7 @@
               </a:defRPr>
             </a:defPPr>
             <a:lvl1pPr>
-              <a:defRPr sz="2175" b="0">
+              <a:defRPr sz="2025" b="0">
                 <a:solidFill>
                   <a:srgbClr val="F4F6FA"/>
                 </a:solidFill>
@@ -5942,7 +5942,7 @@
               </a:defRPr>
             </a:lvl1pPr>
             <a:lvl2pPr>
-              <a:defRPr sz="2175" b="0">
+              <a:defRPr sz="2025" b="0">
                 <a:solidFill>
                   <a:srgbClr val="F4F6FA"/>
                 </a:solidFill>
@@ -5952,7 +5952,7 @@
               </a:defRPr>
             </a:lvl2pPr>
             <a:lvl3pPr>
-              <a:defRPr sz="2175" b="0">
+              <a:defRPr sz="2025" b="0">
                 <a:solidFill>
                   <a:srgbClr val="F4F6FA"/>
                 </a:solidFill>
@@ -5962,7 +5962,7 @@
               </a:defRPr>
             </a:lvl3pPr>
             <a:lvl4pPr>
-              <a:defRPr sz="2175" b="0">
+              <a:defRPr sz="2025" b="0">
                 <a:solidFill>
                   <a:srgbClr val="F4F6FA"/>
                 </a:solidFill>
@@ -5972,7 +5972,7 @@
               </a:defRPr>
             </a:lvl4pPr>
             <a:lvl5pPr>
-              <a:defRPr sz="2175" b="0">
+              <a:defRPr sz="2025" b="0">
                 <a:solidFill>
                   <a:srgbClr val="F4F6FA"/>
                 </a:solidFill>
@@ -5982,7 +5982,7 @@
               </a:defRPr>
             </a:lvl5pPr>
             <a:lvl6pPr>
-              <a:defRPr sz="2175" b="0">
+              <a:defRPr sz="2025" b="0">
                 <a:solidFill>
                   <a:srgbClr val="F4F6FA"/>
                 </a:solidFill>
@@ -5992,7 +5992,7 @@
               </a:defRPr>
             </a:lvl6pPr>
             <a:lvl7pPr>
-              <a:defRPr sz="2175" b="0">
+              <a:defRPr sz="2025" b="0">
                 <a:solidFill>
                   <a:srgbClr val="F4F6FA"/>
                 </a:solidFill>
@@ -6002,7 +6002,7 @@
               </a:defRPr>
             </a:lvl7pPr>
             <a:lvl8pPr>
-              <a:defRPr sz="2175" b="0">
+              <a:defRPr sz="2025" b="0">
                 <a:solidFill>
                   <a:srgbClr val="F4F6FA"/>
                 </a:solidFill>
@@ -6012,7 +6012,7 @@
               </a:defRPr>
             </a:lvl8pPr>
             <a:lvl9pPr>
-              <a:defRPr sz="2175" b="0">
+              <a:defRPr sz="2025" b="0">
                 <a:solidFill>
                   <a:srgbClr val="F4F6FA"/>
                 </a:solidFill>
@@ -6024,7 +6024,7 @@
           </a:lstStyle>
           <a:p xmlns:a="http://schemas.openxmlformats.org/drawingml/2006/main">
             <a:pPr>
-              <a:defRPr sz="2175" b="0">
+              <a:defRPr sz="2025" b="0">
                 <a:solidFill>
                   <a:srgbClr val="F4F6FA"/>
                 </a:solidFill>
@@ -6034,7 +6034,7 @@
               </a:defRPr>
             </a:pPr>
             <a:r>
-              <a:rPr sz="2175" b="0">
+              <a:rPr sz="2025" b="0">
                 <a:solidFill>
                   <a:srgbClr val="F4F6FA"/>
                 </a:solidFill>
@@ -6042,7 +6042,7 @@
                 <a:ea typeface="DejaVu Sans"/>
                 <a:cs typeface="DejaVu Sans"/>
               </a:rPr>
-              <a:t>Compose interface and Room message queue</a:t>
+              <a:t>Compose, Room, Nearby Connections and Tink protection</a:t>
             </a:r>
           </a:p>
         </p:txBody>
@@ -6052,7 +6052,7 @@
           <p:cNvPr id="4" name="">
             <a:extLst xmlns:a="http://schemas.openxmlformats.org/drawingml/2006/main">
               <a:ext uri="{FF2B5EF4-FFF2-40B4-BE49-F238E27FC236}">
-                <a16:creationId xmlns:a16="http://schemas.microsoft.com/office/drawing/2014/main" id="{0AB2AC55-B99C-4A89-8D0A-0A2DEC757193}"/>
+                <a16:creationId xmlns:a16="http://schemas.microsoft.com/office/drawing/2014/main" id="{39216D02-735B-49E5-A4AF-F02124DCC583}"/>
               </a:ext>
             </a:extLst>
           </p:cNvPr>
@@ -6063,8 +6063,8 @@
         </p:nvSpPr>
         <p:spPr>
           <a:xfrm xmlns:a="http://schemas.openxmlformats.org/drawingml/2006/main">
-            <a:off x="619125" y="2514600"/>
-            <a:ext cx="10096500" cy="552450"/>
+            <a:off x="619125" y="2476500"/>
+            <a:ext cx="10572750" cy="628650"/>
           </a:xfrm>
           <a:prstGeom xmlns:a="http://schemas.openxmlformats.org/drawingml/2006/main" prst="rect">
             <a:avLst/>
@@ -6079,7 +6079,7 @@
           <a:bodyPr xmlns:a="http://schemas.openxmlformats.org/drawingml/2006/main"/>
           <a:lstStyle xmlns:a="http://schemas.openxmlformats.org/drawingml/2006/main">
             <a:defPPr>
-              <a:defRPr sz="2175" b="0">
+              <a:defRPr sz="2025" b="0">
                 <a:solidFill>
                   <a:srgbClr val="F4F6FA"/>
                 </a:solidFill>
@@ -6089,7 +6089,7 @@
               </a:defRPr>
             </a:defPPr>
             <a:lvl1pPr>
-              <a:defRPr sz="2175" b="0">
+              <a:defRPr sz="2025" b="0">
                 <a:solidFill>
                   <a:srgbClr val="F4F6FA"/>
                 </a:solidFill>
@@ -6099,7 +6099,7 @@
               </a:defRPr>
             </a:lvl1pPr>
             <a:lvl2pPr>
-              <a:defRPr sz="2175" b="0">
+              <a:defRPr sz="2025" b="0">
                 <a:solidFill>
                   <a:srgbClr val="F4F6FA"/>
                 </a:solidFill>
@@ -6109,7 +6109,7 @@
               </a:defRPr>
             </a:lvl2pPr>
             <a:lvl3pPr>
-              <a:defRPr sz="2175" b="0">
+              <a:defRPr sz="2025" b="0">
                 <a:solidFill>
                   <a:srgbClr val="F4F6FA"/>
                 </a:solidFill>
@@ -6119,7 +6119,7 @@
               </a:defRPr>
             </a:lvl3pPr>
             <a:lvl4pPr>
-              <a:defRPr sz="2175" b="0">
+              <a:defRPr sz="2025" b="0">
                 <a:solidFill>
                   <a:srgbClr val="F4F6FA"/>
                 </a:solidFill>
@@ -6129,7 +6129,7 @@
               </a:defRPr>
             </a:lvl4pPr>
             <a:lvl5pPr>
-              <a:defRPr sz="2175" b="0">
+              <a:defRPr sz="2025" b="0">
                 <a:solidFill>
                   <a:srgbClr val="F4F6FA"/>
                 </a:solidFill>
@@ -6139,7 +6139,7 @@
               </a:defRPr>
             </a:lvl5pPr>
             <a:lvl6pPr>
-              <a:defRPr sz="2175" b="0">
+              <a:defRPr sz="2025" b="0">
                 <a:solidFill>
                   <a:srgbClr val="F4F6FA"/>
                 </a:solidFill>
@@ -6149,7 +6149,7 @@
               </a:defRPr>
             </a:lvl6pPr>
             <a:lvl7pPr>
-              <a:defRPr sz="2175" b="0">
+              <a:defRPr sz="2025" b="0">
                 <a:solidFill>
                   <a:srgbClr val="F4F6FA"/>
                 </a:solidFill>
@@ -6159,7 +6159,7 @@
               </a:defRPr>
             </a:lvl7pPr>
             <a:lvl8pPr>
-              <a:defRPr sz="2175" b="0">
+              <a:defRPr sz="2025" b="0">
                 <a:solidFill>
                   <a:srgbClr val="F4F6FA"/>
                 </a:solidFill>
@@ -6169,7 +6169,7 @@
               </a:defRPr>
             </a:lvl8pPr>
             <a:lvl9pPr>
-              <a:defRPr sz="2175" b="0">
+              <a:defRPr sz="2025" b="0">
                 <a:solidFill>
                   <a:srgbClr val="F4F6FA"/>
                 </a:solidFill>
@@ -6181,7 +6181,7 @@
           </a:lstStyle>
           <a:p xmlns:a="http://schemas.openxmlformats.org/drawingml/2006/main">
             <a:pPr>
-              <a:defRPr sz="2175" b="0">
+              <a:defRPr sz="2025" b="0">
                 <a:solidFill>
                   <a:srgbClr val="F4F6FA"/>
                 </a:solidFill>
@@ -6191,7 +6191,7 @@
               </a:defRPr>
             </a:pPr>
             <a:r>
-              <a:rPr sz="2175" b="0">
+              <a:rPr sz="2025" b="0">
                 <a:solidFill>
                   <a:srgbClr val="F4F6FA"/>
                 </a:solidFill>
@@ -6199,7 +6199,7 @@
                 <a:ea typeface="DejaVu Sans"/>
                 <a:cs typeface="DejaVu Sans"/>
               </a:rPr>
-              <a:t>Nearby Connections relay and delivery acknowledgements</a:t>
+              <a:t>User, Responder and Admin logins work offline</a:t>
             </a:r>
           </a:p>
         </p:txBody>
@@ -6209,7 +6209,7 @@
           <p:cNvPr id="5" name="">
             <a:extLst xmlns:a="http://schemas.openxmlformats.org/drawingml/2006/main">
               <a:ext uri="{FF2B5EF4-FFF2-40B4-BE49-F238E27FC236}">
-                <a16:creationId xmlns:a16="http://schemas.microsoft.com/office/drawing/2014/main" id="{08D80530-BDAF-44E9-B860-99EB0429C945}"/>
+                <a16:creationId xmlns:a16="http://schemas.microsoft.com/office/drawing/2014/main" id="{00EA8BA1-DDB4-4237-8DA5-DABD057DAD0D}"/>
               </a:ext>
             </a:extLst>
           </p:cNvPr>
@@ -6220,8 +6220,8 @@
         </p:nvSpPr>
         <p:spPr>
           <a:xfrm xmlns:a="http://schemas.openxmlformats.org/drawingml/2006/main">
-            <a:off x="619125" y="3314700"/>
-            <a:ext cx="10096500" cy="552450"/>
+            <a:off x="619125" y="3286125"/>
+            <a:ext cx="10572750" cy="628650"/>
           </a:xfrm>
           <a:prstGeom xmlns:a="http://schemas.openxmlformats.org/drawingml/2006/main" prst="rect">
             <a:avLst/>
@@ -6236,9 +6236,9 @@
           <a:bodyPr xmlns:a="http://schemas.openxmlformats.org/drawingml/2006/main"/>
           <a:lstStyle xmlns:a="http://schemas.openxmlformats.org/drawingml/2006/main">
             <a:defPPr>
-              <a:defRPr sz="2175" b="0">
-                <a:solidFill>
-                  <a:srgbClr val="F4F6FA"/>
+              <a:defRPr sz="2025" b="1">
+                <a:solidFill>
+                  <a:srgbClr val="6DE0D5"/>
                 </a:solidFill>
                 <a:latin typeface="DejaVu Sans"/>
                 <a:ea typeface="DejaVu Sans"/>
@@ -6246,9 +6246,9 @@
               </a:defRPr>
             </a:defPPr>
             <a:lvl1pPr>
-              <a:defRPr sz="2175" b="0">
-                <a:solidFill>
-                  <a:srgbClr val="F4F6FA"/>
+              <a:defRPr sz="2025" b="1">
+                <a:solidFill>
+                  <a:srgbClr val="6DE0D5"/>
                 </a:solidFill>
                 <a:latin typeface="DejaVu Sans"/>
                 <a:ea typeface="DejaVu Sans"/>
@@ -6256,9 +6256,9 @@
               </a:defRPr>
             </a:lvl1pPr>
             <a:lvl2pPr>
-              <a:defRPr sz="2175" b="0">
-                <a:solidFill>
-                  <a:srgbClr val="F4F6FA"/>
+              <a:defRPr sz="2025" b="1">
+                <a:solidFill>
+                  <a:srgbClr val="6DE0D5"/>
                 </a:solidFill>
                 <a:latin typeface="DejaVu Sans"/>
                 <a:ea typeface="DejaVu Sans"/>
@@ -6266,9 +6266,9 @@
               </a:defRPr>
             </a:lvl2pPr>
             <a:lvl3pPr>
-              <a:defRPr sz="2175" b="0">
-                <a:solidFill>
-                  <a:srgbClr val="F4F6FA"/>
+              <a:defRPr sz="2025" b="1">
+                <a:solidFill>
+                  <a:srgbClr val="6DE0D5"/>
                 </a:solidFill>
                 <a:latin typeface="DejaVu Sans"/>
                 <a:ea typeface="DejaVu Sans"/>
@@ -6276,9 +6276,9 @@
               </a:defRPr>
             </a:lvl3pPr>
             <a:lvl4pPr>
-              <a:defRPr sz="2175" b="0">
-                <a:solidFill>
-                  <a:srgbClr val="F4F6FA"/>
+              <a:defRPr sz="2025" b="1">
+                <a:solidFill>
+                  <a:srgbClr val="6DE0D5"/>
                 </a:solidFill>
                 <a:latin typeface="DejaVu Sans"/>
                 <a:ea typeface="DejaVu Sans"/>
@@ -6286,9 +6286,9 @@
               </a:defRPr>
             </a:lvl4pPr>
             <a:lvl5pPr>
-              <a:defRPr sz="2175" b="0">
-                <a:solidFill>
-                  <a:srgbClr val="F4F6FA"/>
+              <a:defRPr sz="2025" b="1">
+                <a:solidFill>
+                  <a:srgbClr val="6DE0D5"/>
                 </a:solidFill>
                 <a:latin typeface="DejaVu Sans"/>
                 <a:ea typeface="DejaVu Sans"/>
@@ -6296,9 +6296,9 @@
               </a:defRPr>
             </a:lvl5pPr>
             <a:lvl6pPr>
-              <a:defRPr sz="2175" b="0">
-                <a:solidFill>
-                  <a:srgbClr val="F4F6FA"/>
+              <a:defRPr sz="2025" b="1">
+                <a:solidFill>
+                  <a:srgbClr val="6DE0D5"/>
                 </a:solidFill>
                 <a:latin typeface="DejaVu Sans"/>
                 <a:ea typeface="DejaVu Sans"/>
@@ -6306,9 +6306,9 @@
               </a:defRPr>
             </a:lvl6pPr>
             <a:lvl7pPr>
-              <a:defRPr sz="2175" b="0">
-                <a:solidFill>
-                  <a:srgbClr val="F4F6FA"/>
+              <a:defRPr sz="2025" b="1">
+                <a:solidFill>
+                  <a:srgbClr val="6DE0D5"/>
                 </a:solidFill>
                 <a:latin typeface="DejaVu Sans"/>
                 <a:ea typeface="DejaVu Sans"/>
@@ -6316,9 +6316,9 @@
               </a:defRPr>
             </a:lvl7pPr>
             <a:lvl8pPr>
-              <a:defRPr sz="2175" b="0">
-                <a:solidFill>
-                  <a:srgbClr val="F4F6FA"/>
+              <a:defRPr sz="2025" b="1">
+                <a:solidFill>
+                  <a:srgbClr val="6DE0D5"/>
                 </a:solidFill>
                 <a:latin typeface="DejaVu Sans"/>
                 <a:ea typeface="DejaVu Sans"/>
@@ -6326,9 +6326,9 @@
               </a:defRPr>
             </a:lvl8pPr>
             <a:lvl9pPr>
-              <a:defRPr sz="2175" b="0">
-                <a:solidFill>
-                  <a:srgbClr val="F4F6FA"/>
+              <a:defRPr sz="2025" b="1">
+                <a:solidFill>
+                  <a:srgbClr val="6DE0D5"/>
                 </a:solidFill>
                 <a:latin typeface="DejaVu Sans"/>
                 <a:ea typeface="DejaVu Sans"/>
@@ -6338,9 +6338,9 @@
           </a:lstStyle>
           <a:p xmlns:a="http://schemas.openxmlformats.org/drawingml/2006/main">
             <a:pPr>
-              <a:defRPr sz="2175" b="0">
-                <a:solidFill>
-                  <a:srgbClr val="F4F6FA"/>
+              <a:defRPr sz="2025" b="1">
+                <a:solidFill>
+                  <a:srgbClr val="6DE0D5"/>
                 </a:solidFill>
                 <a:latin typeface="DejaVu Sans"/>
                 <a:ea typeface="DejaVu Sans"/>
@@ -6348,15 +6348,15 @@
               </a:defRPr>
             </a:pPr>
             <a:r>
-              <a:rPr sz="2175" b="0">
-                <a:solidFill>
-                  <a:srgbClr val="F4F6FA"/>
+              <a:rPr sz="2025" b="1">
+                <a:solidFill>
+                  <a:srgbClr val="6DE0D5"/>
                 </a:solidFill>
                 <a:latin typeface="DejaVu Sans"/>
                 <a:ea typeface="DejaVu Sans"/>
                 <a:cs typeface="DejaVu Sans"/>
               </a:rPr>
-              <a:t>Tink protection and Android Keystore identity</a:t>
+              <a:t>Signed area alerts and admin SOS direction</a:t>
             </a:r>
           </a:p>
         </p:txBody>
@@ -6366,7 +6366,7 @@
           <p:cNvPr id="6" name="">
             <a:extLst xmlns:a="http://schemas.openxmlformats.org/drawingml/2006/main">
               <a:ext uri="{FF2B5EF4-FFF2-40B4-BE49-F238E27FC236}">
-                <a16:creationId xmlns:a16="http://schemas.microsoft.com/office/drawing/2014/main" id="{2145D009-2CB2-4946-8AF4-3F98BB109454}"/>
+                <a16:creationId xmlns:a16="http://schemas.microsoft.com/office/drawing/2014/main" id="{02133CE0-FDA2-4C66-82B6-BC2099AC18B2}"/>
               </a:ext>
             </a:extLst>
           </p:cNvPr>
@@ -6377,8 +6377,8 @@
         </p:nvSpPr>
         <p:spPr>
           <a:xfrm xmlns:a="http://schemas.openxmlformats.org/drawingml/2006/main">
-            <a:off x="619125" y="4286250"/>
-            <a:ext cx="10382250" cy="1428750"/>
+            <a:off x="619125" y="4095750"/>
+            <a:ext cx="10572750" cy="628650"/>
           </a:xfrm>
           <a:prstGeom xmlns:a="http://schemas.openxmlformats.org/drawingml/2006/main" prst="rect">
             <a:avLst/>
@@ -6393,9 +6393,9 @@
           <a:bodyPr xmlns:a="http://schemas.openxmlformats.org/drawingml/2006/main"/>
           <a:lstStyle xmlns:a="http://schemas.openxmlformats.org/drawingml/2006/main">
             <a:defPPr>
-              <a:defRPr sz="1875" b="0">
-                <a:solidFill>
-                  <a:srgbClr val="6DE0D5"/>
+              <a:defRPr sz="2025" b="0">
+                <a:solidFill>
+                  <a:srgbClr val="F4F6FA"/>
                 </a:solidFill>
                 <a:latin typeface="DejaVu Sans"/>
                 <a:ea typeface="DejaVu Sans"/>
@@ -6403,9 +6403,9 @@
               </a:defRPr>
             </a:defPPr>
             <a:lvl1pPr>
-              <a:defRPr sz="1875" b="0">
-                <a:solidFill>
-                  <a:srgbClr val="6DE0D5"/>
+              <a:defRPr sz="2025" b="0">
+                <a:solidFill>
+                  <a:srgbClr val="F4F6FA"/>
                 </a:solidFill>
                 <a:latin typeface="DejaVu Sans"/>
                 <a:ea typeface="DejaVu Sans"/>
@@ -6413,9 +6413,9 @@
               </a:defRPr>
             </a:lvl1pPr>
             <a:lvl2pPr>
-              <a:defRPr sz="1875" b="0">
-                <a:solidFill>
-                  <a:srgbClr val="6DE0D5"/>
+              <a:defRPr sz="2025" b="0">
+                <a:solidFill>
+                  <a:srgbClr val="F4F6FA"/>
                 </a:solidFill>
                 <a:latin typeface="DejaVu Sans"/>
                 <a:ea typeface="DejaVu Sans"/>
@@ -6423,9 +6423,9 @@
               </a:defRPr>
             </a:lvl2pPr>
             <a:lvl3pPr>
-              <a:defRPr sz="1875" b="0">
-                <a:solidFill>
-                  <a:srgbClr val="6DE0D5"/>
+              <a:defRPr sz="2025" b="0">
+                <a:solidFill>
+                  <a:srgbClr val="F4F6FA"/>
                 </a:solidFill>
                 <a:latin typeface="DejaVu Sans"/>
                 <a:ea typeface="DejaVu Sans"/>
@@ -6433,9 +6433,9 @@
               </a:defRPr>
             </a:lvl3pPr>
             <a:lvl4pPr>
-              <a:defRPr sz="1875" b="0">
-                <a:solidFill>
-                  <a:srgbClr val="6DE0D5"/>
+              <a:defRPr sz="2025" b="0">
+                <a:solidFill>
+                  <a:srgbClr val="F4F6FA"/>
                 </a:solidFill>
                 <a:latin typeface="DejaVu Sans"/>
                 <a:ea typeface="DejaVu Sans"/>
@@ -6443,9 +6443,9 @@
               </a:defRPr>
             </a:lvl4pPr>
             <a:lvl5pPr>
-              <a:defRPr sz="1875" b="0">
-                <a:solidFill>
-                  <a:srgbClr val="6DE0D5"/>
+              <a:defRPr sz="2025" b="0">
+                <a:solidFill>
+                  <a:srgbClr val="F4F6FA"/>
                 </a:solidFill>
                 <a:latin typeface="DejaVu Sans"/>
                 <a:ea typeface="DejaVu Sans"/>
@@ -6453,9 +6453,9 @@
               </a:defRPr>
             </a:lvl5pPr>
             <a:lvl6pPr>
-              <a:defRPr sz="1875" b="0">
-                <a:solidFill>
-                  <a:srgbClr val="6DE0D5"/>
+              <a:defRPr sz="2025" b="0">
+                <a:solidFill>
+                  <a:srgbClr val="F4F6FA"/>
                 </a:solidFill>
                 <a:latin typeface="DejaVu Sans"/>
                 <a:ea typeface="DejaVu Sans"/>
@@ -6463,9 +6463,9 @@
               </a:defRPr>
             </a:lvl6pPr>
             <a:lvl7pPr>
-              <a:defRPr sz="1875" b="0">
-                <a:solidFill>
-                  <a:srgbClr val="6DE0D5"/>
+              <a:defRPr sz="2025" b="0">
+                <a:solidFill>
+                  <a:srgbClr val="F4F6FA"/>
                 </a:solidFill>
                 <a:latin typeface="DejaVu Sans"/>
                 <a:ea typeface="DejaVu Sans"/>
@@ -6473,9 +6473,9 @@
               </a:defRPr>
             </a:lvl7pPr>
             <a:lvl8pPr>
-              <a:defRPr sz="1875" b="0">
-                <a:solidFill>
-                  <a:srgbClr val="6DE0D5"/>
+              <a:defRPr sz="2025" b="0">
+                <a:solidFill>
+                  <a:srgbClr val="F4F6FA"/>
                 </a:solidFill>
                 <a:latin typeface="DejaVu Sans"/>
                 <a:ea typeface="DejaVu Sans"/>
@@ -6483,9 +6483,9 @@
               </a:defRPr>
             </a:lvl8pPr>
             <a:lvl9pPr>
-              <a:defRPr sz="1875" b="0">
-                <a:solidFill>
-                  <a:srgbClr val="6DE0D5"/>
+              <a:defRPr sz="2025" b="0">
+                <a:solidFill>
+                  <a:srgbClr val="F4F6FA"/>
                 </a:solidFill>
                 <a:latin typeface="DejaVu Sans"/>
                 <a:ea typeface="DejaVu Sans"/>
@@ -6495,9 +6495,9 @@
           </a:lstStyle>
           <a:p xmlns:a="http://schemas.openxmlformats.org/drawingml/2006/main">
             <a:pPr>
-              <a:defRPr sz="1875" b="0">
-                <a:solidFill>
-                  <a:srgbClr val="6DE0D5"/>
+              <a:defRPr sz="2025" b="0">
+                <a:solidFill>
+                  <a:srgbClr val="F4F6FA"/>
                 </a:solidFill>
                 <a:latin typeface="DejaVu Sans"/>
                 <a:ea typeface="DejaVu Sans"/>
@@ -6505,15 +6505,172 @@
               </a:defRPr>
             </a:pPr>
             <a:r>
-              <a:rPr sz="1875" b="0">
-                <a:solidFill>
-                  <a:srgbClr val="6DE0D5"/>
+              <a:rPr sz="2025" b="0">
+                <a:solidFill>
+                  <a:srgbClr val="F4F6FA"/>
                 </a:solidFill>
                 <a:latin typeface="DejaVu Sans"/>
                 <a:ea typeface="DejaVu Sans"/>
                 <a:cs typeface="DejaVu Sans"/>
               </a:rPr>
-              <a:t>Tested extras: Call-Out, Talk-Back, Last Breath, Bluetooth-name SOS, laptop relay and dashboard</a:t>
+              <a:t>Fewest-hop direct routes, with an eight-second fallback</a:t>
+            </a:r>
+          </a:p>
+        </p:txBody>
+      </p:sp>
+      <p:sp>
+        <p:nvSpPr>
+          <p:cNvPr id="7" name="">
+            <a:extLst xmlns:a="http://schemas.openxmlformats.org/drawingml/2006/main">
+              <a:ext uri="{FF2B5EF4-FFF2-40B4-BE49-F238E27FC236}">
+                <a16:creationId xmlns:a16="http://schemas.microsoft.com/office/drawing/2014/main" id="{B1E3612E-B896-43E7-8CEE-C539444E7766}"/>
+              </a:ext>
+            </a:extLst>
+          </p:cNvPr>
+          <p:cNvSpPr>
+            <a:spLocks xmlns:a="http://schemas.openxmlformats.org/drawingml/2006/main" noGrp="1"/>
+          </p:cNvSpPr>
+          <p:nvPr/>
+        </p:nvSpPr>
+        <p:spPr>
+          <a:xfrm xmlns:a="http://schemas.openxmlformats.org/drawingml/2006/main">
+            <a:off x="619125" y="5095875"/>
+            <a:ext cx="10572750" cy="857250"/>
+          </a:xfrm>
+          <a:prstGeom xmlns:a="http://schemas.openxmlformats.org/drawingml/2006/main" prst="rect">
+            <a:avLst/>
+          </a:prstGeom>
+          <a:noFill xmlns:a="http://schemas.openxmlformats.org/drawingml/2006/main"/>
+          <a:ln xmlns:a="http://schemas.openxmlformats.org/drawingml/2006/main" w="0">
+            <a:noFill/>
+            <a:prstDash val="solid"/>
+          </a:ln>
+        </p:spPr>
+        <p:txBody>
+          <a:bodyPr xmlns:a="http://schemas.openxmlformats.org/drawingml/2006/main"/>
+          <a:lstStyle xmlns:a="http://schemas.openxmlformats.org/drawingml/2006/main">
+            <a:defPPr>
+              <a:defRPr sz="1650" b="0">
+                <a:solidFill>
+                  <a:srgbClr val="B6C0D1"/>
+                </a:solidFill>
+                <a:latin typeface="DejaVu Sans"/>
+                <a:ea typeface="DejaVu Sans"/>
+                <a:cs typeface="DejaVu Sans"/>
+              </a:defRPr>
+            </a:defPPr>
+            <a:lvl1pPr>
+              <a:defRPr sz="1650" b="0">
+                <a:solidFill>
+                  <a:srgbClr val="B6C0D1"/>
+                </a:solidFill>
+                <a:latin typeface="DejaVu Sans"/>
+                <a:ea typeface="DejaVu Sans"/>
+                <a:cs typeface="DejaVu Sans"/>
+              </a:defRPr>
+            </a:lvl1pPr>
+            <a:lvl2pPr>
+              <a:defRPr sz="1650" b="0">
+                <a:solidFill>
+                  <a:srgbClr val="B6C0D1"/>
+                </a:solidFill>
+                <a:latin typeface="DejaVu Sans"/>
+                <a:ea typeface="DejaVu Sans"/>
+                <a:cs typeface="DejaVu Sans"/>
+              </a:defRPr>
+            </a:lvl2pPr>
+            <a:lvl3pPr>
+              <a:defRPr sz="1650" b="0">
+                <a:solidFill>
+                  <a:srgbClr val="B6C0D1"/>
+                </a:solidFill>
+                <a:latin typeface="DejaVu Sans"/>
+                <a:ea typeface="DejaVu Sans"/>
+                <a:cs typeface="DejaVu Sans"/>
+              </a:defRPr>
+            </a:lvl3pPr>
+            <a:lvl4pPr>
+              <a:defRPr sz="1650" b="0">
+                <a:solidFill>
+                  <a:srgbClr val="B6C0D1"/>
+                </a:solidFill>
+                <a:latin typeface="DejaVu Sans"/>
+                <a:ea typeface="DejaVu Sans"/>
+                <a:cs typeface="DejaVu Sans"/>
+              </a:defRPr>
+            </a:lvl4pPr>
+            <a:lvl5pPr>
+              <a:defRPr sz="1650" b="0">
+                <a:solidFill>
+                  <a:srgbClr val="B6C0D1"/>
+                </a:solidFill>
+                <a:latin typeface="DejaVu Sans"/>
+                <a:ea typeface="DejaVu Sans"/>
+                <a:cs typeface="DejaVu Sans"/>
+              </a:defRPr>
+            </a:lvl5pPr>
+            <a:lvl6pPr>
+              <a:defRPr sz="1650" b="0">
+                <a:solidFill>
+                  <a:srgbClr val="B6C0D1"/>
+                </a:solidFill>
+                <a:latin typeface="DejaVu Sans"/>
+                <a:ea typeface="DejaVu Sans"/>
+                <a:cs typeface="DejaVu Sans"/>
+              </a:defRPr>
+            </a:lvl6pPr>
+            <a:lvl7pPr>
+              <a:defRPr sz="1650" b="0">
+                <a:solidFill>
+                  <a:srgbClr val="B6C0D1"/>
+                </a:solidFill>
+                <a:latin typeface="DejaVu Sans"/>
+                <a:ea typeface="DejaVu Sans"/>
+                <a:cs typeface="DejaVu Sans"/>
+              </a:defRPr>
+            </a:lvl7pPr>
+            <a:lvl8pPr>
+              <a:defRPr sz="1650" b="0">
+                <a:solidFill>
+                  <a:srgbClr val="B6C0D1"/>
+                </a:solidFill>
+                <a:latin typeface="DejaVu Sans"/>
+                <a:ea typeface="DejaVu Sans"/>
+                <a:cs typeface="DejaVu Sans"/>
+              </a:defRPr>
+            </a:lvl8pPr>
+            <a:lvl9pPr>
+              <a:defRPr sz="1650" b="0">
+                <a:solidFill>
+                  <a:srgbClr val="B6C0D1"/>
+                </a:solidFill>
+                <a:latin typeface="DejaVu Sans"/>
+                <a:ea typeface="DejaVu Sans"/>
+                <a:cs typeface="DejaVu Sans"/>
+              </a:defRPr>
+            </a:lvl9pPr>
+          </a:lstStyle>
+          <a:p xmlns:a="http://schemas.openxmlformats.org/drawingml/2006/main">
+            <a:pPr>
+              <a:defRPr sz="1650" b="0">
+                <a:solidFill>
+                  <a:srgbClr val="B6C0D1"/>
+                </a:solidFill>
+                <a:latin typeface="DejaVu Sans"/>
+                <a:ea typeface="DejaVu Sans"/>
+                <a:cs typeface="DejaVu Sans"/>
+              </a:defRPr>
+            </a:pPr>
+            <a:r>
+              <a:rPr sz="1650" b="0">
+                <a:solidFill>
+                  <a:srgbClr val="B6C0D1"/>
+                </a:solidFill>
+                <a:latin typeface="DejaVu Sans"/>
+                <a:ea typeface="DejaVu Sans"/>
+                <a:cs typeface="DejaVu Sans"/>
+              </a:rPr>
+              <a:t>Extras: Call-Out, Talk-Back, Last Breath, no-app SOS intake, laptop node and dashboard</a:t>
             </a:r>
           </a:p>
         </p:txBody>
@@ -6521,7 +6678,7 @@
     </p:spTree>
     <p:extLst>
       <p:ext uri="{BB962C8B-B14F-4D97-AF65-F5344CB8AC3E}">
-        <p14:creationId xmlns:p14="http://schemas.microsoft.com/office/powerpoint/2010/main" val="801641057"/>
+        <p14:creationId xmlns:p14="http://schemas.microsoft.com/office/powerpoint/2010/main" val="765760502"/>
       </p:ext>
     </p:extLst>
   </p:cSld>
@@ -6552,7 +6709,7 @@
           <p:cNvPr id="8" name="">
             <a:extLst xmlns:a="http://schemas.openxmlformats.org/drawingml/2006/main">
               <a:ext uri="{FF2B5EF4-FFF2-40B4-BE49-F238E27FC236}">
-                <a16:creationId xmlns:a16="http://schemas.microsoft.com/office/drawing/2014/main" id="{911EF1B5-1F20-4B63-A01A-26735FC0E1B0}"/>
+                <a16:creationId xmlns:a16="http://schemas.microsoft.com/office/drawing/2014/main" id="{0BB3D7AF-F52A-471F-9BE9-747194D04554}"/>
               </a:ext>
             </a:extLst>
           </p:cNvPr>
@@ -6709,7 +6866,7 @@
           <p:cNvPr id="2" name="">
             <a:extLst xmlns:a="http://schemas.openxmlformats.org/drawingml/2006/main">
               <a:ext uri="{FF2B5EF4-FFF2-40B4-BE49-F238E27FC236}">
-                <a16:creationId xmlns:a16="http://schemas.microsoft.com/office/drawing/2014/main" id="{373A23F7-49AC-4C51-BF53-31C83FC2DC35}"/>
+                <a16:creationId xmlns:a16="http://schemas.microsoft.com/office/drawing/2014/main" id="{E4EA3997-8B05-477A-848F-AB555A26FB88}"/>
               </a:ext>
             </a:extLst>
           </p:cNvPr>
@@ -6866,7 +7023,7 @@
           <p:cNvPr id="3" name="">
             <a:extLst xmlns:a="http://schemas.openxmlformats.org/drawingml/2006/main">
               <a:ext uri="{FF2B5EF4-FFF2-40B4-BE49-F238E27FC236}">
-                <a16:creationId xmlns:a16="http://schemas.microsoft.com/office/drawing/2014/main" id="{AB9C2836-19E9-4B26-82BC-F276254C1687}"/>
+                <a16:creationId xmlns:a16="http://schemas.microsoft.com/office/drawing/2014/main" id="{61E9807C-AA88-45D1-A6AD-591D235DC8E2}"/>
               </a:ext>
             </a:extLst>
           </p:cNvPr>
@@ -6877,8 +7034,8 @@
         </p:nvSpPr>
         <p:spPr>
           <a:xfrm xmlns:a="http://schemas.openxmlformats.org/drawingml/2006/main">
-            <a:off x="619125" y="1790700"/>
-            <a:ext cx="4191000" cy="400050"/>
+            <a:off x="619125" y="1666875"/>
+            <a:ext cx="10572750" cy="952500"/>
           </a:xfrm>
           <a:prstGeom xmlns:a="http://schemas.openxmlformats.org/drawingml/2006/main" prst="rect">
             <a:avLst/>
@@ -6893,7 +7050,7 @@
           <a:bodyPr xmlns:a="http://schemas.openxmlformats.org/drawingml/2006/main"/>
           <a:lstStyle xmlns:a="http://schemas.openxmlformats.org/drawingml/2006/main">
             <a:defPPr>
-              <a:defRPr sz="2100" b="1">
+              <a:defRPr sz="1875" b="1">
                 <a:solidFill>
                   <a:srgbClr val="6DE0D5"/>
                 </a:solidFill>
@@ -6903,7 +7060,7 @@
               </a:defRPr>
             </a:defPPr>
             <a:lvl1pPr>
-              <a:defRPr sz="2100" b="1">
+              <a:defRPr sz="1875" b="1">
                 <a:solidFill>
                   <a:srgbClr val="6DE0D5"/>
                 </a:solidFill>
@@ -6913,7 +7070,7 @@
               </a:defRPr>
             </a:lvl1pPr>
             <a:lvl2pPr>
-              <a:defRPr sz="2100" b="1">
+              <a:defRPr sz="1875" b="1">
                 <a:solidFill>
                   <a:srgbClr val="6DE0D5"/>
                 </a:solidFill>
@@ -6923,7 +7080,7 @@
               </a:defRPr>
             </a:lvl2pPr>
             <a:lvl3pPr>
-              <a:defRPr sz="2100" b="1">
+              <a:defRPr sz="1875" b="1">
                 <a:solidFill>
                   <a:srgbClr val="6DE0D5"/>
                 </a:solidFill>
@@ -6933,7 +7090,7 @@
               </a:defRPr>
             </a:lvl3pPr>
             <a:lvl4pPr>
-              <a:defRPr sz="2100" b="1">
+              <a:defRPr sz="1875" b="1">
                 <a:solidFill>
                   <a:srgbClr val="6DE0D5"/>
                 </a:solidFill>
@@ -6943,7 +7100,7 @@
               </a:defRPr>
             </a:lvl4pPr>
             <a:lvl5pPr>
-              <a:defRPr sz="2100" b="1">
+              <a:defRPr sz="1875" b="1">
                 <a:solidFill>
                   <a:srgbClr val="6DE0D5"/>
                 </a:solidFill>
@@ -6953,7 +7110,7 @@
               </a:defRPr>
             </a:lvl5pPr>
             <a:lvl6pPr>
-              <a:defRPr sz="2100" b="1">
+              <a:defRPr sz="1875" b="1">
                 <a:solidFill>
                   <a:srgbClr val="6DE0D5"/>
                 </a:solidFill>
@@ -6963,7 +7120,7 @@
               </a:defRPr>
             </a:lvl6pPr>
             <a:lvl7pPr>
-              <a:defRPr sz="2100" b="1">
+              <a:defRPr sz="1875" b="1">
                 <a:solidFill>
                   <a:srgbClr val="6DE0D5"/>
                 </a:solidFill>
@@ -6973,7 +7130,7 @@
               </a:defRPr>
             </a:lvl7pPr>
             <a:lvl8pPr>
-              <a:defRPr sz="2100" b="1">
+              <a:defRPr sz="1875" b="1">
                 <a:solidFill>
                   <a:srgbClr val="6DE0D5"/>
                 </a:solidFill>
@@ -6983,7 +7140,7 @@
               </a:defRPr>
             </a:lvl8pPr>
             <a:lvl9pPr>
-              <a:defRPr sz="2100" b="1">
+              <a:defRPr sz="1875" b="1">
                 <a:solidFill>
                   <a:srgbClr val="6DE0D5"/>
                 </a:solidFill>
@@ -6995,7 +7152,7 @@
           </a:lstStyle>
           <a:p xmlns:a="http://schemas.openxmlformats.org/drawingml/2006/main">
             <a:pPr>
-              <a:defRPr sz="2100" b="1">
+              <a:defRPr sz="1875" b="1">
                 <a:solidFill>
                   <a:srgbClr val="6DE0D5"/>
                 </a:solidFill>
@@ -7005,7 +7162,7 @@
               </a:defRPr>
             </a:pPr>
             <a:r>
-              <a:rPr sz="2100" b="1">
+              <a:rPr sz="1875" b="1">
                 <a:solidFill>
                   <a:srgbClr val="6DE0D5"/>
                 </a:solidFill>
@@ -7013,7 +7170,7 @@
                 <a:ea typeface="DejaVu Sans"/>
                 <a:cs typeface="DejaVu Sans"/>
               </a:rPr>
-              <a:t>vivo V2404</a:t>
+              <a:t>Area alert crossed an outside relay and reached the inside phone in 3.0 s.</a:t>
             </a:r>
           </a:p>
         </p:txBody>
@@ -7023,7 +7180,7 @@
           <p:cNvPr id="4" name="">
             <a:extLst xmlns:a="http://schemas.openxmlformats.org/drawingml/2006/main">
               <a:ext uri="{FF2B5EF4-FFF2-40B4-BE49-F238E27FC236}">
-                <a16:creationId xmlns:a16="http://schemas.microsoft.com/office/drawing/2014/main" id="{7D52E33E-12E2-451F-BECE-CCB199AD90B2}"/>
+                <a16:creationId xmlns:a16="http://schemas.microsoft.com/office/drawing/2014/main" id="{677136DD-2CF5-4EF0-A85C-EDE81B8450B8}"/>
               </a:ext>
             </a:extLst>
           </p:cNvPr>
@@ -7034,8 +7191,8 @@
         </p:nvSpPr>
         <p:spPr>
           <a:xfrm xmlns:a="http://schemas.openxmlformats.org/drawingml/2006/main">
-            <a:off x="619125" y="2533650"/>
-            <a:ext cx="4953000" cy="400050"/>
+            <a:off x="619125" y="2733675"/>
+            <a:ext cx="10572750" cy="647700"/>
           </a:xfrm>
           <a:prstGeom xmlns:a="http://schemas.openxmlformats.org/drawingml/2006/main" prst="rect">
             <a:avLst/>
@@ -7050,9 +7207,9 @@
           <a:bodyPr xmlns:a="http://schemas.openxmlformats.org/drawingml/2006/main"/>
           <a:lstStyle xmlns:a="http://schemas.openxmlformats.org/drawingml/2006/main">
             <a:defPPr>
-              <a:defRPr sz="2100" b="1">
-                <a:solidFill>
-                  <a:srgbClr val="6DE0D5"/>
+              <a:defRPr sz="1875" b="0">
+                <a:solidFill>
+                  <a:srgbClr val="F4F6FA"/>
                 </a:solidFill>
                 <a:latin typeface="DejaVu Sans"/>
                 <a:ea typeface="DejaVu Sans"/>
@@ -7060,9 +7217,9 @@
               </a:defRPr>
             </a:defPPr>
             <a:lvl1pPr>
-              <a:defRPr sz="2100" b="1">
-                <a:solidFill>
-                  <a:srgbClr val="6DE0D5"/>
+              <a:defRPr sz="1875" b="0">
+                <a:solidFill>
+                  <a:srgbClr val="F4F6FA"/>
                 </a:solidFill>
                 <a:latin typeface="DejaVu Sans"/>
                 <a:ea typeface="DejaVu Sans"/>
@@ -7070,9 +7227,9 @@
               </a:defRPr>
             </a:lvl1pPr>
             <a:lvl2pPr>
-              <a:defRPr sz="2100" b="1">
-                <a:solidFill>
-                  <a:srgbClr val="6DE0D5"/>
+              <a:defRPr sz="1875" b="0">
+                <a:solidFill>
+                  <a:srgbClr val="F4F6FA"/>
                 </a:solidFill>
                 <a:latin typeface="DejaVu Sans"/>
                 <a:ea typeface="DejaVu Sans"/>
@@ -7080,9 +7237,9 @@
               </a:defRPr>
             </a:lvl2pPr>
             <a:lvl3pPr>
-              <a:defRPr sz="2100" b="1">
-                <a:solidFill>
-                  <a:srgbClr val="6DE0D5"/>
+              <a:defRPr sz="1875" b="0">
+                <a:solidFill>
+                  <a:srgbClr val="F4F6FA"/>
                 </a:solidFill>
                 <a:latin typeface="DejaVu Sans"/>
                 <a:ea typeface="DejaVu Sans"/>
@@ -7090,9 +7247,9 @@
               </a:defRPr>
             </a:lvl3pPr>
             <a:lvl4pPr>
-              <a:defRPr sz="2100" b="1">
-                <a:solidFill>
-                  <a:srgbClr val="6DE0D5"/>
+              <a:defRPr sz="1875" b="0">
+                <a:solidFill>
+                  <a:srgbClr val="F4F6FA"/>
                 </a:solidFill>
                 <a:latin typeface="DejaVu Sans"/>
                 <a:ea typeface="DejaVu Sans"/>
@@ -7100,9 +7257,9 @@
               </a:defRPr>
             </a:lvl4pPr>
             <a:lvl5pPr>
-              <a:defRPr sz="2100" b="1">
-                <a:solidFill>
-                  <a:srgbClr val="6DE0D5"/>
+              <a:defRPr sz="1875" b="0">
+                <a:solidFill>
+                  <a:srgbClr val="F4F6FA"/>
                 </a:solidFill>
                 <a:latin typeface="DejaVu Sans"/>
                 <a:ea typeface="DejaVu Sans"/>
@@ -7110,9 +7267,9 @@
               </a:defRPr>
             </a:lvl5pPr>
             <a:lvl6pPr>
-              <a:defRPr sz="2100" b="1">
-                <a:solidFill>
-                  <a:srgbClr val="6DE0D5"/>
+              <a:defRPr sz="1875" b="0">
+                <a:solidFill>
+                  <a:srgbClr val="F4F6FA"/>
                 </a:solidFill>
                 <a:latin typeface="DejaVu Sans"/>
                 <a:ea typeface="DejaVu Sans"/>
@@ -7120,9 +7277,9 @@
               </a:defRPr>
             </a:lvl6pPr>
             <a:lvl7pPr>
-              <a:defRPr sz="2100" b="1">
-                <a:solidFill>
-                  <a:srgbClr val="6DE0D5"/>
+              <a:defRPr sz="1875" b="0">
+                <a:solidFill>
+                  <a:srgbClr val="F4F6FA"/>
                 </a:solidFill>
                 <a:latin typeface="DejaVu Sans"/>
                 <a:ea typeface="DejaVu Sans"/>
@@ -7130,9 +7287,9 @@
               </a:defRPr>
             </a:lvl7pPr>
             <a:lvl8pPr>
-              <a:defRPr sz="2100" b="1">
-                <a:solidFill>
-                  <a:srgbClr val="6DE0D5"/>
+              <a:defRPr sz="1875" b="0">
+                <a:solidFill>
+                  <a:srgbClr val="F4F6FA"/>
                 </a:solidFill>
                 <a:latin typeface="DejaVu Sans"/>
                 <a:ea typeface="DejaVu Sans"/>
@@ -7140,9 +7297,9 @@
               </a:defRPr>
             </a:lvl8pPr>
             <a:lvl9pPr>
-              <a:defRPr sz="2100" b="1">
-                <a:solidFill>
-                  <a:srgbClr val="6DE0D5"/>
+              <a:defRPr sz="1875" b="0">
+                <a:solidFill>
+                  <a:srgbClr val="F4F6FA"/>
                 </a:solidFill>
                 <a:latin typeface="DejaVu Sans"/>
                 <a:ea typeface="DejaVu Sans"/>
@@ -7152,9 +7309,9 @@
           </a:lstStyle>
           <a:p xmlns:a="http://schemas.openxmlformats.org/drawingml/2006/main">
             <a:pPr>
-              <a:defRPr sz="2100" b="1">
-                <a:solidFill>
-                  <a:srgbClr val="6DE0D5"/>
+              <a:defRPr sz="1875" b="0">
+                <a:solidFill>
+                  <a:srgbClr val="F4F6FA"/>
                 </a:solidFill>
                 <a:latin typeface="DejaVu Sans"/>
                 <a:ea typeface="DejaVu Sans"/>
@@ -7162,15 +7319,15 @@
               </a:defRPr>
             </a:pPr>
             <a:r>
-              <a:rPr sz="2100" b="1">
-                <a:solidFill>
-                  <a:srgbClr val="6DE0D5"/>
+              <a:rPr sz="1875" b="0">
+                <a:solidFill>
+                  <a:srgbClr val="F4F6FA"/>
                 </a:solidFill>
                 <a:latin typeface="DejaVu Sans"/>
                 <a:ea typeface="DejaVu Sans"/>
                 <a:cs typeface="DejaVu Sans"/>
               </a:rPr>
-              <a:t>Samsung SM-S721B</a:t>
+              <a:t>Locked Samsung inside the area was notified in 2.1 s.</a:t>
             </a:r>
           </a:p>
         </p:txBody>
@@ -7180,7 +7337,7 @@
           <p:cNvPr id="5" name="">
             <a:extLst xmlns:a="http://schemas.openxmlformats.org/drawingml/2006/main">
               <a:ext uri="{FF2B5EF4-FFF2-40B4-BE49-F238E27FC236}">
-                <a16:creationId xmlns:a16="http://schemas.microsoft.com/office/drawing/2014/main" id="{8D09C120-96EA-4B0D-B4B5-15B7591A7AB5}"/>
+                <a16:creationId xmlns:a16="http://schemas.microsoft.com/office/drawing/2014/main" id="{294EC604-DFA4-48F5-9B54-769147EC5DB4}"/>
               </a:ext>
             </a:extLst>
           </p:cNvPr>
@@ -7191,8 +7348,8 @@
         </p:nvSpPr>
         <p:spPr>
           <a:xfrm xmlns:a="http://schemas.openxmlformats.org/drawingml/2006/main">
-            <a:off x="619125" y="3276600"/>
-            <a:ext cx="4953000" cy="400050"/>
+            <a:off x="619125" y="3571875"/>
+            <a:ext cx="10572750" cy="647700"/>
           </a:xfrm>
           <a:prstGeom xmlns:a="http://schemas.openxmlformats.org/drawingml/2006/main" prst="rect">
             <a:avLst/>
@@ -7207,9 +7364,9 @@
           <a:bodyPr xmlns:a="http://schemas.openxmlformats.org/drawingml/2006/main"/>
           <a:lstStyle xmlns:a="http://schemas.openxmlformats.org/drawingml/2006/main">
             <a:defPPr>
-              <a:defRPr sz="2100" b="1">
-                <a:solidFill>
-                  <a:srgbClr val="6DE0D5"/>
+              <a:defRPr sz="1875" b="0">
+                <a:solidFill>
+                  <a:srgbClr val="F4F6FA"/>
                 </a:solidFill>
                 <a:latin typeface="DejaVu Sans"/>
                 <a:ea typeface="DejaVu Sans"/>
@@ -7217,9 +7374,9 @@
               </a:defRPr>
             </a:defPPr>
             <a:lvl1pPr>
-              <a:defRPr sz="2100" b="1">
-                <a:solidFill>
-                  <a:srgbClr val="6DE0D5"/>
+              <a:defRPr sz="1875" b="0">
+                <a:solidFill>
+                  <a:srgbClr val="F4F6FA"/>
                 </a:solidFill>
                 <a:latin typeface="DejaVu Sans"/>
                 <a:ea typeface="DejaVu Sans"/>
@@ -7227,9 +7384,9 @@
               </a:defRPr>
             </a:lvl1pPr>
             <a:lvl2pPr>
-              <a:defRPr sz="2100" b="1">
-                <a:solidFill>
-                  <a:srgbClr val="6DE0D5"/>
+              <a:defRPr sz="1875" b="0">
+                <a:solidFill>
+                  <a:srgbClr val="F4F6FA"/>
                 </a:solidFill>
                 <a:latin typeface="DejaVu Sans"/>
                 <a:ea typeface="DejaVu Sans"/>
@@ -7237,9 +7394,9 @@
               </a:defRPr>
             </a:lvl2pPr>
             <a:lvl3pPr>
-              <a:defRPr sz="2100" b="1">
-                <a:solidFill>
-                  <a:srgbClr val="6DE0D5"/>
+              <a:defRPr sz="1875" b="0">
+                <a:solidFill>
+                  <a:srgbClr val="F4F6FA"/>
                 </a:solidFill>
                 <a:latin typeface="DejaVu Sans"/>
                 <a:ea typeface="DejaVu Sans"/>
@@ -7247,9 +7404,9 @@
               </a:defRPr>
             </a:lvl3pPr>
             <a:lvl4pPr>
-              <a:defRPr sz="2100" b="1">
-                <a:solidFill>
-                  <a:srgbClr val="6DE0D5"/>
+              <a:defRPr sz="1875" b="0">
+                <a:solidFill>
+                  <a:srgbClr val="F4F6FA"/>
                 </a:solidFill>
                 <a:latin typeface="DejaVu Sans"/>
                 <a:ea typeface="DejaVu Sans"/>
@@ -7257,9 +7414,9 @@
               </a:defRPr>
             </a:lvl4pPr>
             <a:lvl5pPr>
-              <a:defRPr sz="2100" b="1">
-                <a:solidFill>
-                  <a:srgbClr val="6DE0D5"/>
+              <a:defRPr sz="1875" b="0">
+                <a:solidFill>
+                  <a:srgbClr val="F4F6FA"/>
                 </a:solidFill>
                 <a:latin typeface="DejaVu Sans"/>
                 <a:ea typeface="DejaVu Sans"/>
@@ -7267,9 +7424,9 @@
               </a:defRPr>
             </a:lvl5pPr>
             <a:lvl6pPr>
-              <a:defRPr sz="2100" b="1">
-                <a:solidFill>
-                  <a:srgbClr val="6DE0D5"/>
+              <a:defRPr sz="1875" b="0">
+                <a:solidFill>
+                  <a:srgbClr val="F4F6FA"/>
                 </a:solidFill>
                 <a:latin typeface="DejaVu Sans"/>
                 <a:ea typeface="DejaVu Sans"/>
@@ -7277,9 +7434,9 @@
               </a:defRPr>
             </a:lvl6pPr>
             <a:lvl7pPr>
-              <a:defRPr sz="2100" b="1">
-                <a:solidFill>
-                  <a:srgbClr val="6DE0D5"/>
+              <a:defRPr sz="1875" b="0">
+                <a:solidFill>
+                  <a:srgbClr val="F4F6FA"/>
                 </a:solidFill>
                 <a:latin typeface="DejaVu Sans"/>
                 <a:ea typeface="DejaVu Sans"/>
@@ -7287,9 +7444,9 @@
               </a:defRPr>
             </a:lvl7pPr>
             <a:lvl8pPr>
-              <a:defRPr sz="2100" b="1">
-                <a:solidFill>
-                  <a:srgbClr val="6DE0D5"/>
+              <a:defRPr sz="1875" b="0">
+                <a:solidFill>
+                  <a:srgbClr val="F4F6FA"/>
                 </a:solidFill>
                 <a:latin typeface="DejaVu Sans"/>
                 <a:ea typeface="DejaVu Sans"/>
@@ -7297,9 +7454,9 @@
               </a:defRPr>
             </a:lvl8pPr>
             <a:lvl9pPr>
-              <a:defRPr sz="2100" b="1">
-                <a:solidFill>
-                  <a:srgbClr val="6DE0D5"/>
+              <a:defRPr sz="1875" b="0">
+                <a:solidFill>
+                  <a:srgbClr val="F4F6FA"/>
                 </a:solidFill>
                 <a:latin typeface="DejaVu Sans"/>
                 <a:ea typeface="DejaVu Sans"/>
@@ -7309,9 +7466,9 @@
           </a:lstStyle>
           <a:p xmlns:a="http://schemas.openxmlformats.org/drawingml/2006/main">
             <a:pPr>
-              <a:defRPr sz="2100" b="1">
-                <a:solidFill>
-                  <a:srgbClr val="6DE0D5"/>
+              <a:defRPr sz="1875" b="0">
+                <a:solidFill>
+                  <a:srgbClr val="F4F6FA"/>
                 </a:solidFill>
                 <a:latin typeface="DejaVu Sans"/>
                 <a:ea typeface="DejaVu Sans"/>
@@ -7319,15 +7476,15 @@
               </a:defRPr>
             </a:pPr>
             <a:r>
-              <a:rPr sz="2100" b="1">
-                <a:solidFill>
-                  <a:srgbClr val="6DE0D5"/>
+              <a:rPr sz="1875" b="0">
+                <a:solidFill>
+                  <a:srgbClr val="F4F6FA"/>
                 </a:solidFill>
                 <a:latin typeface="DejaVu Sans"/>
                 <a:ea typeface="DejaVu Sans"/>
                 <a:cs typeface="DejaVu Sans"/>
               </a:rPr>
-              <a:t>OnePlus CPH2569</a:t>
+              <a:t>Triangle: B saw neither of two direct messages.</a:t>
             </a:r>
           </a:p>
         </p:txBody>
@@ -7337,7 +7494,7 @@
           <p:cNvPr id="6" name="">
             <a:extLst xmlns:a="http://schemas.openxmlformats.org/drawingml/2006/main">
               <a:ext uri="{FF2B5EF4-FFF2-40B4-BE49-F238E27FC236}">
-                <a16:creationId xmlns:a16="http://schemas.microsoft.com/office/drawing/2014/main" id="{6D6302DD-D167-4CBB-8439-913A7C733DD2}"/>
+                <a16:creationId xmlns:a16="http://schemas.microsoft.com/office/drawing/2014/main" id="{9F3C3A84-A8AF-4891-8661-0DE14F77AF03}"/>
               </a:ext>
             </a:extLst>
           </p:cNvPr>
@@ -7348,8 +7505,8 @@
         </p:nvSpPr>
         <p:spPr>
           <a:xfrm xmlns:a="http://schemas.openxmlformats.org/drawingml/2006/main">
-            <a:off x="619125" y="4476750"/>
-            <a:ext cx="10477500" cy="762000"/>
+            <a:off x="619125" y="4410075"/>
+            <a:ext cx="10572750" cy="647700"/>
           </a:xfrm>
           <a:prstGeom xmlns:a="http://schemas.openxmlformats.org/drawingml/2006/main" prst="rect">
             <a:avLst/>
@@ -7364,7 +7521,7 @@
           <a:bodyPr xmlns:a="http://schemas.openxmlformats.org/drawingml/2006/main"/>
           <a:lstStyle xmlns:a="http://schemas.openxmlformats.org/drawingml/2006/main">
             <a:defPPr>
-              <a:defRPr sz="2025" b="0">
+              <a:defRPr sz="1875" b="0">
                 <a:solidFill>
                   <a:srgbClr val="F4F6FA"/>
                 </a:solidFill>
@@ -7374,7 +7531,7 @@
               </a:defRPr>
             </a:defPPr>
             <a:lvl1pPr>
-              <a:defRPr sz="2025" b="0">
+              <a:defRPr sz="1875" b="0">
                 <a:solidFill>
                   <a:srgbClr val="F4F6FA"/>
                 </a:solidFill>
@@ -7384,7 +7541,7 @@
               </a:defRPr>
             </a:lvl1pPr>
             <a:lvl2pPr>
-              <a:defRPr sz="2025" b="0">
+              <a:defRPr sz="1875" b="0">
                 <a:solidFill>
                   <a:srgbClr val="F4F6FA"/>
                 </a:solidFill>
@@ -7394,7 +7551,7 @@
               </a:defRPr>
             </a:lvl2pPr>
             <a:lvl3pPr>
-              <a:defRPr sz="2025" b="0">
+              <a:defRPr sz="1875" b="0">
                 <a:solidFill>
                   <a:srgbClr val="F4F6FA"/>
                 </a:solidFill>
@@ -7404,7 +7561,7 @@
               </a:defRPr>
             </a:lvl3pPr>
             <a:lvl4pPr>
-              <a:defRPr sz="2025" b="0">
+              <a:defRPr sz="1875" b="0">
                 <a:solidFill>
                   <a:srgbClr val="F4F6FA"/>
                 </a:solidFill>
@@ -7414,7 +7571,7 @@
               </a:defRPr>
             </a:lvl4pPr>
             <a:lvl5pPr>
-              <a:defRPr sz="2025" b="0">
+              <a:defRPr sz="1875" b="0">
                 <a:solidFill>
                   <a:srgbClr val="F4F6FA"/>
                 </a:solidFill>
@@ -7424,7 +7581,7 @@
               </a:defRPr>
             </a:lvl5pPr>
             <a:lvl6pPr>
-              <a:defRPr sz="2025" b="0">
+              <a:defRPr sz="1875" b="0">
                 <a:solidFill>
                   <a:srgbClr val="F4F6FA"/>
                 </a:solidFill>
@@ -7434,7 +7591,7 @@
               </a:defRPr>
             </a:lvl6pPr>
             <a:lvl7pPr>
-              <a:defRPr sz="2025" b="0">
+              <a:defRPr sz="1875" b="0">
                 <a:solidFill>
                   <a:srgbClr val="F4F6FA"/>
                 </a:solidFill>
@@ -7444,7 +7601,7 @@
               </a:defRPr>
             </a:lvl7pPr>
             <a:lvl8pPr>
-              <a:defRPr sz="2025" b="0">
+              <a:defRPr sz="1875" b="0">
                 <a:solidFill>
                   <a:srgbClr val="F4F6FA"/>
                 </a:solidFill>
@@ -7454,7 +7611,7 @@
               </a:defRPr>
             </a:lvl8pPr>
             <a:lvl9pPr>
-              <a:defRPr sz="2025" b="0">
+              <a:defRPr sz="1875" b="0">
                 <a:solidFill>
                   <a:srgbClr val="F4F6FA"/>
                 </a:solidFill>
@@ -7466,7 +7623,7 @@
           </a:lstStyle>
           <a:p xmlns:a="http://schemas.openxmlformats.org/drawingml/2006/main">
             <a:pPr>
-              <a:defRPr sz="2025" b="0">
+              <a:defRPr sz="1875" b="0">
                 <a:solidFill>
                   <a:srgbClr val="F4F6FA"/>
                 </a:solidFill>
@@ -7476,7 +7633,7 @@
               </a:defRPr>
             </a:pPr>
             <a:r>
-              <a:rPr sz="2025" b="0">
+              <a:rPr sz="1875" b="0">
                 <a:solidFill>
                   <a:srgbClr val="F4F6FA"/>
                 </a:solidFill>
@@ -7484,7 +7641,7 @@
                 <a:ea typeface="DejaVu Sans"/>
                 <a:cs typeface="DejaVu Sans"/>
               </a:rPr>
-              <a:t>Offline relay: 2.6 s. Four-stage status timeline.</a:t>
+              <a:t>Removing the direct link sent the next message through B.</a:t>
             </a:r>
           </a:p>
         </p:txBody>
@@ -7494,7 +7651,7 @@
           <p:cNvPr id="7" name="">
             <a:extLst xmlns:a="http://schemas.openxmlformats.org/drawingml/2006/main">
               <a:ext uri="{FF2B5EF4-FFF2-40B4-BE49-F238E27FC236}">
-                <a16:creationId xmlns:a16="http://schemas.microsoft.com/office/drawing/2014/main" id="{467F18FB-B955-412E-ABEE-D407CA693DF9}"/>
+                <a16:creationId xmlns:a16="http://schemas.microsoft.com/office/drawing/2014/main" id="{4058EF79-0DA4-4616-A7B6-5EEE0867DB90}"/>
               </a:ext>
             </a:extLst>
           </p:cNvPr>
@@ -7505,8 +7662,8 @@
         </p:nvSpPr>
         <p:spPr>
           <a:xfrm xmlns:a="http://schemas.openxmlformats.org/drawingml/2006/main">
-            <a:off x="619125" y="5295900"/>
-            <a:ext cx="10477500" cy="619125"/>
+            <a:off x="619125" y="5353050"/>
+            <a:ext cx="10572750" cy="523875"/>
           </a:xfrm>
           <a:prstGeom xmlns:a="http://schemas.openxmlformats.org/drawingml/2006/main" prst="rect">
             <a:avLst/>
@@ -7641,7 +7798,7 @@
                 <a:ea typeface="DejaVu Sans"/>
                 <a:cs typeface="DejaVu Sans"/>
               </a:rPr>
-              <a:t>Locked Samsung passed; vivo needed settings; OnePlus froze.</a:t>
+              <a:t>Earlier offline core relay: one hop in 2.6 s.</a:t>
             </a:r>
           </a:p>
         </p:txBody>
@@ -7649,7 +7806,7 @@
     </p:spTree>
     <p:extLst>
       <p:ext uri="{BB962C8B-B14F-4D97-AF65-F5344CB8AC3E}">
-        <p14:creationId xmlns:p14="http://schemas.microsoft.com/office/powerpoint/2010/main" val="2122729423"/>
+        <p14:creationId xmlns:p14="http://schemas.microsoft.com/office/powerpoint/2010/main" val="1739022348"/>
       </p:ext>
     </p:extLst>
   </p:cSld>
@@ -7677,10 +7834,10 @@
       </p:grpSpPr>
       <p:sp>
         <p:nvSpPr>
-          <p:cNvPr id="7" name="">
+          <p:cNvPr id="8" name="">
             <a:extLst xmlns:a="http://schemas.openxmlformats.org/drawingml/2006/main">
               <a:ext uri="{FF2B5EF4-FFF2-40B4-BE49-F238E27FC236}">
-                <a16:creationId xmlns:a16="http://schemas.microsoft.com/office/drawing/2014/main" id="{AD9AB925-5ED9-468C-9C12-A216178996DF}"/>
+                <a16:creationId xmlns:a16="http://schemas.microsoft.com/office/drawing/2014/main" id="{C6FF1320-3F9F-4D54-90AC-D6D7926D97C4}"/>
               </a:ext>
             </a:extLst>
           </p:cNvPr>
@@ -7837,7 +7994,7 @@
           <p:cNvPr id="2" name="">
             <a:extLst xmlns:a="http://schemas.openxmlformats.org/drawingml/2006/main">
               <a:ext uri="{FF2B5EF4-FFF2-40B4-BE49-F238E27FC236}">
-                <a16:creationId xmlns:a16="http://schemas.microsoft.com/office/drawing/2014/main" id="{50BDCB59-CF10-409E-B66E-2B6BB7C58E73}"/>
+                <a16:creationId xmlns:a16="http://schemas.microsoft.com/office/drawing/2014/main" id="{C01A1354-E0DA-4508-86E7-778342B6272A}"/>
               </a:ext>
             </a:extLst>
           </p:cNvPr>
@@ -7994,7 +8151,7 @@
           <p:cNvPr id="3" name="">
             <a:extLst xmlns:a="http://schemas.openxmlformats.org/drawingml/2006/main">
               <a:ext uri="{FF2B5EF4-FFF2-40B4-BE49-F238E27FC236}">
-                <a16:creationId xmlns:a16="http://schemas.microsoft.com/office/drawing/2014/main" id="{81B2B7BC-9892-487A-B58C-DA88A624D644}"/>
+                <a16:creationId xmlns:a16="http://schemas.microsoft.com/office/drawing/2014/main" id="{BC8163B0-AF21-450C-B3AF-7469D6B8F91D}"/>
               </a:ext>
             </a:extLst>
           </p:cNvPr>
@@ -8005,8 +8162,8 @@
         </p:nvSpPr>
         <p:spPr>
           <a:xfrm xmlns:a="http://schemas.openxmlformats.org/drawingml/2006/main">
-            <a:off x="619125" y="1724025"/>
-            <a:ext cx="10572750" cy="933450"/>
+            <a:off x="619125" y="1619250"/>
+            <a:ext cx="10572750" cy="771525"/>
           </a:xfrm>
           <a:prstGeom xmlns:a="http://schemas.openxmlformats.org/drawingml/2006/main" prst="rect">
             <a:avLst/>
@@ -8021,7 +8178,7 @@
           <a:bodyPr xmlns:a="http://schemas.openxmlformats.org/drawingml/2006/main"/>
           <a:lstStyle xmlns:a="http://schemas.openxmlformats.org/drawingml/2006/main">
             <a:defPPr>
-              <a:defRPr sz="1950" b="0">
+              <a:defRPr sz="1875" b="0">
                 <a:solidFill>
                   <a:srgbClr val="F4F6FA"/>
                 </a:solidFill>
@@ -8031,7 +8188,7 @@
               </a:defRPr>
             </a:defPPr>
             <a:lvl1pPr>
-              <a:defRPr sz="1950" b="0">
+              <a:defRPr sz="1875" b="0">
                 <a:solidFill>
                   <a:srgbClr val="F4F6FA"/>
                 </a:solidFill>
@@ -8041,7 +8198,7 @@
               </a:defRPr>
             </a:lvl1pPr>
             <a:lvl2pPr>
-              <a:defRPr sz="1950" b="0">
+              <a:defRPr sz="1875" b="0">
                 <a:solidFill>
                   <a:srgbClr val="F4F6FA"/>
                 </a:solidFill>
@@ -8051,7 +8208,7 @@
               </a:defRPr>
             </a:lvl2pPr>
             <a:lvl3pPr>
-              <a:defRPr sz="1950" b="0">
+              <a:defRPr sz="1875" b="0">
                 <a:solidFill>
                   <a:srgbClr val="F4F6FA"/>
                 </a:solidFill>
@@ -8061,7 +8218,7 @@
               </a:defRPr>
             </a:lvl3pPr>
             <a:lvl4pPr>
-              <a:defRPr sz="1950" b="0">
+              <a:defRPr sz="1875" b="0">
                 <a:solidFill>
                   <a:srgbClr val="F4F6FA"/>
                 </a:solidFill>
@@ -8071,7 +8228,7 @@
               </a:defRPr>
             </a:lvl4pPr>
             <a:lvl5pPr>
-              <a:defRPr sz="1950" b="0">
+              <a:defRPr sz="1875" b="0">
                 <a:solidFill>
                   <a:srgbClr val="F4F6FA"/>
                 </a:solidFill>
@@ -8081,7 +8238,7 @@
               </a:defRPr>
             </a:lvl5pPr>
             <a:lvl6pPr>
-              <a:defRPr sz="1950" b="0">
+              <a:defRPr sz="1875" b="0">
                 <a:solidFill>
                   <a:srgbClr val="F4F6FA"/>
                 </a:solidFill>
@@ -8091,7 +8248,7 @@
               </a:defRPr>
             </a:lvl6pPr>
             <a:lvl7pPr>
-              <a:defRPr sz="1950" b="0">
+              <a:defRPr sz="1875" b="0">
                 <a:solidFill>
                   <a:srgbClr val="F4F6FA"/>
                 </a:solidFill>
@@ -8101,7 +8258,7 @@
               </a:defRPr>
             </a:lvl7pPr>
             <a:lvl8pPr>
-              <a:defRPr sz="1950" b="0">
+              <a:defRPr sz="1875" b="0">
                 <a:solidFill>
                   <a:srgbClr val="F4F6FA"/>
                 </a:solidFill>
@@ -8111,7 +8268,7 @@
               </a:defRPr>
             </a:lvl8pPr>
             <a:lvl9pPr>
-              <a:defRPr sz="1950" b="0">
+              <a:defRPr sz="1875" b="0">
                 <a:solidFill>
                   <a:srgbClr val="F4F6FA"/>
                 </a:solidFill>
@@ -8123,7 +8280,7 @@
           </a:lstStyle>
           <a:p xmlns:a="http://schemas.openxmlformats.org/drawingml/2006/main">
             <a:pPr>
-              <a:defRPr sz="1950" b="0">
+              <a:defRPr sz="1875" b="0">
                 <a:solidFill>
                   <a:srgbClr val="F4F6FA"/>
                 </a:solidFill>
@@ -8133,7 +8290,7 @@
               </a:defRPr>
             </a:pPr>
             <a:r>
-              <a:rPr sz="1950" b="0">
+              <a:rPr sz="1875" b="0">
                 <a:solidFill>
                   <a:srgbClr val="F4F6FA"/>
                 </a:solidFill>
@@ -8141,7 +8298,7 @@
                 <a:ea typeface="DejaVu Sans"/>
                 <a:cs typeface="DejaVu Sans"/>
               </a:rPr>
-              <a:t>Locked relay varied by phone brand; OnePlus froze despite exemptions.</a:t>
+              <a:t>Three real phones and five simulated phones, not 1,000.</a:t>
             </a:r>
           </a:p>
         </p:txBody>
@@ -8151,7 +8308,7 @@
           <p:cNvPr id="4" name="">
             <a:extLst xmlns:a="http://schemas.openxmlformats.org/drawingml/2006/main">
               <a:ext uri="{FF2B5EF4-FFF2-40B4-BE49-F238E27FC236}">
-                <a16:creationId xmlns:a16="http://schemas.microsoft.com/office/drawing/2014/main" id="{9467A517-0B05-4D5D-8E0B-CBB24BD79DA7}"/>
+                <a16:creationId xmlns:a16="http://schemas.microsoft.com/office/drawing/2014/main" id="{5DD68AA9-4354-45D1-A9F2-2C8D8AA9EE03}"/>
               </a:ext>
             </a:extLst>
           </p:cNvPr>
@@ -8162,8 +8319,8 @@
         </p:nvSpPr>
         <p:spPr>
           <a:xfrm xmlns:a="http://schemas.openxmlformats.org/drawingml/2006/main">
-            <a:off x="619125" y="2724150"/>
-            <a:ext cx="10572750" cy="933450"/>
+            <a:off x="619125" y="2457450"/>
+            <a:ext cx="10572750" cy="771525"/>
           </a:xfrm>
           <a:prstGeom xmlns:a="http://schemas.openxmlformats.org/drawingml/2006/main" prst="rect">
             <a:avLst/>
@@ -8178,7 +8335,7 @@
           <a:bodyPr xmlns:a="http://schemas.openxmlformats.org/drawingml/2006/main"/>
           <a:lstStyle xmlns:a="http://schemas.openxmlformats.org/drawingml/2006/main">
             <a:defPPr>
-              <a:defRPr sz="1950" b="0">
+              <a:defRPr sz="1875" b="0">
                 <a:solidFill>
                   <a:srgbClr val="B6C0D1"/>
                 </a:solidFill>
@@ -8188,7 +8345,7 @@
               </a:defRPr>
             </a:defPPr>
             <a:lvl1pPr>
-              <a:defRPr sz="1950" b="0">
+              <a:defRPr sz="1875" b="0">
                 <a:solidFill>
                   <a:srgbClr val="B6C0D1"/>
                 </a:solidFill>
@@ -8198,7 +8355,7 @@
               </a:defRPr>
             </a:lvl1pPr>
             <a:lvl2pPr>
-              <a:defRPr sz="1950" b="0">
+              <a:defRPr sz="1875" b="0">
                 <a:solidFill>
                   <a:srgbClr val="B6C0D1"/>
                 </a:solidFill>
@@ -8208,7 +8365,7 @@
               </a:defRPr>
             </a:lvl2pPr>
             <a:lvl3pPr>
-              <a:defRPr sz="1950" b="0">
+              <a:defRPr sz="1875" b="0">
                 <a:solidFill>
                   <a:srgbClr val="B6C0D1"/>
                 </a:solidFill>
@@ -8218,7 +8375,7 @@
               </a:defRPr>
             </a:lvl3pPr>
             <a:lvl4pPr>
-              <a:defRPr sz="1950" b="0">
+              <a:defRPr sz="1875" b="0">
                 <a:solidFill>
                   <a:srgbClr val="B6C0D1"/>
                 </a:solidFill>
@@ -8228,7 +8385,7 @@
               </a:defRPr>
             </a:lvl4pPr>
             <a:lvl5pPr>
-              <a:defRPr sz="1950" b="0">
+              <a:defRPr sz="1875" b="0">
                 <a:solidFill>
                   <a:srgbClr val="B6C0D1"/>
                 </a:solidFill>
@@ -8238,7 +8395,7 @@
               </a:defRPr>
             </a:lvl5pPr>
             <a:lvl6pPr>
-              <a:defRPr sz="1950" b="0">
+              <a:defRPr sz="1875" b="0">
                 <a:solidFill>
                   <a:srgbClr val="B6C0D1"/>
                 </a:solidFill>
@@ -8248,7 +8405,7 @@
               </a:defRPr>
             </a:lvl6pPr>
             <a:lvl7pPr>
-              <a:defRPr sz="1950" b="0">
+              <a:defRPr sz="1875" b="0">
                 <a:solidFill>
                   <a:srgbClr val="B6C0D1"/>
                 </a:solidFill>
@@ -8258,7 +8415,7 @@
               </a:defRPr>
             </a:lvl7pPr>
             <a:lvl8pPr>
-              <a:defRPr sz="1950" b="0">
+              <a:defRPr sz="1875" b="0">
                 <a:solidFill>
                   <a:srgbClr val="B6C0D1"/>
                 </a:solidFill>
@@ -8268,7 +8425,7 @@
               </a:defRPr>
             </a:lvl8pPr>
             <a:lvl9pPr>
-              <a:defRPr sz="1950" b="0">
+              <a:defRPr sz="1875" b="0">
                 <a:solidFill>
                   <a:srgbClr val="B6C0D1"/>
                 </a:solidFill>
@@ -8280,7 +8437,7 @@
           </a:lstStyle>
           <a:p xmlns:a="http://schemas.openxmlformats.org/drawingml/2006/main">
             <a:pPr>
-              <a:defRPr sz="1950" b="0">
+              <a:defRPr sz="1875" b="0">
                 <a:solidFill>
                   <a:srgbClr val="B6C0D1"/>
                 </a:solidFill>
@@ -8290,7 +8447,7 @@
               </a:defRPr>
             </a:pPr>
             <a:r>
-              <a:rPr sz="1950" b="0">
+              <a:rPr sz="1875" b="0">
                 <a:solidFill>
                   <a:srgbClr val="B6C0D1"/>
                 </a:solidFill>
@@ -8298,7 +8455,7 @@
                 <a:ea typeface="DejaVu Sans"/>
                 <a:cs typeface="DejaVu Sans"/>
               </a:rPr>
-              <a:t>Extras run: A had internet, all phones were on USB power.</a:t>
+              <a:t>Area alerts used indoor test locations, not real GPS boundaries.</a:t>
             </a:r>
           </a:p>
         </p:txBody>
@@ -8308,7 +8465,7 @@
           <p:cNvPr id="5" name="">
             <a:extLst xmlns:a="http://schemas.openxmlformats.org/drawingml/2006/main">
               <a:ext uri="{FF2B5EF4-FFF2-40B4-BE49-F238E27FC236}">
-                <a16:creationId xmlns:a16="http://schemas.microsoft.com/office/drawing/2014/main" id="{F41A013D-5725-4701-B325-C7A36FD6AA5A}"/>
+                <a16:creationId xmlns:a16="http://schemas.microsoft.com/office/drawing/2014/main" id="{86555D36-16D4-4EC6-A153-CAFA23232B3B}"/>
               </a:ext>
             </a:extLst>
           </p:cNvPr>
@@ -8319,8 +8476,8 @@
         </p:nvSpPr>
         <p:spPr>
           <a:xfrm xmlns:a="http://schemas.openxmlformats.org/drawingml/2006/main">
-            <a:off x="619125" y="3724275"/>
-            <a:ext cx="10572750" cy="933450"/>
+            <a:off x="619125" y="3295650"/>
+            <a:ext cx="10572750" cy="771525"/>
           </a:xfrm>
           <a:prstGeom xmlns:a="http://schemas.openxmlformats.org/drawingml/2006/main" prst="rect">
             <a:avLst/>
@@ -8335,7 +8492,7 @@
           <a:bodyPr xmlns:a="http://schemas.openxmlformats.org/drawingml/2006/main"/>
           <a:lstStyle xmlns:a="http://schemas.openxmlformats.org/drawingml/2006/main">
             <a:defPPr>
-              <a:defRPr sz="1950" b="0">
+              <a:defRPr sz="1875" b="0">
                 <a:solidFill>
                   <a:srgbClr val="B6C0D1"/>
                 </a:solidFill>
@@ -8345,7 +8502,7 @@
               </a:defRPr>
             </a:defPPr>
             <a:lvl1pPr>
-              <a:defRPr sz="1950" b="0">
+              <a:defRPr sz="1875" b="0">
                 <a:solidFill>
                   <a:srgbClr val="B6C0D1"/>
                 </a:solidFill>
@@ -8355,7 +8512,7 @@
               </a:defRPr>
             </a:lvl1pPr>
             <a:lvl2pPr>
-              <a:defRPr sz="1950" b="0">
+              <a:defRPr sz="1875" b="0">
                 <a:solidFill>
                   <a:srgbClr val="B6C0D1"/>
                 </a:solidFill>
@@ -8365,7 +8522,7 @@
               </a:defRPr>
             </a:lvl2pPr>
             <a:lvl3pPr>
-              <a:defRPr sz="1950" b="0">
+              <a:defRPr sz="1875" b="0">
                 <a:solidFill>
                   <a:srgbClr val="B6C0D1"/>
                 </a:solidFill>
@@ -8375,7 +8532,7 @@
               </a:defRPr>
             </a:lvl3pPr>
             <a:lvl4pPr>
-              <a:defRPr sz="1950" b="0">
+              <a:defRPr sz="1875" b="0">
                 <a:solidFill>
                   <a:srgbClr val="B6C0D1"/>
                 </a:solidFill>
@@ -8385,7 +8542,7 @@
               </a:defRPr>
             </a:lvl4pPr>
             <a:lvl5pPr>
-              <a:defRPr sz="1950" b="0">
+              <a:defRPr sz="1875" b="0">
                 <a:solidFill>
                   <a:srgbClr val="B6C0D1"/>
                 </a:solidFill>
@@ -8395,7 +8552,7 @@
               </a:defRPr>
             </a:lvl5pPr>
             <a:lvl6pPr>
-              <a:defRPr sz="1950" b="0">
+              <a:defRPr sz="1875" b="0">
                 <a:solidFill>
                   <a:srgbClr val="B6C0D1"/>
                 </a:solidFill>
@@ -8405,7 +8562,7 @@
               </a:defRPr>
             </a:lvl6pPr>
             <a:lvl7pPr>
-              <a:defRPr sz="1950" b="0">
+              <a:defRPr sz="1875" b="0">
                 <a:solidFill>
                   <a:srgbClr val="B6C0D1"/>
                 </a:solidFill>
@@ -8415,7 +8572,7 @@
               </a:defRPr>
             </a:lvl7pPr>
             <a:lvl8pPr>
-              <a:defRPr sz="1950" b="0">
+              <a:defRPr sz="1875" b="0">
                 <a:solidFill>
                   <a:srgbClr val="B6C0D1"/>
                 </a:solidFill>
@@ -8425,7 +8582,7 @@
               </a:defRPr>
             </a:lvl8pPr>
             <a:lvl9pPr>
-              <a:defRPr sz="1950" b="0">
+              <a:defRPr sz="1875" b="0">
                 <a:solidFill>
                   <a:srgbClr val="B6C0D1"/>
                 </a:solidFill>
@@ -8437,7 +8594,7 @@
           </a:lstStyle>
           <a:p xmlns:a="http://schemas.openxmlformats.org/drawingml/2006/main">
             <a:pPr>
-              <a:defRPr sz="1950" b="0">
+              <a:defRPr sz="1875" b="0">
                 <a:solidFill>
                   <a:srgbClr val="B6C0D1"/>
                 </a:solidFill>
@@ -8447,7 +8604,7 @@
               </a:defRPr>
             </a:pPr>
             <a:r>
-              <a:rPr sz="1950" b="0">
+              <a:rPr sz="1875" b="0">
                 <a:solidFill>
                   <a:srgbClr val="B6C0D1"/>
                 </a:solidFill>
@@ -8455,7 +8612,7 @@
                 <a:ea typeface="DejaVu Sans"/>
                 <a:cs typeface="DejaVu Sans"/>
               </a:rPr>
-              <a:t>Laptop and dashboard tests used a USB bridge; AI model was off.</a:t>
+              <a:t>SOS location needs a fix from the last two minutes.</a:t>
             </a:r>
           </a:p>
         </p:txBody>
@@ -8465,7 +8622,7 @@
           <p:cNvPr id="6" name="">
             <a:extLst xmlns:a="http://schemas.openxmlformats.org/drawingml/2006/main">
               <a:ext uri="{FF2B5EF4-FFF2-40B4-BE49-F238E27FC236}">
-                <a16:creationId xmlns:a16="http://schemas.microsoft.com/office/drawing/2014/main" id="{1D3A6F78-98AF-4A01-8762-2831D9C00F76}"/>
+                <a16:creationId xmlns:a16="http://schemas.microsoft.com/office/drawing/2014/main" id="{A0A22D8B-C9A4-4500-AEAD-2D5EA3C2BA4F}"/>
               </a:ext>
             </a:extLst>
           </p:cNvPr>
@@ -8476,8 +8633,8 @@
         </p:nvSpPr>
         <p:spPr>
           <a:xfrm xmlns:a="http://schemas.openxmlformats.org/drawingml/2006/main">
-            <a:off x="619125" y="4724400"/>
-            <a:ext cx="10572750" cy="933450"/>
+            <a:off x="619125" y="4133850"/>
+            <a:ext cx="10572750" cy="771525"/>
           </a:xfrm>
           <a:prstGeom xmlns:a="http://schemas.openxmlformats.org/drawingml/2006/main" prst="rect">
             <a:avLst/>
@@ -8492,7 +8649,7 @@
           <a:bodyPr xmlns:a="http://schemas.openxmlformats.org/drawingml/2006/main"/>
           <a:lstStyle xmlns:a="http://schemas.openxmlformats.org/drawingml/2006/main">
             <a:defPPr>
-              <a:defRPr sz="1950" b="0">
+              <a:defRPr sz="1875" b="0">
                 <a:solidFill>
                   <a:srgbClr val="B6C0D1"/>
                 </a:solidFill>
@@ -8502,7 +8659,7 @@
               </a:defRPr>
             </a:defPPr>
             <a:lvl1pPr>
-              <a:defRPr sz="1950" b="0">
+              <a:defRPr sz="1875" b="0">
                 <a:solidFill>
                   <a:srgbClr val="B6C0D1"/>
                 </a:solidFill>
@@ -8512,7 +8669,7 @@
               </a:defRPr>
             </a:lvl1pPr>
             <a:lvl2pPr>
-              <a:defRPr sz="1950" b="0">
+              <a:defRPr sz="1875" b="0">
                 <a:solidFill>
                   <a:srgbClr val="B6C0D1"/>
                 </a:solidFill>
@@ -8522,7 +8679,7 @@
               </a:defRPr>
             </a:lvl2pPr>
             <a:lvl3pPr>
-              <a:defRPr sz="1950" b="0">
+              <a:defRPr sz="1875" b="0">
                 <a:solidFill>
                   <a:srgbClr val="B6C0D1"/>
                 </a:solidFill>
@@ -8532,7 +8689,7 @@
               </a:defRPr>
             </a:lvl3pPr>
             <a:lvl4pPr>
-              <a:defRPr sz="1950" b="0">
+              <a:defRPr sz="1875" b="0">
                 <a:solidFill>
                   <a:srgbClr val="B6C0D1"/>
                 </a:solidFill>
@@ -8542,7 +8699,7 @@
               </a:defRPr>
             </a:lvl4pPr>
             <a:lvl5pPr>
-              <a:defRPr sz="1950" b="0">
+              <a:defRPr sz="1875" b="0">
                 <a:solidFill>
                   <a:srgbClr val="B6C0D1"/>
                 </a:solidFill>
@@ -8552,7 +8709,7 @@
               </a:defRPr>
             </a:lvl5pPr>
             <a:lvl6pPr>
-              <a:defRPr sz="1950" b="0">
+              <a:defRPr sz="1875" b="0">
                 <a:solidFill>
                   <a:srgbClr val="B6C0D1"/>
                 </a:solidFill>
@@ -8562,7 +8719,7 @@
               </a:defRPr>
             </a:lvl6pPr>
             <a:lvl7pPr>
-              <a:defRPr sz="1950" b="0">
+              <a:defRPr sz="1875" b="0">
                 <a:solidFill>
                   <a:srgbClr val="B6C0D1"/>
                 </a:solidFill>
@@ -8572,7 +8729,7 @@
               </a:defRPr>
             </a:lvl7pPr>
             <a:lvl8pPr>
-              <a:defRPr sz="1950" b="0">
+              <a:defRPr sz="1875" b="0">
                 <a:solidFill>
                   <a:srgbClr val="B6C0D1"/>
                 </a:solidFill>
@@ -8582,7 +8739,7 @@
               </a:defRPr>
             </a:lvl8pPr>
             <a:lvl9pPr>
-              <a:defRPr sz="1950" b="0">
+              <a:defRPr sz="1875" b="0">
                 <a:solidFill>
                   <a:srgbClr val="B6C0D1"/>
                 </a:solidFill>
@@ -8594,7 +8751,7 @@
           </a:lstStyle>
           <a:p xmlns:a="http://schemas.openxmlformats.org/drawingml/2006/main">
             <a:pPr>
-              <a:defRPr sz="1950" b="0">
+              <a:defRPr sz="1875" b="0">
                 <a:solidFill>
                   <a:srgbClr val="B6C0D1"/>
                 </a:solidFill>
@@ -8604,7 +8761,7 @@
               </a:defRPr>
             </a:pPr>
             <a:r>
-              <a:rPr sz="1950" b="0">
+              <a:rPr sz="1875" b="0">
                 <a:solidFill>
                   <a:srgbClr val="B6C0D1"/>
                 </a:solidFill>
@@ -8612,7 +8769,164 @@
                 <a:ea typeface="DejaVu Sans"/>
                 <a:cs typeface="DejaVu Sans"/>
               </a:rPr>
-              <a:t>Range, battery drain and real no-app phone remain untested.</a:t>
+              <a:t>The first message to a new phone still spreads through all paths.</a:t>
+            </a:r>
+          </a:p>
+        </p:txBody>
+      </p:sp>
+      <p:sp>
+        <p:nvSpPr>
+          <p:cNvPr id="7" name="">
+            <a:extLst xmlns:a="http://schemas.openxmlformats.org/drawingml/2006/main">
+              <a:ext uri="{FF2B5EF4-FFF2-40B4-BE49-F238E27FC236}">
+                <a16:creationId xmlns:a16="http://schemas.microsoft.com/office/drawing/2014/main" id="{A6C36C63-1DFD-48A9-B136-86105758D974}"/>
+              </a:ext>
+            </a:extLst>
+          </p:cNvPr>
+          <p:cNvSpPr>
+            <a:spLocks xmlns:a="http://schemas.openxmlformats.org/drawingml/2006/main" noGrp="1"/>
+          </p:cNvSpPr>
+          <p:nvPr/>
+        </p:nvSpPr>
+        <p:spPr>
+          <a:xfrm xmlns:a="http://schemas.openxmlformats.org/drawingml/2006/main">
+            <a:off x="619125" y="4972050"/>
+            <a:ext cx="10572750" cy="771525"/>
+          </a:xfrm>
+          <a:prstGeom xmlns:a="http://schemas.openxmlformats.org/drawingml/2006/main" prst="rect">
+            <a:avLst/>
+          </a:prstGeom>
+          <a:noFill xmlns:a="http://schemas.openxmlformats.org/drawingml/2006/main"/>
+          <a:ln xmlns:a="http://schemas.openxmlformats.org/drawingml/2006/main" w="0">
+            <a:noFill/>
+            <a:prstDash val="solid"/>
+          </a:ln>
+        </p:spPr>
+        <p:txBody>
+          <a:bodyPr xmlns:a="http://schemas.openxmlformats.org/drawingml/2006/main"/>
+          <a:lstStyle xmlns:a="http://schemas.openxmlformats.org/drawingml/2006/main">
+            <a:defPPr>
+              <a:defRPr sz="1875" b="0">
+                <a:solidFill>
+                  <a:srgbClr val="B6C0D1"/>
+                </a:solidFill>
+                <a:latin typeface="DejaVu Sans"/>
+                <a:ea typeface="DejaVu Sans"/>
+                <a:cs typeface="DejaVu Sans"/>
+              </a:defRPr>
+            </a:defPPr>
+            <a:lvl1pPr>
+              <a:defRPr sz="1875" b="0">
+                <a:solidFill>
+                  <a:srgbClr val="B6C0D1"/>
+                </a:solidFill>
+                <a:latin typeface="DejaVu Sans"/>
+                <a:ea typeface="DejaVu Sans"/>
+                <a:cs typeface="DejaVu Sans"/>
+              </a:defRPr>
+            </a:lvl1pPr>
+            <a:lvl2pPr>
+              <a:defRPr sz="1875" b="0">
+                <a:solidFill>
+                  <a:srgbClr val="B6C0D1"/>
+                </a:solidFill>
+                <a:latin typeface="DejaVu Sans"/>
+                <a:ea typeface="DejaVu Sans"/>
+                <a:cs typeface="DejaVu Sans"/>
+              </a:defRPr>
+            </a:lvl2pPr>
+            <a:lvl3pPr>
+              <a:defRPr sz="1875" b="0">
+                <a:solidFill>
+                  <a:srgbClr val="B6C0D1"/>
+                </a:solidFill>
+                <a:latin typeface="DejaVu Sans"/>
+                <a:ea typeface="DejaVu Sans"/>
+                <a:cs typeface="DejaVu Sans"/>
+              </a:defRPr>
+            </a:lvl3pPr>
+            <a:lvl4pPr>
+              <a:defRPr sz="1875" b="0">
+                <a:solidFill>
+                  <a:srgbClr val="B6C0D1"/>
+                </a:solidFill>
+                <a:latin typeface="DejaVu Sans"/>
+                <a:ea typeface="DejaVu Sans"/>
+                <a:cs typeface="DejaVu Sans"/>
+              </a:defRPr>
+            </a:lvl4pPr>
+            <a:lvl5pPr>
+              <a:defRPr sz="1875" b="0">
+                <a:solidFill>
+                  <a:srgbClr val="B6C0D1"/>
+                </a:solidFill>
+                <a:latin typeface="DejaVu Sans"/>
+                <a:ea typeface="DejaVu Sans"/>
+                <a:cs typeface="DejaVu Sans"/>
+              </a:defRPr>
+            </a:lvl5pPr>
+            <a:lvl6pPr>
+              <a:defRPr sz="1875" b="0">
+                <a:solidFill>
+                  <a:srgbClr val="B6C0D1"/>
+                </a:solidFill>
+                <a:latin typeface="DejaVu Sans"/>
+                <a:ea typeface="DejaVu Sans"/>
+                <a:cs typeface="DejaVu Sans"/>
+              </a:defRPr>
+            </a:lvl6pPr>
+            <a:lvl7pPr>
+              <a:defRPr sz="1875" b="0">
+                <a:solidFill>
+                  <a:srgbClr val="B6C0D1"/>
+                </a:solidFill>
+                <a:latin typeface="DejaVu Sans"/>
+                <a:ea typeface="DejaVu Sans"/>
+                <a:cs typeface="DejaVu Sans"/>
+              </a:defRPr>
+            </a:lvl7pPr>
+            <a:lvl8pPr>
+              <a:defRPr sz="1875" b="0">
+                <a:solidFill>
+                  <a:srgbClr val="B6C0D1"/>
+                </a:solidFill>
+                <a:latin typeface="DejaVu Sans"/>
+                <a:ea typeface="DejaVu Sans"/>
+                <a:cs typeface="DejaVu Sans"/>
+              </a:defRPr>
+            </a:lvl8pPr>
+            <a:lvl9pPr>
+              <a:defRPr sz="1875" b="0">
+                <a:solidFill>
+                  <a:srgbClr val="B6C0D1"/>
+                </a:solidFill>
+                <a:latin typeface="DejaVu Sans"/>
+                <a:ea typeface="DejaVu Sans"/>
+                <a:cs typeface="DejaVu Sans"/>
+              </a:defRPr>
+            </a:lvl9pPr>
+          </a:lstStyle>
+          <a:p xmlns:a="http://schemas.openxmlformats.org/drawingml/2006/main">
+            <a:pPr>
+              <a:defRPr sz="1875" b="0">
+                <a:solidFill>
+                  <a:srgbClr val="B6C0D1"/>
+                </a:solidFill>
+                <a:latin typeface="DejaVu Sans"/>
+                <a:ea typeface="DejaVu Sans"/>
+                <a:cs typeface="DejaVu Sans"/>
+              </a:defRPr>
+            </a:pPr>
+            <a:r>
+              <a:rPr sz="1875" b="0">
+                <a:solidFill>
+                  <a:srgbClr val="B6C0D1"/>
+                </a:solidFill>
+                <a:latin typeface="DejaVu Sans"/>
+                <a:ea typeface="DejaVu Sans"/>
+                <a:cs typeface="DejaVu Sans"/>
+              </a:rPr>
+              <a:t>Range, battery drain and live AI remain untested.</a:t>
             </a:r>
           </a:p>
         </p:txBody>
@@ -8620,7 +8934,7 @@
     </p:spTree>
     <p:extLst>
       <p:ext uri="{BB962C8B-B14F-4D97-AF65-F5344CB8AC3E}">
-        <p14:creationId xmlns:p14="http://schemas.microsoft.com/office/powerpoint/2010/main" val="1944898372"/>
+        <p14:creationId xmlns:p14="http://schemas.microsoft.com/office/powerpoint/2010/main" val="1162727454"/>
       </p:ext>
     </p:extLst>
   </p:cSld>
@@ -8648,10 +8962,10 @@
       </p:grpSpPr>
       <p:sp>
         <p:nvSpPr>
-          <p:cNvPr id="7" name="">
+          <p:cNvPr id="4" name="">
             <a:extLst xmlns:a="http://schemas.openxmlformats.org/drawingml/2006/main">
               <a:ext uri="{FF2B5EF4-FFF2-40B4-BE49-F238E27FC236}">
-                <a16:creationId xmlns:a16="http://schemas.microsoft.com/office/drawing/2014/main" id="{5A5C7FA7-6FFC-4E3A-93F0-DB8B998D6AB6}"/>
+                <a16:creationId xmlns:a16="http://schemas.microsoft.com/office/drawing/2014/main" id="{57E85F53-FE8E-4B56-A5DC-96AC6CD5A351}"/>
               </a:ext>
             </a:extLst>
           </p:cNvPr>
@@ -8808,7 +9122,7 @@
           <p:cNvPr id="2" name="">
             <a:extLst xmlns:a="http://schemas.openxmlformats.org/drawingml/2006/main">
               <a:ext uri="{FF2B5EF4-FFF2-40B4-BE49-F238E27FC236}">
-                <a16:creationId xmlns:a16="http://schemas.microsoft.com/office/drawing/2014/main" id="{4BE96CCA-BE28-4B93-B3CA-ECA471F583E0}"/>
+                <a16:creationId xmlns:a16="http://schemas.microsoft.com/office/drawing/2014/main" id="{2514CC53-039A-48A2-9695-17C74FDB23C8}"/>
               </a:ext>
             </a:extLst>
           </p:cNvPr>
@@ -8960,638 +9274,530 @@
           </a:p>
         </p:txBody>
       </p:sp>
-      <p:sp>
-        <p:nvSpPr>
+      <p:graphicFrame>
+        <p:nvGraphicFramePr>
           <p:cNvPr id="3" name="">
             <a:extLst xmlns:a="http://schemas.openxmlformats.org/drawingml/2006/main">
               <a:ext uri="{FF2B5EF4-FFF2-40B4-BE49-F238E27FC236}">
-                <a16:creationId xmlns:a16="http://schemas.microsoft.com/office/drawing/2014/main" id="{13F57E53-C64E-4B61-9E5E-A354AA63646F}"/>
+                <a16:creationId xmlns:a16="http://schemas.microsoft.com/office/drawing/2014/main" id="{71669BA5-6F66-4D45-9F3E-57E98C0990A3}"/>
               </a:ext>
             </a:extLst>
           </p:cNvPr>
-          <p:cNvSpPr>
-            <a:spLocks xmlns:a="http://schemas.openxmlformats.org/drawingml/2006/main" noGrp="1"/>
-          </p:cNvSpPr>
+          <p:cNvGraphicFramePr/>
           <p:nvPr/>
-        </p:nvSpPr>
-        <p:spPr>
-          <a:xfrm xmlns:a="http://schemas.openxmlformats.org/drawingml/2006/main">
-            <a:off x="619125" y="1657350"/>
-            <a:ext cx="10477500" cy="952500"/>
-          </a:xfrm>
-          <a:prstGeom xmlns:a="http://schemas.openxmlformats.org/drawingml/2006/main" prst="rect">
-            <a:avLst/>
-          </a:prstGeom>
-          <a:noFill xmlns:a="http://schemas.openxmlformats.org/drawingml/2006/main"/>
-          <a:ln xmlns:a="http://schemas.openxmlformats.org/drawingml/2006/main" w="0">
-            <a:noFill/>
-            <a:prstDash val="solid"/>
-          </a:ln>
-        </p:spPr>
-        <p:txBody>
-          <a:bodyPr xmlns:a="http://schemas.openxmlformats.org/drawingml/2006/main"/>
-          <a:lstStyle xmlns:a="http://schemas.openxmlformats.org/drawingml/2006/main">
-            <a:defPPr>
-              <a:defRPr sz="2025" b="0">
-                <a:solidFill>
-                  <a:srgbClr val="F4F6FA"/>
-                </a:solidFill>
-                <a:latin typeface="DejaVu Sans"/>
-                <a:ea typeface="DejaVu Sans"/>
-                <a:cs typeface="DejaVu Sans"/>
-              </a:defRPr>
-            </a:defPPr>
-            <a:lvl1pPr>
-              <a:defRPr sz="2025" b="0">
-                <a:solidFill>
-                  <a:srgbClr val="F4F6FA"/>
-                </a:solidFill>
-                <a:latin typeface="DejaVu Sans"/>
-                <a:ea typeface="DejaVu Sans"/>
-                <a:cs typeface="DejaVu Sans"/>
-              </a:defRPr>
-            </a:lvl1pPr>
-            <a:lvl2pPr>
-              <a:defRPr sz="2025" b="0">
-                <a:solidFill>
-                  <a:srgbClr val="F4F6FA"/>
-                </a:solidFill>
-                <a:latin typeface="DejaVu Sans"/>
-                <a:ea typeface="DejaVu Sans"/>
-                <a:cs typeface="DejaVu Sans"/>
-              </a:defRPr>
-            </a:lvl2pPr>
-            <a:lvl3pPr>
-              <a:defRPr sz="2025" b="0">
-                <a:solidFill>
-                  <a:srgbClr val="F4F6FA"/>
-                </a:solidFill>
-                <a:latin typeface="DejaVu Sans"/>
-                <a:ea typeface="DejaVu Sans"/>
-                <a:cs typeface="DejaVu Sans"/>
-              </a:defRPr>
-            </a:lvl3pPr>
-            <a:lvl4pPr>
-              <a:defRPr sz="2025" b="0">
-                <a:solidFill>
-                  <a:srgbClr val="F4F6FA"/>
-                </a:solidFill>
-                <a:latin typeface="DejaVu Sans"/>
-                <a:ea typeface="DejaVu Sans"/>
-                <a:cs typeface="DejaVu Sans"/>
-              </a:defRPr>
-            </a:lvl4pPr>
-            <a:lvl5pPr>
-              <a:defRPr sz="2025" b="0">
-                <a:solidFill>
-                  <a:srgbClr val="F4F6FA"/>
-                </a:solidFill>
-                <a:latin typeface="DejaVu Sans"/>
-                <a:ea typeface="DejaVu Sans"/>
-                <a:cs typeface="DejaVu Sans"/>
-              </a:defRPr>
-            </a:lvl5pPr>
-            <a:lvl6pPr>
-              <a:defRPr sz="2025" b="0">
-                <a:solidFill>
-                  <a:srgbClr val="F4F6FA"/>
-                </a:solidFill>
-                <a:latin typeface="DejaVu Sans"/>
-                <a:ea typeface="DejaVu Sans"/>
-                <a:cs typeface="DejaVu Sans"/>
-              </a:defRPr>
-            </a:lvl6pPr>
-            <a:lvl7pPr>
-              <a:defRPr sz="2025" b="0">
-                <a:solidFill>
-                  <a:srgbClr val="F4F6FA"/>
-                </a:solidFill>
-                <a:latin typeface="DejaVu Sans"/>
-                <a:ea typeface="DejaVu Sans"/>
-                <a:cs typeface="DejaVu Sans"/>
-              </a:defRPr>
-            </a:lvl7pPr>
-            <a:lvl8pPr>
-              <a:defRPr sz="2025" b="0">
-                <a:solidFill>
-                  <a:srgbClr val="F4F6FA"/>
-                </a:solidFill>
-                <a:latin typeface="DejaVu Sans"/>
-                <a:ea typeface="DejaVu Sans"/>
-                <a:cs typeface="DejaVu Sans"/>
-              </a:defRPr>
-            </a:lvl8pPr>
-            <a:lvl9pPr>
-              <a:defRPr sz="2025" b="0">
-                <a:solidFill>
-                  <a:srgbClr val="F4F6FA"/>
-                </a:solidFill>
-                <a:latin typeface="DejaVu Sans"/>
-                <a:ea typeface="DejaVu Sans"/>
-                <a:cs typeface="DejaVu Sans"/>
-              </a:defRPr>
-            </a:lvl9pPr>
-          </a:lstStyle>
-          <a:p xmlns:a="http://schemas.openxmlformats.org/drawingml/2006/main">
-            <a:pPr>
-              <a:defRPr sz="2025" b="0">
-                <a:solidFill>
-                  <a:srgbClr val="F4F6FA"/>
-                </a:solidFill>
-                <a:latin typeface="DejaVu Sans"/>
-                <a:ea typeface="DejaVu Sans"/>
-                <a:cs typeface="DejaVu Sans"/>
-              </a:defRPr>
-            </a:pPr>
-            <a:r>
-              <a:rPr sz="2025" b="0">
-                <a:solidFill>
-                  <a:srgbClr val="F4F6FA"/>
-                </a:solidFill>
-                <a:latin typeface="DejaVu Sans"/>
-                <a:ea typeface="DejaVu Sans"/>
-                <a:cs typeface="DejaVu Sans"/>
-              </a:rPr>
-              <a:t>Relay, acknowledgement and queued recovery passed on three phones.</a:t>
-            </a:r>
-          </a:p>
-        </p:txBody>
-      </p:sp>
-      <p:sp>
-        <p:nvSpPr>
-          <p:cNvPr id="4" name="">
-            <a:extLst xmlns:a="http://schemas.openxmlformats.org/drawingml/2006/main">
-              <a:ext uri="{FF2B5EF4-FFF2-40B4-BE49-F238E27FC236}">
-                <a16:creationId xmlns:a16="http://schemas.microsoft.com/office/drawing/2014/main" id="{D8A4144F-B00A-4C27-ACFB-AF2421CC54FA}"/>
-              </a:ext>
-            </a:extLst>
-          </p:cNvPr>
-          <p:cNvSpPr>
-            <a:spLocks xmlns:a="http://schemas.openxmlformats.org/drawingml/2006/main" noGrp="1"/>
-          </p:cNvSpPr>
-          <p:nvPr/>
-        </p:nvSpPr>
-        <p:spPr>
-          <a:xfrm xmlns:a="http://schemas.openxmlformats.org/drawingml/2006/main">
-            <a:off x="619125" y="2838450"/>
-            <a:ext cx="10477500" cy="857250"/>
-          </a:xfrm>
-          <a:prstGeom xmlns:a="http://schemas.openxmlformats.org/drawingml/2006/main" prst="rect">
-            <a:avLst/>
-          </a:prstGeom>
-          <a:noFill xmlns:a="http://schemas.openxmlformats.org/drawingml/2006/main"/>
-          <a:ln xmlns:a="http://schemas.openxmlformats.org/drawingml/2006/main" w="0">
-            <a:noFill/>
-            <a:prstDash val="solid"/>
-          </a:ln>
-        </p:spPr>
-        <p:txBody>
-          <a:bodyPr xmlns:a="http://schemas.openxmlformats.org/drawingml/2006/main"/>
-          <a:lstStyle xmlns:a="http://schemas.openxmlformats.org/drawingml/2006/main">
-            <a:defPPr>
-              <a:defRPr sz="2025" b="1">
-                <a:solidFill>
-                  <a:srgbClr val="6DE0D5"/>
-                </a:solidFill>
-                <a:latin typeface="DejaVu Sans"/>
-                <a:ea typeface="DejaVu Sans"/>
-                <a:cs typeface="DejaVu Sans"/>
-              </a:defRPr>
-            </a:defPPr>
-            <a:lvl1pPr>
-              <a:defRPr sz="2025" b="1">
-                <a:solidFill>
-                  <a:srgbClr val="6DE0D5"/>
-                </a:solidFill>
-                <a:latin typeface="DejaVu Sans"/>
-                <a:ea typeface="DejaVu Sans"/>
-                <a:cs typeface="DejaVu Sans"/>
-              </a:defRPr>
-            </a:lvl1pPr>
-            <a:lvl2pPr>
-              <a:defRPr sz="2025" b="1">
-                <a:solidFill>
-                  <a:srgbClr val="6DE0D5"/>
-                </a:solidFill>
-                <a:latin typeface="DejaVu Sans"/>
-                <a:ea typeface="DejaVu Sans"/>
-                <a:cs typeface="DejaVu Sans"/>
-              </a:defRPr>
-            </a:lvl2pPr>
-            <a:lvl3pPr>
-              <a:defRPr sz="2025" b="1">
-                <a:solidFill>
-                  <a:srgbClr val="6DE0D5"/>
-                </a:solidFill>
-                <a:latin typeface="DejaVu Sans"/>
-                <a:ea typeface="DejaVu Sans"/>
-                <a:cs typeface="DejaVu Sans"/>
-              </a:defRPr>
-            </a:lvl3pPr>
-            <a:lvl4pPr>
-              <a:defRPr sz="2025" b="1">
-                <a:solidFill>
-                  <a:srgbClr val="6DE0D5"/>
-                </a:solidFill>
-                <a:latin typeface="DejaVu Sans"/>
-                <a:ea typeface="DejaVu Sans"/>
-                <a:cs typeface="DejaVu Sans"/>
-              </a:defRPr>
-            </a:lvl4pPr>
-            <a:lvl5pPr>
-              <a:defRPr sz="2025" b="1">
-                <a:solidFill>
-                  <a:srgbClr val="6DE0D5"/>
-                </a:solidFill>
-                <a:latin typeface="DejaVu Sans"/>
-                <a:ea typeface="DejaVu Sans"/>
-                <a:cs typeface="DejaVu Sans"/>
-              </a:defRPr>
-            </a:lvl5pPr>
-            <a:lvl6pPr>
-              <a:defRPr sz="2025" b="1">
-                <a:solidFill>
-                  <a:srgbClr val="6DE0D5"/>
-                </a:solidFill>
-                <a:latin typeface="DejaVu Sans"/>
-                <a:ea typeface="DejaVu Sans"/>
-                <a:cs typeface="DejaVu Sans"/>
-              </a:defRPr>
-            </a:lvl6pPr>
-            <a:lvl7pPr>
-              <a:defRPr sz="2025" b="1">
-                <a:solidFill>
-                  <a:srgbClr val="6DE0D5"/>
-                </a:solidFill>
-                <a:latin typeface="DejaVu Sans"/>
-                <a:ea typeface="DejaVu Sans"/>
-                <a:cs typeface="DejaVu Sans"/>
-              </a:defRPr>
-            </a:lvl7pPr>
-            <a:lvl8pPr>
-              <a:defRPr sz="2025" b="1">
-                <a:solidFill>
-                  <a:srgbClr val="6DE0D5"/>
-                </a:solidFill>
-                <a:latin typeface="DejaVu Sans"/>
-                <a:ea typeface="DejaVu Sans"/>
-                <a:cs typeface="DejaVu Sans"/>
-              </a:defRPr>
-            </a:lvl8pPr>
-            <a:lvl9pPr>
-              <a:defRPr sz="2025" b="1">
-                <a:solidFill>
-                  <a:srgbClr val="6DE0D5"/>
-                </a:solidFill>
-                <a:latin typeface="DejaVu Sans"/>
-                <a:ea typeface="DejaVu Sans"/>
-                <a:cs typeface="DejaVu Sans"/>
-              </a:defRPr>
-            </a:lvl9pPr>
-          </a:lstStyle>
-          <a:p xmlns:a="http://schemas.openxmlformats.org/drawingml/2006/main">
-            <a:pPr>
-              <a:defRPr sz="2025" b="1">
-                <a:solidFill>
-                  <a:srgbClr val="6DE0D5"/>
-                </a:solidFill>
-                <a:latin typeface="DejaVu Sans"/>
-                <a:ea typeface="DejaVu Sans"/>
-                <a:cs typeface="DejaVu Sans"/>
-              </a:defRPr>
-            </a:pPr>
-            <a:r>
-              <a:rPr sz="2025" b="1">
-                <a:solidFill>
-                  <a:srgbClr val="6DE0D5"/>
-                </a:solidFill>
-                <a:latin typeface="DejaVu Sans"/>
-                <a:ea typeface="DejaVu Sans"/>
-                <a:cs typeface="DejaVu Sans"/>
-              </a:rPr>
-              <a:t>A new status timeline keeps Relayed visible after delivery.</a:t>
-            </a:r>
-          </a:p>
-        </p:txBody>
-      </p:sp>
-      <p:sp>
-        <p:nvSpPr>
-          <p:cNvPr id="5" name="">
-            <a:extLst xmlns:a="http://schemas.openxmlformats.org/drawingml/2006/main">
-              <a:ext uri="{FF2B5EF4-FFF2-40B4-BE49-F238E27FC236}">
-                <a16:creationId xmlns:a16="http://schemas.microsoft.com/office/drawing/2014/main" id="{844ECD6C-E3BA-48BD-8901-6C362E6F87E8}"/>
-              </a:ext>
-            </a:extLst>
-          </p:cNvPr>
-          <p:cNvSpPr>
-            <a:spLocks xmlns:a="http://schemas.openxmlformats.org/drawingml/2006/main" noGrp="1"/>
-          </p:cNvSpPr>
-          <p:nvPr/>
-        </p:nvSpPr>
-        <p:spPr>
-          <a:xfrm xmlns:a="http://schemas.openxmlformats.org/drawingml/2006/main">
-            <a:off x="619125" y="4000500"/>
-            <a:ext cx="10477500" cy="619125"/>
-          </a:xfrm>
-          <a:prstGeom xmlns:a="http://schemas.openxmlformats.org/drawingml/2006/main" prst="rect">
-            <a:avLst/>
-          </a:prstGeom>
-          <a:noFill xmlns:a="http://schemas.openxmlformats.org/drawingml/2006/main"/>
-          <a:ln xmlns:a="http://schemas.openxmlformats.org/drawingml/2006/main" w="0">
-            <a:noFill/>
-            <a:prstDash val="solid"/>
-          </a:ln>
-        </p:spPr>
-        <p:txBody>
-          <a:bodyPr xmlns:a="http://schemas.openxmlformats.org/drawingml/2006/main"/>
-          <a:lstStyle xmlns:a="http://schemas.openxmlformats.org/drawingml/2006/main">
-            <a:defPPr>
-              <a:defRPr sz="2025" b="0">
-                <a:solidFill>
-                  <a:srgbClr val="F4F6FA"/>
-                </a:solidFill>
-                <a:latin typeface="DejaVu Sans"/>
-                <a:ea typeface="DejaVu Sans"/>
-                <a:cs typeface="DejaVu Sans"/>
-              </a:defRPr>
-            </a:defPPr>
-            <a:lvl1pPr>
-              <a:defRPr sz="2025" b="0">
-                <a:solidFill>
-                  <a:srgbClr val="F4F6FA"/>
-                </a:solidFill>
-                <a:latin typeface="DejaVu Sans"/>
-                <a:ea typeface="DejaVu Sans"/>
-                <a:cs typeface="DejaVu Sans"/>
-              </a:defRPr>
-            </a:lvl1pPr>
-            <a:lvl2pPr>
-              <a:defRPr sz="2025" b="0">
-                <a:solidFill>
-                  <a:srgbClr val="F4F6FA"/>
-                </a:solidFill>
-                <a:latin typeface="DejaVu Sans"/>
-                <a:ea typeface="DejaVu Sans"/>
-                <a:cs typeface="DejaVu Sans"/>
-              </a:defRPr>
-            </a:lvl2pPr>
-            <a:lvl3pPr>
-              <a:defRPr sz="2025" b="0">
-                <a:solidFill>
-                  <a:srgbClr val="F4F6FA"/>
-                </a:solidFill>
-                <a:latin typeface="DejaVu Sans"/>
-                <a:ea typeface="DejaVu Sans"/>
-                <a:cs typeface="DejaVu Sans"/>
-              </a:defRPr>
-            </a:lvl3pPr>
-            <a:lvl4pPr>
-              <a:defRPr sz="2025" b="0">
-                <a:solidFill>
-                  <a:srgbClr val="F4F6FA"/>
-                </a:solidFill>
-                <a:latin typeface="DejaVu Sans"/>
-                <a:ea typeface="DejaVu Sans"/>
-                <a:cs typeface="DejaVu Sans"/>
-              </a:defRPr>
-            </a:lvl4pPr>
-            <a:lvl5pPr>
-              <a:defRPr sz="2025" b="0">
-                <a:solidFill>
-                  <a:srgbClr val="F4F6FA"/>
-                </a:solidFill>
-                <a:latin typeface="DejaVu Sans"/>
-                <a:ea typeface="DejaVu Sans"/>
-                <a:cs typeface="DejaVu Sans"/>
-              </a:defRPr>
-            </a:lvl5pPr>
-            <a:lvl6pPr>
-              <a:defRPr sz="2025" b="0">
-                <a:solidFill>
-                  <a:srgbClr val="F4F6FA"/>
-                </a:solidFill>
-                <a:latin typeface="DejaVu Sans"/>
-                <a:ea typeface="DejaVu Sans"/>
-                <a:cs typeface="DejaVu Sans"/>
-              </a:defRPr>
-            </a:lvl6pPr>
-            <a:lvl7pPr>
-              <a:defRPr sz="2025" b="0">
-                <a:solidFill>
-                  <a:srgbClr val="F4F6FA"/>
-                </a:solidFill>
-                <a:latin typeface="DejaVu Sans"/>
-                <a:ea typeface="DejaVu Sans"/>
-                <a:cs typeface="DejaVu Sans"/>
-              </a:defRPr>
-            </a:lvl7pPr>
-            <a:lvl8pPr>
-              <a:defRPr sz="2025" b="0">
-                <a:solidFill>
-                  <a:srgbClr val="F4F6FA"/>
-                </a:solidFill>
-                <a:latin typeface="DejaVu Sans"/>
-                <a:ea typeface="DejaVu Sans"/>
-                <a:cs typeface="DejaVu Sans"/>
-              </a:defRPr>
-            </a:lvl8pPr>
-            <a:lvl9pPr>
-              <a:defRPr sz="2025" b="0">
-                <a:solidFill>
-                  <a:srgbClr val="F4F6FA"/>
-                </a:solidFill>
-                <a:latin typeface="DejaVu Sans"/>
-                <a:ea typeface="DejaVu Sans"/>
-                <a:cs typeface="DejaVu Sans"/>
-              </a:defRPr>
-            </a:lvl9pPr>
-          </a:lstStyle>
-          <a:p xmlns:a="http://schemas.openxmlformats.org/drawingml/2006/main">
-            <a:pPr>
-              <a:defRPr sz="2025" b="0">
-                <a:solidFill>
-                  <a:srgbClr val="F4F6FA"/>
-                </a:solidFill>
-                <a:latin typeface="DejaVu Sans"/>
-                <a:ea typeface="DejaVu Sans"/>
-                <a:cs typeface="DejaVu Sans"/>
-              </a:defRPr>
-            </a:pPr>
-            <a:r>
-              <a:rPr sz="2025" b="0">
-                <a:solidFill>
-                  <a:srgbClr val="F4F6FA"/>
-                </a:solidFill>
-                <a:latin typeface="DejaVu Sans"/>
-                <a:ea typeface="DejaVu Sans"/>
-                <a:cs typeface="DejaVu Sans"/>
-              </a:rPr>
-              <a:t>Shortest-path routing and responder/admin changes:</a:t>
-            </a:r>
-          </a:p>
-        </p:txBody>
-      </p:sp>
-      <p:sp>
-        <p:nvSpPr>
-          <p:cNvPr id="6" name="">
-            <a:extLst xmlns:a="http://schemas.openxmlformats.org/drawingml/2006/main">
-              <a:ext uri="{FF2B5EF4-FFF2-40B4-BE49-F238E27FC236}">
-                <a16:creationId xmlns:a16="http://schemas.microsoft.com/office/drawing/2014/main" id="{EEB83203-678F-4E32-8CEE-6B7DA22CF1B6}"/>
-              </a:ext>
-            </a:extLst>
-          </p:cNvPr>
-          <p:cNvSpPr>
-            <a:spLocks xmlns:a="http://schemas.openxmlformats.org/drawingml/2006/main" noGrp="1"/>
-          </p:cNvSpPr>
-          <p:nvPr/>
-        </p:nvSpPr>
-        <p:spPr>
-          <a:xfrm xmlns:a="http://schemas.openxmlformats.org/drawingml/2006/main">
-            <a:off x="619125" y="4810125"/>
-            <a:ext cx="10477500" cy="619125"/>
-          </a:xfrm>
-          <a:prstGeom xmlns:a="http://schemas.openxmlformats.org/drawingml/2006/main" prst="rect">
-            <a:avLst/>
-          </a:prstGeom>
-          <a:noFill xmlns:a="http://schemas.openxmlformats.org/drawingml/2006/main"/>
-          <a:ln xmlns:a="http://schemas.openxmlformats.org/drawingml/2006/main" w="0">
-            <a:noFill/>
-            <a:prstDash val="solid"/>
-          </a:ln>
-        </p:spPr>
-        <p:txBody>
-          <a:bodyPr xmlns:a="http://schemas.openxmlformats.org/drawingml/2006/main"/>
-          <a:lstStyle xmlns:a="http://schemas.openxmlformats.org/drawingml/2006/main">
-            <a:defPPr>
-              <a:defRPr sz="2100" b="0">
-                <a:solidFill>
-                  <a:srgbClr val="B6C0D1"/>
-                </a:solidFill>
-                <a:latin typeface="DejaVu Sans"/>
-                <a:ea typeface="DejaVu Sans"/>
-                <a:cs typeface="DejaVu Sans"/>
-              </a:defRPr>
-            </a:defPPr>
-            <a:lvl1pPr>
-              <a:defRPr sz="2100" b="0">
-                <a:solidFill>
-                  <a:srgbClr val="B6C0D1"/>
-                </a:solidFill>
-                <a:latin typeface="DejaVu Sans"/>
-                <a:ea typeface="DejaVu Sans"/>
-                <a:cs typeface="DejaVu Sans"/>
-              </a:defRPr>
-            </a:lvl1pPr>
-            <a:lvl2pPr>
-              <a:defRPr sz="2100" b="0">
-                <a:solidFill>
-                  <a:srgbClr val="B6C0D1"/>
-                </a:solidFill>
-                <a:latin typeface="DejaVu Sans"/>
-                <a:ea typeface="DejaVu Sans"/>
-                <a:cs typeface="DejaVu Sans"/>
-              </a:defRPr>
-            </a:lvl2pPr>
-            <a:lvl3pPr>
-              <a:defRPr sz="2100" b="0">
-                <a:solidFill>
-                  <a:srgbClr val="B6C0D1"/>
-                </a:solidFill>
-                <a:latin typeface="DejaVu Sans"/>
-                <a:ea typeface="DejaVu Sans"/>
-                <a:cs typeface="DejaVu Sans"/>
-              </a:defRPr>
-            </a:lvl3pPr>
-            <a:lvl4pPr>
-              <a:defRPr sz="2100" b="0">
-                <a:solidFill>
-                  <a:srgbClr val="B6C0D1"/>
-                </a:solidFill>
-                <a:latin typeface="DejaVu Sans"/>
-                <a:ea typeface="DejaVu Sans"/>
-                <a:cs typeface="DejaVu Sans"/>
-              </a:defRPr>
-            </a:lvl4pPr>
-            <a:lvl5pPr>
-              <a:defRPr sz="2100" b="0">
-                <a:solidFill>
-                  <a:srgbClr val="B6C0D1"/>
-                </a:solidFill>
-                <a:latin typeface="DejaVu Sans"/>
-                <a:ea typeface="DejaVu Sans"/>
-                <a:cs typeface="DejaVu Sans"/>
-              </a:defRPr>
-            </a:lvl5pPr>
-            <a:lvl6pPr>
-              <a:defRPr sz="2100" b="0">
-                <a:solidFill>
-                  <a:srgbClr val="B6C0D1"/>
-                </a:solidFill>
-                <a:latin typeface="DejaVu Sans"/>
-                <a:ea typeface="DejaVu Sans"/>
-                <a:cs typeface="DejaVu Sans"/>
-              </a:defRPr>
-            </a:lvl6pPr>
-            <a:lvl7pPr>
-              <a:defRPr sz="2100" b="0">
-                <a:solidFill>
-                  <a:srgbClr val="B6C0D1"/>
-                </a:solidFill>
-                <a:latin typeface="DejaVu Sans"/>
-                <a:ea typeface="DejaVu Sans"/>
-                <a:cs typeface="DejaVu Sans"/>
-              </a:defRPr>
-            </a:lvl7pPr>
-            <a:lvl8pPr>
-              <a:defRPr sz="2100" b="0">
-                <a:solidFill>
-                  <a:srgbClr val="B6C0D1"/>
-                </a:solidFill>
-                <a:latin typeface="DejaVu Sans"/>
-                <a:ea typeface="DejaVu Sans"/>
-                <a:cs typeface="DejaVu Sans"/>
-              </a:defRPr>
-            </a:lvl8pPr>
-            <a:lvl9pPr>
-              <a:defRPr sz="2100" b="0">
-                <a:solidFill>
-                  <a:srgbClr val="B6C0D1"/>
-                </a:solidFill>
-                <a:latin typeface="DejaVu Sans"/>
-                <a:ea typeface="DejaVu Sans"/>
-                <a:cs typeface="DejaVu Sans"/>
-              </a:defRPr>
-            </a:lvl9pPr>
-          </a:lstStyle>
-          <a:p xmlns:a="http://schemas.openxmlformats.org/drawingml/2006/main">
-            <a:pPr>
-              <a:defRPr sz="2100" b="0">
-                <a:solidFill>
-                  <a:srgbClr val="B6C0D1"/>
-                </a:solidFill>
-                <a:latin typeface="DejaVu Sans"/>
-                <a:ea typeface="DejaVu Sans"/>
-                <a:cs typeface="DejaVu Sans"/>
-              </a:defRPr>
-            </a:pPr>
-            <a:r>
-              <a:rPr sz="2100" b="0">
-                <a:solidFill>
-                  <a:srgbClr val="B6C0D1"/>
-                </a:solidFill>
-                <a:latin typeface="DejaVu Sans"/>
-                <a:ea typeface="DejaVu Sans"/>
-                <a:cs typeface="DejaVu Sans"/>
-              </a:rPr>
-              <a:t>Pending final merge and phone recheck.</a:t>
-            </a:r>
-          </a:p>
-        </p:txBody>
-      </p:sp>
+        </p:nvGraphicFramePr>
+        <p:xfrm>
+          <a:off xmlns:a="http://schemas.openxmlformats.org/drawingml/2006/main" x="619125" y="1666875"/>
+          <a:ext xmlns:a="http://schemas.openxmlformats.org/drawingml/2006/main" cx="10906125" cy="4524375"/>
+        </p:xfrm>
+        <a:graphic xmlns:a="http://schemas.openxmlformats.org/drawingml/2006/main">
+          <a:graphicData uri="http://schemas.openxmlformats.org/drawingml/2006/table">
+            <a:tbl>
+              <a:tblPr/>
+              <a:tblGrid>
+                <a:gridCol w="3333750"/>
+                <a:gridCol w="7572375"/>
+              </a:tblGrid>
+              <a:tr h="754063">
+                <a:tc>
+                  <a:txBody>
+                    <a:bodyPr/>
+                    <a:lstStyle/>
+                    <a:p>
+                      <a:r>
+                        <a:rPr sz="1350" b="1">
+                          <a:solidFill>
+                            <a:srgbClr val="F4F6FA"/>
+                          </a:solidFill>
+                          <a:latin typeface="DejaVu Sans"/>
+                          <a:ea typeface="DejaVu Sans"/>
+                          <a:cs typeface="DejaVu Sans"/>
+                        </a:rPr>
+                        <a:t>Mentor question</a:t>
+                      </a:r>
+                    </a:p>
+                  </a:txBody>
+                  <a:tcPr marL="91440" marR="91440" marT="45720" marB="45720">
+                    <a:lnL w="9525">
+                      <a:solidFill>
+                        <a:srgbClr val="546174"/>
+                      </a:solidFill>
+                      <a:prstDash val="solid"/>
+                    </a:lnL>
+                    <a:lnR w="9525">
+                      <a:solidFill>
+                        <a:srgbClr val="546174"/>
+                      </a:solidFill>
+                      <a:prstDash val="solid"/>
+                    </a:lnR>
+                    <a:lnT w="9525">
+                      <a:solidFill>
+                        <a:srgbClr val="546174"/>
+                      </a:solidFill>
+                      <a:prstDash val="solid"/>
+                    </a:lnT>
+                    <a:lnB w="9525">
+                      <a:solidFill>
+                        <a:srgbClr val="546174"/>
+                      </a:solidFill>
+                      <a:prstDash val="solid"/>
+                    </a:lnB>
+                    <a:solidFill>
+                      <a:srgbClr val="23405B"/>
+                    </a:solidFill>
+                  </a:tcPr>
+                </a:tc>
+                <a:tc>
+                  <a:txBody>
+                    <a:bodyPr/>
+                    <a:lstStyle/>
+                    <a:p>
+                      <a:r>
+                        <a:rPr sz="1350" b="1">
+                          <a:solidFill>
+                            <a:srgbClr val="F4F6FA"/>
+                          </a:solidFill>
+                          <a:latin typeface="DejaVu Sans"/>
+                          <a:ea typeface="DejaVu Sans"/>
+                          <a:cs typeface="DejaVu Sans"/>
+                        </a:rPr>
+                        <a:t>What we did</a:t>
+                      </a:r>
+                    </a:p>
+                  </a:txBody>
+                  <a:tcPr marL="91440" marR="91440" marT="45720" marB="45720">
+                    <a:lnR w="9525">
+                      <a:solidFill>
+                        <a:srgbClr val="546174"/>
+                      </a:solidFill>
+                      <a:prstDash val="solid"/>
+                    </a:lnR>
+                    <a:lnT w="9525">
+                      <a:solidFill>
+                        <a:srgbClr val="546174"/>
+                      </a:solidFill>
+                      <a:prstDash val="solid"/>
+                    </a:lnT>
+                    <a:lnB w="9525">
+                      <a:solidFill>
+                        <a:srgbClr val="546174"/>
+                      </a:solidFill>
+                      <a:prstDash val="solid"/>
+                    </a:lnB>
+                    <a:solidFill>
+                      <a:srgbClr val="23405B"/>
+                    </a:solidFill>
+                  </a:tcPr>
+                </a:tc>
+              </a:tr>
+              <a:tr h="754063">
+                <a:tc>
+                  <a:txBody>
+                    <a:bodyPr/>
+                    <a:lstStyle/>
+                    <a:p>
+                      <a:r>
+                        <a:rPr sz="1275" b="0">
+                          <a:solidFill>
+                            <a:srgbClr val="F4F6FA"/>
+                          </a:solidFill>
+                          <a:latin typeface="DejaVu Sans"/>
+                          <a:ea typeface="DejaVu Sans"/>
+                          <a:cs typeface="DejaVu Sans"/>
+                        </a:rPr>
+                        <a:t>1,000 phones: shortest path?</a:t>
+                      </a:r>
+                    </a:p>
+                  </a:txBody>
+                  <a:tcPr marL="91440" marR="91440" marT="45720" marB="45720">
+                    <a:lnL w="9525">
+                      <a:solidFill>
+                        <a:srgbClr val="546174"/>
+                      </a:solidFill>
+                      <a:prstDash val="solid"/>
+                    </a:lnL>
+                    <a:lnR w="9525">
+                      <a:solidFill>
+                        <a:srgbClr val="546174"/>
+                      </a:solidFill>
+                      <a:prstDash val="solid"/>
+                    </a:lnR>
+                    <a:lnB w="9525">
+                      <a:solidFill>
+                        <a:srgbClr val="546174"/>
+                      </a:solidFill>
+                      <a:prstDash val="solid"/>
+                    </a:lnB>
+                    <a:solidFill>
+                      <a:srgbClr val="182943"/>
+                    </a:solidFill>
+                  </a:tcPr>
+                </a:tc>
+                <a:tc>
+                  <a:txBody>
+                    <a:bodyPr/>
+                    <a:lstStyle/>
+                    <a:p>
+                      <a:r>
+                        <a:rPr sz="1275" b="0">
+                          <a:solidFill>
+                            <a:srgbClr val="F4F6FA"/>
+                          </a:solidFill>
+                          <a:latin typeface="DejaVu Sans"/>
+                          <a:ea typeface="DejaVu Sans"/>
+                          <a:cs typeface="DejaVu Sans"/>
+                        </a:rPr>
+                        <a:t>Verified traffic teaches fewest-hop routes. After 8 seconds other paths open. Routes expire in 5 minutes or on disconnect. SOS and area alerts flood. Tested on 3 real and 5 simulated phones.</a:t>
+                      </a:r>
+                    </a:p>
+                  </a:txBody>
+                  <a:tcPr marL="91440" marR="91440" marT="45720" marB="45720">
+                    <a:lnR w="9525">
+                      <a:solidFill>
+                        <a:srgbClr val="546174"/>
+                      </a:solidFill>
+                      <a:prstDash val="solid"/>
+                    </a:lnR>
+                    <a:lnB w="9525">
+                      <a:solidFill>
+                        <a:srgbClr val="546174"/>
+                      </a:solidFill>
+                      <a:prstDash val="solid"/>
+                    </a:lnB>
+                    <a:solidFill>
+                      <a:srgbClr val="182943"/>
+                    </a:solidFill>
+                  </a:tcPr>
+                </a:tc>
+              </a:tr>
+              <a:tr h="754063">
+                <a:tc>
+                  <a:txBody>
+                    <a:bodyPr/>
+                    <a:lstStyle/>
+                    <a:p>
+                      <a:r>
+                        <a:rPr sz="1275" b="0">
+                          <a:solidFill>
+                            <a:srgbClr val="F4F6FA"/>
+                          </a:solidFill>
+                          <a:latin typeface="DejaVu Sans"/>
+                          <a:ea typeface="DejaVu Sans"/>
+                          <a:cs typeface="DejaVu Sans"/>
+                        </a:rPr>
+                        <a:t>Three logins?</a:t>
+                      </a:r>
+                    </a:p>
+                  </a:txBody>
+                  <a:tcPr marL="91440" marR="91440" marT="45720" marB="45720">
+                    <a:lnL w="9525">
+                      <a:solidFill>
+                        <a:srgbClr val="546174"/>
+                      </a:solidFill>
+                      <a:prstDash val="solid"/>
+                    </a:lnL>
+                    <a:lnR w="9525">
+                      <a:solidFill>
+                        <a:srgbClr val="546174"/>
+                      </a:solidFill>
+                      <a:prstDash val="solid"/>
+                    </a:lnR>
+                    <a:lnB w="9525">
+                      <a:solidFill>
+                        <a:srgbClr val="546174"/>
+                      </a:solidFill>
+                      <a:prstDash val="solid"/>
+                    </a:lnB>
+                    <a:solidFill>
+                      <a:srgbClr val="142139"/>
+                    </a:solidFill>
+                  </a:tcPr>
+                </a:tc>
+                <a:tc>
+                  <a:txBody>
+                    <a:bodyPr/>
+                    <a:lstStyle/>
+                    <a:p>
+                      <a:r>
+                        <a:rPr sz="1275" b="0">
+                          <a:solidFill>
+                            <a:srgbClr val="F4F6FA"/>
+                          </a:solidFill>
+                          <a:latin typeface="DejaVu Sans"/>
+                          <a:ea typeface="DejaVu Sans"/>
+                          <a:cs typeface="DejaVu Sans"/>
+                        </a:rPr>
+                        <a:t>User, Responder and Admin work offline. The app stores public keys only.</a:t>
+                      </a:r>
+                    </a:p>
+                  </a:txBody>
+                  <a:tcPr marL="91440" marR="91440" marT="45720" marB="45720">
+                    <a:lnR w="9525">
+                      <a:solidFill>
+                        <a:srgbClr val="546174"/>
+                      </a:solidFill>
+                      <a:prstDash val="solid"/>
+                    </a:lnR>
+                    <a:lnB w="9525">
+                      <a:solidFill>
+                        <a:srgbClr val="546174"/>
+                      </a:solidFill>
+                      <a:prstDash val="solid"/>
+                    </a:lnB>
+                    <a:solidFill>
+                      <a:srgbClr val="142139"/>
+                    </a:solidFill>
+                  </a:tcPr>
+                </a:tc>
+              </a:tr>
+              <a:tr h="754063">
+                <a:tc>
+                  <a:txBody>
+                    <a:bodyPr/>
+                    <a:lstStyle/>
+                    <a:p>
+                      <a:r>
+                        <a:rPr sz="1275" b="0">
+                          <a:solidFill>
+                            <a:srgbClr val="F4F6FA"/>
+                          </a:solidFill>
+                          <a:latin typeface="DejaVu Sans"/>
+                          <a:ea typeface="DejaVu Sans"/>
+                          <a:cs typeface="DejaVu Sans"/>
+                        </a:rPr>
+                        <a:t>How is hopping different?</a:t>
+                      </a:r>
+                    </a:p>
+                  </a:txBody>
+                  <a:tcPr marL="91440" marR="91440" marT="45720" marB="45720">
+                    <a:lnL w="9525">
+                      <a:solidFill>
+                        <a:srgbClr val="546174"/>
+                      </a:solidFill>
+                      <a:prstDash val="solid"/>
+                    </a:lnL>
+                    <a:lnR w="9525">
+                      <a:solidFill>
+                        <a:srgbClr val="546174"/>
+                      </a:solidFill>
+                      <a:prstDash val="solid"/>
+                    </a:lnR>
+                    <a:lnB w="9525">
+                      <a:solidFill>
+                        <a:srgbClr val="546174"/>
+                      </a:solidFill>
+                      <a:prstDash val="solid"/>
+                    </a:lnB>
+                    <a:solidFill>
+                      <a:srgbClr val="182943"/>
+                    </a:solidFill>
+                  </a:tcPr>
+                </a:tc>
+                <a:tc>
+                  <a:txBody>
+                    <a:bodyPr/>
+                    <a:lstStyle/>
+                    <a:p>
+                      <a:r>
+                        <a:rPr sz="1275" b="0">
+                          <a:solidFill>
+                            <a:srgbClr val="F4F6FA"/>
+                          </a:solidFill>
+                          <a:latin typeface="DejaVu Sans"/>
+                          <a:ea typeface="DejaVu Sans"/>
+                          <a:cs typeface="DejaVu Sans"/>
+                        </a:rPr>
+                        <a:t>Call-Out, Talk-Back, Last Breath and no-app SOS intake help people beyond the app flow. A laptop node carries packets.</a:t>
+                      </a:r>
+                    </a:p>
+                  </a:txBody>
+                  <a:tcPr marL="91440" marR="91440" marT="45720" marB="45720">
+                    <a:lnR w="9525">
+                      <a:solidFill>
+                        <a:srgbClr val="546174"/>
+                      </a:solidFill>
+                      <a:prstDash val="solid"/>
+                    </a:lnR>
+                    <a:lnB w="9525">
+                      <a:solidFill>
+                        <a:srgbClr val="546174"/>
+                      </a:solidFill>
+                      <a:prstDash val="solid"/>
+                    </a:lnB>
+                    <a:solidFill>
+                      <a:srgbClr val="182943"/>
+                    </a:solidFill>
+                  </a:tcPr>
+                </a:tc>
+              </a:tr>
+              <a:tr h="754063">
+                <a:tc>
+                  <a:txBody>
+                    <a:bodyPr/>
+                    <a:lstStyle/>
+                    <a:p>
+                      <a:r>
+                        <a:rPr sz="1275" b="0">
+                          <a:solidFill>
+                            <a:srgbClr val="F4F6FA"/>
+                          </a:solidFill>
+                          <a:latin typeface="DejaVu Sans"/>
+                          <a:ea typeface="DejaVu Sans"/>
+                          <a:cs typeface="DejaVu Sans"/>
+                        </a:rPr>
+                        <a:t>How does admin locate help?</a:t>
+                      </a:r>
+                    </a:p>
+                  </a:txBody>
+                  <a:tcPr marL="91440" marR="91440" marT="45720" marB="45720">
+                    <a:lnL w="9525">
+                      <a:solidFill>
+                        <a:srgbClr val="546174"/>
+                      </a:solidFill>
+                      <a:prstDash val="solid"/>
+                    </a:lnL>
+                    <a:lnR w="9525">
+                      <a:solidFill>
+                        <a:srgbClr val="546174"/>
+                      </a:solidFill>
+                      <a:prstDash val="solid"/>
+                    </a:lnR>
+                    <a:lnB w="9525">
+                      <a:solidFill>
+                        <a:srgbClr val="546174"/>
+                      </a:solidFill>
+                      <a:prstDash val="solid"/>
+                    </a:lnB>
+                    <a:solidFill>
+                      <a:srgbClr val="142139"/>
+                    </a:solidFill>
+                  </a:tcPr>
+                </a:tc>
+                <a:tc>
+                  <a:txBody>
+                    <a:bodyPr/>
+                    <a:lstStyle/>
+                    <a:p>
+                      <a:r>
+                        <a:rPr sz="1275" b="0">
+                          <a:solidFill>
+                            <a:srgbClr val="F4F6FA"/>
+                          </a:solidFill>
+                          <a:latin typeface="DejaVu Sans"/>
+                          <a:ea typeface="DejaVu Sans"/>
+                          <a:cs typeface="DejaVu Sans"/>
+                        </a:rPr>
+                        <a:t>SOS distance and direction show on the admin phone without maps or internet.</a:t>
+                      </a:r>
+                    </a:p>
+                  </a:txBody>
+                  <a:tcPr marL="91440" marR="91440" marT="45720" marB="45720">
+                    <a:lnR w="9525">
+                      <a:solidFill>
+                        <a:srgbClr val="546174"/>
+                      </a:solidFill>
+                      <a:prstDash val="solid"/>
+                    </a:lnR>
+                    <a:lnB w="9525">
+                      <a:solidFill>
+                        <a:srgbClr val="546174"/>
+                      </a:solidFill>
+                      <a:prstDash val="solid"/>
+                    </a:lnB>
+                    <a:solidFill>
+                      <a:srgbClr val="142139"/>
+                    </a:solidFill>
+                  </a:tcPr>
+                </a:tc>
+              </a:tr>
+              <a:tr h="754063">
+                <a:tc>
+                  <a:txBody>
+                    <a:bodyPr/>
+                    <a:lstStyle/>
+                    <a:p>
+                      <a:r>
+                        <a:rPr sz="1275" b="0">
+                          <a:solidFill>
+                            <a:srgbClr val="F4F6FA"/>
+                          </a:solidFill>
+                          <a:latin typeface="DejaVu Sans"/>
+                          <a:ea typeface="DejaVu Sans"/>
+                          <a:cs typeface="DejaVu Sans"/>
+                        </a:rPr>
+                        <a:t>Warn only one area?</a:t>
+                      </a:r>
+                    </a:p>
+                  </a:txBody>
+                  <a:tcPr marL="91440" marR="91440" marT="45720" marB="45720">
+                    <a:lnL w="9525">
+                      <a:solidFill>
+                        <a:srgbClr val="546174"/>
+                      </a:solidFill>
+                      <a:prstDash val="solid"/>
+                    </a:lnL>
+                    <a:lnR w="9525">
+                      <a:solidFill>
+                        <a:srgbClr val="546174"/>
+                      </a:solidFill>
+                      <a:prstDash val="solid"/>
+                    </a:lnR>
+                    <a:lnB w="9525">
+                      <a:solidFill>
+                        <a:srgbClr val="546174"/>
+                      </a:solidFill>
+                      <a:prstDash val="solid"/>
+                    </a:lnB>
+                    <a:solidFill>
+                      <a:srgbClr val="182943"/>
+                    </a:solidFill>
+                  </a:tcPr>
+                </a:tc>
+                <a:tc>
+                  <a:txBody>
+                    <a:bodyPr/>
+                    <a:lstStyle/>
+                    <a:p>
+                      <a:r>
+                        <a:rPr sz="1275" b="0">
+                          <a:solidFill>
+                            <a:srgbClr val="F4F6FA"/>
+                          </a:solidFill>
+                          <a:latin typeface="DejaVu Sans"/>
+                          <a:ea typeface="DejaVu Sans"/>
+                          <a:cs typeface="DejaVu Sans"/>
+                        </a:rPr>
+                        <a:t>Every phone relays signed alerts; phones inside show them. Indoor test locations were used.</a:t>
+                      </a:r>
+                    </a:p>
+                  </a:txBody>
+                  <a:tcPr marL="91440" marR="91440" marT="45720" marB="45720">
+                    <a:lnR w="9525">
+                      <a:solidFill>
+                        <a:srgbClr val="546174"/>
+                      </a:solidFill>
+                      <a:prstDash val="solid"/>
+                    </a:lnR>
+                    <a:lnB w="9525">
+                      <a:solidFill>
+                        <a:srgbClr val="546174"/>
+                      </a:solidFill>
+                      <a:prstDash val="solid"/>
+                    </a:lnB>
+                    <a:solidFill>
+                      <a:srgbClr val="182943"/>
+                    </a:solidFill>
+                  </a:tcPr>
+                </a:tc>
+              </a:tr>
+            </a:tbl>
+          </a:graphicData>
+        </a:graphic>
+      </p:graphicFrame>
     </p:spTree>
     <p:extLst>
       <p:ext uri="{BB962C8B-B14F-4D97-AF65-F5344CB8AC3E}">
-        <p14:creationId xmlns:p14="http://schemas.microsoft.com/office/powerpoint/2010/main" val="142731531"/>
+        <p14:creationId xmlns:p14="http://schemas.microsoft.com/office/powerpoint/2010/main" val="1034682430"/>
       </p:ext>
     </p:extLst>
   </p:cSld>

</xml_diff>

<commit_message>
docs: link encrypted phone test and clarify security limits
</commit_message>
<xml_diff>
--- a/docs/TEAM30_SUBMISSION.pptx
+++ b/docs/TEAM30_SUBMISSION.pptx
@@ -2,18 +2,18 @@
 <file path=ppt/presentation.xml><?xml version="1.0" encoding="utf-8"?>
 <p:presentation xmlns:p="http://schemas.openxmlformats.org/presentationml/2006/main">
   <p:sldMasterIdLst>
-    <p:sldMasterId xmlns:r="http://schemas.openxmlformats.org/officeDocument/2006/relationships" id="2147483648" r:id="Rd03ec769591b401e"/>
+    <p:sldMasterId xmlns:r="http://schemas.openxmlformats.org/officeDocument/2006/relationships" id="2147483648" r:id="R43520aecf4a34057"/>
   </p:sldMasterIdLst>
   <p:notesMasterIdLst>
-    <p:notesMasterId xmlns:r="http://schemas.openxmlformats.org/officeDocument/2006/relationships" r:id="Rbe105a4c4b0343b5"/>
+    <p:notesMasterId xmlns:r="http://schemas.openxmlformats.org/officeDocument/2006/relationships" r:id="R9abec4f74a03475a"/>
   </p:notesMasterIdLst>
   <p:sldIdLst>
-    <p:sldId xmlns:r="http://schemas.openxmlformats.org/officeDocument/2006/relationships" id="256" r:id="Rfaca620380bf4ccf"/>
-    <p:sldId xmlns:r="http://schemas.openxmlformats.org/officeDocument/2006/relationships" id="257" r:id="R6bac2286ef3845b6"/>
-    <p:sldId xmlns:r="http://schemas.openxmlformats.org/officeDocument/2006/relationships" id="258" r:id="R22a57be18632484b"/>
-    <p:sldId xmlns:r="http://schemas.openxmlformats.org/officeDocument/2006/relationships" id="259" r:id="R8eaffb0886a2492b"/>
-    <p:sldId xmlns:r="http://schemas.openxmlformats.org/officeDocument/2006/relationships" id="260" r:id="R6f7fc07e68144ba0"/>
-    <p:sldId xmlns:r="http://schemas.openxmlformats.org/officeDocument/2006/relationships" id="261" r:id="R97b173afa08c471f"/>
+    <p:sldId xmlns:r="http://schemas.openxmlformats.org/officeDocument/2006/relationships" id="256" r:id="R5dac7ad362584b96"/>
+    <p:sldId xmlns:r="http://schemas.openxmlformats.org/officeDocument/2006/relationships" id="257" r:id="Rdffd922a813e4f21"/>
+    <p:sldId xmlns:r="http://schemas.openxmlformats.org/officeDocument/2006/relationships" id="258" r:id="Rc2e8e641afa749d4"/>
+    <p:sldId xmlns:r="http://schemas.openxmlformats.org/officeDocument/2006/relationships" id="259" r:id="Rd4a5bb3633e240c6"/>
+    <p:sldId xmlns:r="http://schemas.openxmlformats.org/officeDocument/2006/relationships" id="260" r:id="R66c97c99d4e5470b"/>
+    <p:sldId xmlns:r="http://schemas.openxmlformats.org/officeDocument/2006/relationships" id="261" r:id="Ra63e64ea64a54a7e"/>
   </p:sldIdLst>
   <p:sldSz cx="12192000" cy="6858000"/>
   <p:notesSz cx="6858000" cy="9144000"/>
@@ -727,7 +727,7 @@
           <a:lstStyle xmlns:a="http://schemas.openxmlformats.org/drawingml/2006/main"/>
           <a:p xmlns:a="http://schemas.openxmlformats.org/drawingml/2006/main">
             <a:r>
-              <a:t>Source: docs/evidence/extras-phone-test.md and final-build.md. Battery and range may be updated if later evidence is measured. Laptop and dashboard were over USB adb reverse. A had internet in extras run. No real AI key.</a:t>
+              <a:t>Sources: docs/evidence/extras-phone-test.md, final-build.md and tink-security.md. Battery and range remain unmeasured. Laptop and dashboard used USB adb reverse. A had internet in the extras run. No real AI key. SOS can be read by group-code holders; no forward secrecy or independent review.</a:t>
             </a:r>
           </a:p>
         </p:txBody>
@@ -844,7 +844,7 @@
           <p:cNvPr id="3" name="Title">
             <a:extLst xmlns:a="http://schemas.openxmlformats.org/drawingml/2006/main">
               <a:ext uri="{FF2B5EF4-FFF2-40B4-BE49-F238E27FC236}">
-                <a16:creationId xmlns:a16="http://schemas.microsoft.com/office/drawing/2014/main" id="{7B12A351-C688-4339-8457-203E08F113A6}"/>
+                <a16:creationId xmlns:a16="http://schemas.microsoft.com/office/drawing/2014/main" id="{482EDBB0-0FD2-49CE-90A7-A548DD834E05}"/>
               </a:ext>
             </a:extLst>
           </p:cNvPr>
@@ -1073,7 +1073,7 @@
           <p:cNvPr id="2" name="Subtitle">
             <a:extLst xmlns:a="http://schemas.openxmlformats.org/drawingml/2006/main">
               <a:ext uri="{FF2B5EF4-FFF2-40B4-BE49-F238E27FC236}">
-                <a16:creationId xmlns:a16="http://schemas.microsoft.com/office/drawing/2014/main" id="{E78040B8-124A-430F-B08F-817159A77FEB}"/>
+                <a16:creationId xmlns:a16="http://schemas.microsoft.com/office/drawing/2014/main" id="{3212C7CC-7EB5-4D10-97D9-3CD9888AA635}"/>
               </a:ext>
             </a:extLst>
           </p:cNvPr>
@@ -1319,7 +1319,7 @@
           <p:cNvPr id="2" name="Section title">
             <a:extLst xmlns:a="http://schemas.openxmlformats.org/drawingml/2006/main">
               <a:ext uri="{FF2B5EF4-FFF2-40B4-BE49-F238E27FC236}">
-                <a16:creationId xmlns:a16="http://schemas.microsoft.com/office/drawing/2014/main" id="{BD6E12A2-C405-40DA-9E3B-0509502A9508}"/>
+                <a16:creationId xmlns:a16="http://schemas.microsoft.com/office/drawing/2014/main" id="{65F1D2E6-A04C-4D79-8F7A-6445C548F830}"/>
               </a:ext>
             </a:extLst>
           </p:cNvPr>
@@ -1565,7 +1565,7 @@
           <p:cNvPr id="3" name="Title">
             <a:extLst xmlns:a="http://schemas.openxmlformats.org/drawingml/2006/main">
               <a:ext uri="{FF2B5EF4-FFF2-40B4-BE49-F238E27FC236}">
-                <a16:creationId xmlns:a16="http://schemas.microsoft.com/office/drawing/2014/main" id="{19EA0527-902F-45D8-A97A-2A0EB78BF83D}"/>
+                <a16:creationId xmlns:a16="http://schemas.microsoft.com/office/drawing/2014/main" id="{35AD4B2D-26D0-473D-A72A-D08BC9F8FF62}"/>
               </a:ext>
             </a:extLst>
           </p:cNvPr>
@@ -1794,7 +1794,7 @@
           <p:cNvPr id="2" name="Body">
             <a:extLst xmlns:a="http://schemas.openxmlformats.org/drawingml/2006/main">
               <a:ext uri="{FF2B5EF4-FFF2-40B4-BE49-F238E27FC236}">
-                <a16:creationId xmlns:a16="http://schemas.microsoft.com/office/drawing/2014/main" id="{8C246976-C6A1-4EAC-AE89-15A9457C803D}"/>
+                <a16:creationId xmlns:a16="http://schemas.microsoft.com/office/drawing/2014/main" id="{828CC51C-6981-4B36-8F5A-2ADEC7C279BA}"/>
               </a:ext>
             </a:extLst>
           </p:cNvPr>
@@ -2040,7 +2040,7 @@
           <p:cNvPr id="4" name="Title">
             <a:extLst xmlns:a="http://schemas.openxmlformats.org/drawingml/2006/main">
               <a:ext uri="{FF2B5EF4-FFF2-40B4-BE49-F238E27FC236}">
-                <a16:creationId xmlns:a16="http://schemas.microsoft.com/office/drawing/2014/main" id="{469718CA-3FBE-4EDD-B43D-A280894326EB}"/>
+                <a16:creationId xmlns:a16="http://schemas.microsoft.com/office/drawing/2014/main" id="{64613EA8-08A6-4BAC-BEBA-08B40330A133}"/>
               </a:ext>
             </a:extLst>
           </p:cNvPr>
@@ -2269,7 +2269,7 @@
           <p:cNvPr id="2" name="Left column">
             <a:extLst xmlns:a="http://schemas.openxmlformats.org/drawingml/2006/main">
               <a:ext uri="{FF2B5EF4-FFF2-40B4-BE49-F238E27FC236}">
-                <a16:creationId xmlns:a16="http://schemas.microsoft.com/office/drawing/2014/main" id="{7405A5DD-F2AC-4F00-9C7F-E1FB5CEE7E3D}"/>
+                <a16:creationId xmlns:a16="http://schemas.microsoft.com/office/drawing/2014/main" id="{67DCE431-9A52-4A28-A9F6-37E0E166F5CD}"/>
               </a:ext>
             </a:extLst>
           </p:cNvPr>
@@ -2498,7 +2498,7 @@
           <p:cNvPr id="3" name="Right column">
             <a:extLst xmlns:a="http://schemas.openxmlformats.org/drawingml/2006/main">
               <a:ext uri="{FF2B5EF4-FFF2-40B4-BE49-F238E27FC236}">
-                <a16:creationId xmlns:a16="http://schemas.microsoft.com/office/drawing/2014/main" id="{5BED7D0C-0DE2-4C78-BC6C-D1D802233051}"/>
+                <a16:creationId xmlns:a16="http://schemas.microsoft.com/office/drawing/2014/main" id="{22CD948C-52B4-46B2-87EE-46046804C608}"/>
               </a:ext>
             </a:extLst>
           </p:cNvPr>
@@ -2744,7 +2744,7 @@
           <p:cNvPr id="3" name="Title">
             <a:extLst xmlns:a="http://schemas.openxmlformats.org/drawingml/2006/main">
               <a:ext uri="{FF2B5EF4-FFF2-40B4-BE49-F238E27FC236}">
-                <a16:creationId xmlns:a16="http://schemas.microsoft.com/office/drawing/2014/main" id="{C9FFB1B8-0B62-4E25-8FCD-9710697CEFC6}"/>
+                <a16:creationId xmlns:a16="http://schemas.microsoft.com/office/drawing/2014/main" id="{78C9A36C-9626-465F-BB78-C23D633B9E6F}"/>
               </a:ext>
             </a:extLst>
           </p:cNvPr>
@@ -2973,7 +2973,7 @@
           <p:cNvPr id="2" name="Left column">
             <a:extLst xmlns:a="http://schemas.openxmlformats.org/drawingml/2006/main">
               <a:ext uri="{FF2B5EF4-FFF2-40B4-BE49-F238E27FC236}">
-                <a16:creationId xmlns:a16="http://schemas.microsoft.com/office/drawing/2014/main" id="{9E1FF30D-B351-4A6F-BAE8-B8FA735527EB}"/>
+                <a16:creationId xmlns:a16="http://schemas.microsoft.com/office/drawing/2014/main" id="{38C12A52-9C4D-45D5-A210-F46EF3D3FBE4}"/>
               </a:ext>
             </a:extLst>
           </p:cNvPr>
@@ -3240,12 +3240,12 @@
   </p:cSld>
   <p:clrMap bg1="lt1" tx1="dk1" bg2="lt2" tx2="dk2" accent1="accent1" accent2="accent2" accent3="accent3" accent4="accent4" accent5="accent5" accent6="accent6" hlink="hlink" folHlink="folHlink"/>
   <p:sldLayoutIdLst>
-    <p:sldLayoutId xmlns:r="http://schemas.openxmlformats.org/officeDocument/2006/relationships" id="2147483649" r:id="Rdc931311c5b64def"/>
-    <p:sldLayoutId xmlns:r="http://schemas.openxmlformats.org/officeDocument/2006/relationships" id="2147483650" r:id="Rd4cdce5bd51a4fc8"/>
-    <p:sldLayoutId xmlns:r="http://schemas.openxmlformats.org/officeDocument/2006/relationships" id="2147483651" r:id="R278b9e681a7e4b38"/>
-    <p:sldLayoutId xmlns:r="http://schemas.openxmlformats.org/officeDocument/2006/relationships" id="2147483652" r:id="R1b8d9860e31f4a74"/>
-    <p:sldLayoutId xmlns:r="http://schemas.openxmlformats.org/officeDocument/2006/relationships" id="2147483653" r:id="R949ff1d840dc43e3"/>
-    <p:sldLayoutId xmlns:r="http://schemas.openxmlformats.org/officeDocument/2006/relationships" id="2147483654" r:id="R4ffe234de6d74403"/>
+    <p:sldLayoutId xmlns:r="http://schemas.openxmlformats.org/officeDocument/2006/relationships" id="2147483649" r:id="Rf9db5a84fb3748b0"/>
+    <p:sldLayoutId xmlns:r="http://schemas.openxmlformats.org/officeDocument/2006/relationships" id="2147483650" r:id="Ra1981d8d846e4c54"/>
+    <p:sldLayoutId xmlns:r="http://schemas.openxmlformats.org/officeDocument/2006/relationships" id="2147483651" r:id="R270cf1c21cc04a43"/>
+    <p:sldLayoutId xmlns:r="http://schemas.openxmlformats.org/officeDocument/2006/relationships" id="2147483652" r:id="R28156581fcb34c26"/>
+    <p:sldLayoutId xmlns:r="http://schemas.openxmlformats.org/officeDocument/2006/relationships" id="2147483653" r:id="R9a3ca1e5d53a4db9"/>
+    <p:sldLayoutId xmlns:r="http://schemas.openxmlformats.org/officeDocument/2006/relationships" id="2147483654" r:id="R95054885a9eb452e"/>
   </p:sldLayoutIdLst>
   <p:txStyles>
     <p:titleStyle>
@@ -3796,7 +3796,7 @@
           <p:cNvPr id="6" name="">
             <a:extLst xmlns:a="http://schemas.openxmlformats.org/drawingml/2006/main">
               <a:ext uri="{FF2B5EF4-FFF2-40B4-BE49-F238E27FC236}">
-                <a16:creationId xmlns:a16="http://schemas.microsoft.com/office/drawing/2014/main" id="{F058AA9F-CF3B-481F-8178-20A1A44B1310}"/>
+                <a16:creationId xmlns:a16="http://schemas.microsoft.com/office/drawing/2014/main" id="{E3D70645-4D78-4291-B188-96CAF23D6593}"/>
               </a:ext>
             </a:extLst>
           </p:cNvPr>
@@ -3953,7 +3953,7 @@
           <p:cNvPr id="2" name="">
             <a:extLst xmlns:a="http://schemas.openxmlformats.org/drawingml/2006/main">
               <a:ext uri="{FF2B5EF4-FFF2-40B4-BE49-F238E27FC236}">
-                <a16:creationId xmlns:a16="http://schemas.microsoft.com/office/drawing/2014/main" id="{7B91812A-3364-4870-9431-D34284D8AE3E}"/>
+                <a16:creationId xmlns:a16="http://schemas.microsoft.com/office/drawing/2014/main" id="{2AF14A9A-12B6-4D9E-B4B7-E6C6DE0EE753}"/>
               </a:ext>
             </a:extLst>
           </p:cNvPr>
@@ -4110,7 +4110,7 @@
           <p:cNvPr id="3" name="">
             <a:extLst xmlns:a="http://schemas.openxmlformats.org/drawingml/2006/main">
               <a:ext uri="{FF2B5EF4-FFF2-40B4-BE49-F238E27FC236}">
-                <a16:creationId xmlns:a16="http://schemas.microsoft.com/office/drawing/2014/main" id="{85AF7E3B-7034-41DB-AD2C-399627639DC8}"/>
+                <a16:creationId xmlns:a16="http://schemas.microsoft.com/office/drawing/2014/main" id="{FB3234BE-086C-4980-B88C-5EA2B4EFB450}"/>
               </a:ext>
             </a:extLst>
           </p:cNvPr>
@@ -4267,7 +4267,7 @@
           <p:cNvPr id="4" name="">
             <a:extLst xmlns:a="http://schemas.openxmlformats.org/drawingml/2006/main">
               <a:ext uri="{FF2B5EF4-FFF2-40B4-BE49-F238E27FC236}">
-                <a16:creationId xmlns:a16="http://schemas.microsoft.com/office/drawing/2014/main" id="{01B75782-DF73-4B41-9B5F-43EE330DB382}"/>
+                <a16:creationId xmlns:a16="http://schemas.microsoft.com/office/drawing/2014/main" id="{EA9BDD28-01A6-45AF-A599-0DF152EE2BC2}"/>
               </a:ext>
             </a:extLst>
           </p:cNvPr>
@@ -4424,7 +4424,7 @@
           <p:cNvPr id="5" name="">
             <a:extLst xmlns:a="http://schemas.openxmlformats.org/drawingml/2006/main">
               <a:ext uri="{FF2B5EF4-FFF2-40B4-BE49-F238E27FC236}">
-                <a16:creationId xmlns:a16="http://schemas.microsoft.com/office/drawing/2014/main" id="{E40B5309-DDB0-4DBB-B74E-218A46B6A92E}"/>
+                <a16:creationId xmlns:a16="http://schemas.microsoft.com/office/drawing/2014/main" id="{1B767FF1-269E-4BE2-9E60-E243FE6691B0}"/>
               </a:ext>
             </a:extLst>
           </p:cNvPr>
@@ -4579,7 +4579,7 @@
     </p:spTree>
     <p:extLst>
       <p:ext uri="{BB962C8B-B14F-4D97-AF65-F5344CB8AC3E}">
-        <p14:creationId xmlns:p14="http://schemas.microsoft.com/office/powerpoint/2010/main" val="450349545"/>
+        <p14:creationId xmlns:p14="http://schemas.microsoft.com/office/powerpoint/2010/main" val="501261458"/>
       </p:ext>
     </p:extLst>
   </p:cSld>
@@ -4610,7 +4610,7 @@
           <p:cNvPr id="7" name="">
             <a:extLst xmlns:a="http://schemas.openxmlformats.org/drawingml/2006/main">
               <a:ext uri="{FF2B5EF4-FFF2-40B4-BE49-F238E27FC236}">
-                <a16:creationId xmlns:a16="http://schemas.microsoft.com/office/drawing/2014/main" id="{8BC044CE-B01F-42A4-B223-A60F142A25ED}"/>
+                <a16:creationId xmlns:a16="http://schemas.microsoft.com/office/drawing/2014/main" id="{5FCFCFBF-50D0-4CBE-8AEA-2DDDE50F8C53}"/>
               </a:ext>
             </a:extLst>
           </p:cNvPr>
@@ -4767,7 +4767,7 @@
           <p:cNvPr id="2" name="">
             <a:extLst xmlns:a="http://schemas.openxmlformats.org/drawingml/2006/main">
               <a:ext uri="{FF2B5EF4-FFF2-40B4-BE49-F238E27FC236}">
-                <a16:creationId xmlns:a16="http://schemas.microsoft.com/office/drawing/2014/main" id="{5BC86180-E7B2-4C8B-8869-1DC6C0E23B7F}"/>
+                <a16:creationId xmlns:a16="http://schemas.microsoft.com/office/drawing/2014/main" id="{B039DE22-2E0B-4915-86EC-1D09DAF93313}"/>
               </a:ext>
             </a:extLst>
           </p:cNvPr>
@@ -4924,7 +4924,7 @@
           <p:cNvPr id="3" name="">
             <a:extLst xmlns:a="http://schemas.openxmlformats.org/drawingml/2006/main">
               <a:ext uri="{FF2B5EF4-FFF2-40B4-BE49-F238E27FC236}">
-                <a16:creationId xmlns:a16="http://schemas.microsoft.com/office/drawing/2014/main" id="{0C9632E7-8CCD-4A19-8DD4-0FD1932A790E}"/>
+                <a16:creationId xmlns:a16="http://schemas.microsoft.com/office/drawing/2014/main" id="{ABF0B882-1D26-48FE-B86F-60DA1DE070D2}"/>
               </a:ext>
             </a:extLst>
           </p:cNvPr>
@@ -5081,7 +5081,7 @@
           <p:cNvPr id="4" name="">
             <a:extLst xmlns:a="http://schemas.openxmlformats.org/drawingml/2006/main">
               <a:ext uri="{FF2B5EF4-FFF2-40B4-BE49-F238E27FC236}">
-                <a16:creationId xmlns:a16="http://schemas.microsoft.com/office/drawing/2014/main" id="{F6EDB940-623A-41FA-98BB-B46B1FF32482}"/>
+                <a16:creationId xmlns:a16="http://schemas.microsoft.com/office/drawing/2014/main" id="{8A61C866-7FAA-4069-A706-ADDD64748849}"/>
               </a:ext>
             </a:extLst>
           </p:cNvPr>
@@ -5238,7 +5238,7 @@
           <p:cNvPr id="5" name="">
             <a:extLst xmlns:a="http://schemas.openxmlformats.org/drawingml/2006/main">
               <a:ext uri="{FF2B5EF4-FFF2-40B4-BE49-F238E27FC236}">
-                <a16:creationId xmlns:a16="http://schemas.microsoft.com/office/drawing/2014/main" id="{DCF3E20E-4CD4-4CC2-90A1-116F7983052C}"/>
+                <a16:creationId xmlns:a16="http://schemas.microsoft.com/office/drawing/2014/main" id="{2B95DF56-A5B9-4E0D-A868-DB6A3742BBAF}"/>
               </a:ext>
             </a:extLst>
           </p:cNvPr>
@@ -5395,7 +5395,7 @@
           <p:cNvPr id="6" name="">
             <a:extLst xmlns:a="http://schemas.openxmlformats.org/drawingml/2006/main">
               <a:ext uri="{FF2B5EF4-FFF2-40B4-BE49-F238E27FC236}">
-                <a16:creationId xmlns:a16="http://schemas.microsoft.com/office/drawing/2014/main" id="{4CC00052-A70C-4B23-8C5C-4B230B05A78A}"/>
+                <a16:creationId xmlns:a16="http://schemas.microsoft.com/office/drawing/2014/main" id="{FF1FB973-6A0D-4F13-98D9-818737795613}"/>
               </a:ext>
             </a:extLst>
           </p:cNvPr>
@@ -5550,7 +5550,7 @@
     </p:spTree>
     <p:extLst>
       <p:ext uri="{BB962C8B-B14F-4D97-AF65-F5344CB8AC3E}">
-        <p14:creationId xmlns:p14="http://schemas.microsoft.com/office/powerpoint/2010/main" val="1288733491"/>
+        <p14:creationId xmlns:p14="http://schemas.microsoft.com/office/powerpoint/2010/main" val="740200032"/>
       </p:ext>
     </p:extLst>
   </p:cSld>
@@ -5581,7 +5581,7 @@
           <p:cNvPr id="8" name="">
             <a:extLst xmlns:a="http://schemas.openxmlformats.org/drawingml/2006/main">
               <a:ext uri="{FF2B5EF4-FFF2-40B4-BE49-F238E27FC236}">
-                <a16:creationId xmlns:a16="http://schemas.microsoft.com/office/drawing/2014/main" id="{3C91896A-75C2-4D1C-8BD3-FCE6184B0D91}"/>
+                <a16:creationId xmlns:a16="http://schemas.microsoft.com/office/drawing/2014/main" id="{BAD5CD97-37A4-49E2-A763-2812BF5AB5B7}"/>
               </a:ext>
             </a:extLst>
           </p:cNvPr>
@@ -5738,7 +5738,7 @@
           <p:cNvPr id="2" name="">
             <a:extLst xmlns:a="http://schemas.openxmlformats.org/drawingml/2006/main">
               <a:ext uri="{FF2B5EF4-FFF2-40B4-BE49-F238E27FC236}">
-                <a16:creationId xmlns:a16="http://schemas.microsoft.com/office/drawing/2014/main" id="{18F43A82-827A-4AE5-9CD8-A8CBE3C71245}"/>
+                <a16:creationId xmlns:a16="http://schemas.microsoft.com/office/drawing/2014/main" id="{09B66A24-E5BF-4534-A8BF-20E2066D6E52}"/>
               </a:ext>
             </a:extLst>
           </p:cNvPr>
@@ -5895,7 +5895,7 @@
           <p:cNvPr id="3" name="">
             <a:extLst xmlns:a="http://schemas.openxmlformats.org/drawingml/2006/main">
               <a:ext uri="{FF2B5EF4-FFF2-40B4-BE49-F238E27FC236}">
-                <a16:creationId xmlns:a16="http://schemas.microsoft.com/office/drawing/2014/main" id="{419C9199-B3EA-4D63-B040-47925FAC53C5}"/>
+                <a16:creationId xmlns:a16="http://schemas.microsoft.com/office/drawing/2014/main" id="{3CA7DC70-33F3-487D-B80C-969C2103F18B}"/>
               </a:ext>
             </a:extLst>
           </p:cNvPr>
@@ -6052,7 +6052,7 @@
           <p:cNvPr id="4" name="">
             <a:extLst xmlns:a="http://schemas.openxmlformats.org/drawingml/2006/main">
               <a:ext uri="{FF2B5EF4-FFF2-40B4-BE49-F238E27FC236}">
-                <a16:creationId xmlns:a16="http://schemas.microsoft.com/office/drawing/2014/main" id="{39216D02-735B-49E5-A4AF-F02124DCC583}"/>
+                <a16:creationId xmlns:a16="http://schemas.microsoft.com/office/drawing/2014/main" id="{E2FDFAE2-6063-4FD6-B261-93380A0D3562}"/>
               </a:ext>
             </a:extLst>
           </p:cNvPr>
@@ -6209,7 +6209,7 @@
           <p:cNvPr id="5" name="">
             <a:extLst xmlns:a="http://schemas.openxmlformats.org/drawingml/2006/main">
               <a:ext uri="{FF2B5EF4-FFF2-40B4-BE49-F238E27FC236}">
-                <a16:creationId xmlns:a16="http://schemas.microsoft.com/office/drawing/2014/main" id="{00EA8BA1-DDB4-4237-8DA5-DABD057DAD0D}"/>
+                <a16:creationId xmlns:a16="http://schemas.microsoft.com/office/drawing/2014/main" id="{4BAE1928-0416-4DBB-9670-D65F42587FA9}"/>
               </a:ext>
             </a:extLst>
           </p:cNvPr>
@@ -6366,7 +6366,7 @@
           <p:cNvPr id="6" name="">
             <a:extLst xmlns:a="http://schemas.openxmlformats.org/drawingml/2006/main">
               <a:ext uri="{FF2B5EF4-FFF2-40B4-BE49-F238E27FC236}">
-                <a16:creationId xmlns:a16="http://schemas.microsoft.com/office/drawing/2014/main" id="{02133CE0-FDA2-4C66-82B6-BC2099AC18B2}"/>
+                <a16:creationId xmlns:a16="http://schemas.microsoft.com/office/drawing/2014/main" id="{4693D7CA-0A24-4285-A950-6337C8E88536}"/>
               </a:ext>
             </a:extLst>
           </p:cNvPr>
@@ -6523,7 +6523,7 @@
           <p:cNvPr id="7" name="">
             <a:extLst xmlns:a="http://schemas.openxmlformats.org/drawingml/2006/main">
               <a:ext uri="{FF2B5EF4-FFF2-40B4-BE49-F238E27FC236}">
-                <a16:creationId xmlns:a16="http://schemas.microsoft.com/office/drawing/2014/main" id="{B1E3612E-B896-43E7-8CEE-C539444E7766}"/>
+                <a16:creationId xmlns:a16="http://schemas.microsoft.com/office/drawing/2014/main" id="{F471E33B-CAAD-48EF-BB16-73405124A055}"/>
               </a:ext>
             </a:extLst>
           </p:cNvPr>
@@ -6678,7 +6678,7 @@
     </p:spTree>
     <p:extLst>
       <p:ext uri="{BB962C8B-B14F-4D97-AF65-F5344CB8AC3E}">
-        <p14:creationId xmlns:p14="http://schemas.microsoft.com/office/powerpoint/2010/main" val="765760502"/>
+        <p14:creationId xmlns:p14="http://schemas.microsoft.com/office/powerpoint/2010/main" val="1273596659"/>
       </p:ext>
     </p:extLst>
   </p:cSld>
@@ -6709,7 +6709,7 @@
           <p:cNvPr id="8" name="">
             <a:extLst xmlns:a="http://schemas.openxmlformats.org/drawingml/2006/main">
               <a:ext uri="{FF2B5EF4-FFF2-40B4-BE49-F238E27FC236}">
-                <a16:creationId xmlns:a16="http://schemas.microsoft.com/office/drawing/2014/main" id="{0BB3D7AF-F52A-471F-9BE9-747194D04554}"/>
+                <a16:creationId xmlns:a16="http://schemas.microsoft.com/office/drawing/2014/main" id="{0E3AE97B-6C15-43B3-8C6D-E2DF61803134}"/>
               </a:ext>
             </a:extLst>
           </p:cNvPr>
@@ -6866,7 +6866,7 @@
           <p:cNvPr id="2" name="">
             <a:extLst xmlns:a="http://schemas.openxmlformats.org/drawingml/2006/main">
               <a:ext uri="{FF2B5EF4-FFF2-40B4-BE49-F238E27FC236}">
-                <a16:creationId xmlns:a16="http://schemas.microsoft.com/office/drawing/2014/main" id="{E4EA3997-8B05-477A-848F-AB555A26FB88}"/>
+                <a16:creationId xmlns:a16="http://schemas.microsoft.com/office/drawing/2014/main" id="{B57369BE-5EA2-469C-BA07-0570184271F1}"/>
               </a:ext>
             </a:extLst>
           </p:cNvPr>
@@ -7023,7 +7023,7 @@
           <p:cNvPr id="3" name="">
             <a:extLst xmlns:a="http://schemas.openxmlformats.org/drawingml/2006/main">
               <a:ext uri="{FF2B5EF4-FFF2-40B4-BE49-F238E27FC236}">
-                <a16:creationId xmlns:a16="http://schemas.microsoft.com/office/drawing/2014/main" id="{61E9807C-AA88-45D1-A6AD-591D235DC8E2}"/>
+                <a16:creationId xmlns:a16="http://schemas.microsoft.com/office/drawing/2014/main" id="{91DF5651-8575-4CF2-96F8-C9BED5DA332A}"/>
               </a:ext>
             </a:extLst>
           </p:cNvPr>
@@ -7180,7 +7180,7 @@
           <p:cNvPr id="4" name="">
             <a:extLst xmlns:a="http://schemas.openxmlformats.org/drawingml/2006/main">
               <a:ext uri="{FF2B5EF4-FFF2-40B4-BE49-F238E27FC236}">
-                <a16:creationId xmlns:a16="http://schemas.microsoft.com/office/drawing/2014/main" id="{677136DD-2CF5-4EF0-A85C-EDE81B8450B8}"/>
+                <a16:creationId xmlns:a16="http://schemas.microsoft.com/office/drawing/2014/main" id="{E219B369-225A-47BF-A4D8-DF313C73F3A5}"/>
               </a:ext>
             </a:extLst>
           </p:cNvPr>
@@ -7337,7 +7337,7 @@
           <p:cNvPr id="5" name="">
             <a:extLst xmlns:a="http://schemas.openxmlformats.org/drawingml/2006/main">
               <a:ext uri="{FF2B5EF4-FFF2-40B4-BE49-F238E27FC236}">
-                <a16:creationId xmlns:a16="http://schemas.microsoft.com/office/drawing/2014/main" id="{294EC604-DFA4-48F5-9B54-769147EC5DB4}"/>
+                <a16:creationId xmlns:a16="http://schemas.microsoft.com/office/drawing/2014/main" id="{8A91C62E-A93B-42F2-870B-83CCFE91CF7A}"/>
               </a:ext>
             </a:extLst>
           </p:cNvPr>
@@ -7494,7 +7494,7 @@
           <p:cNvPr id="6" name="">
             <a:extLst xmlns:a="http://schemas.openxmlformats.org/drawingml/2006/main">
               <a:ext uri="{FF2B5EF4-FFF2-40B4-BE49-F238E27FC236}">
-                <a16:creationId xmlns:a16="http://schemas.microsoft.com/office/drawing/2014/main" id="{9F3C3A84-A8AF-4891-8661-0DE14F77AF03}"/>
+                <a16:creationId xmlns:a16="http://schemas.microsoft.com/office/drawing/2014/main" id="{FD235AAD-15B6-41B1-AC34-E7ED017A4DA1}"/>
               </a:ext>
             </a:extLst>
           </p:cNvPr>
@@ -7651,7 +7651,7 @@
           <p:cNvPr id="7" name="">
             <a:extLst xmlns:a="http://schemas.openxmlformats.org/drawingml/2006/main">
               <a:ext uri="{FF2B5EF4-FFF2-40B4-BE49-F238E27FC236}">
-                <a16:creationId xmlns:a16="http://schemas.microsoft.com/office/drawing/2014/main" id="{4058EF79-0DA4-4616-A7B6-5EEE0867DB90}"/>
+                <a16:creationId xmlns:a16="http://schemas.microsoft.com/office/drawing/2014/main" id="{8A2859C3-D04E-4607-9A9C-0FB7C272F6C1}"/>
               </a:ext>
             </a:extLst>
           </p:cNvPr>
@@ -7806,7 +7806,7 @@
     </p:spTree>
     <p:extLst>
       <p:ext uri="{BB962C8B-B14F-4D97-AF65-F5344CB8AC3E}">
-        <p14:creationId xmlns:p14="http://schemas.microsoft.com/office/powerpoint/2010/main" val="1739022348"/>
+        <p14:creationId xmlns:p14="http://schemas.microsoft.com/office/powerpoint/2010/main" val="1296076628"/>
       </p:ext>
     </p:extLst>
   </p:cSld>
@@ -7834,10 +7834,10 @@
       </p:grpSpPr>
       <p:sp>
         <p:nvSpPr>
-          <p:cNvPr id="8" name="">
+          <p:cNvPr id="9" name="">
             <a:extLst xmlns:a="http://schemas.openxmlformats.org/drawingml/2006/main">
               <a:ext uri="{FF2B5EF4-FFF2-40B4-BE49-F238E27FC236}">
-                <a16:creationId xmlns:a16="http://schemas.microsoft.com/office/drawing/2014/main" id="{C6FF1320-3F9F-4D54-90AC-D6D7926D97C4}"/>
+                <a16:creationId xmlns:a16="http://schemas.microsoft.com/office/drawing/2014/main" id="{FBF66E4C-A041-4A61-AD4D-432DE57A6D0A}"/>
               </a:ext>
             </a:extLst>
           </p:cNvPr>
@@ -7994,7 +7994,7 @@
           <p:cNvPr id="2" name="">
             <a:extLst xmlns:a="http://schemas.openxmlformats.org/drawingml/2006/main">
               <a:ext uri="{FF2B5EF4-FFF2-40B4-BE49-F238E27FC236}">
-                <a16:creationId xmlns:a16="http://schemas.microsoft.com/office/drawing/2014/main" id="{C01A1354-E0DA-4508-86E7-778342B6272A}"/>
+                <a16:creationId xmlns:a16="http://schemas.microsoft.com/office/drawing/2014/main" id="{68613E74-5D38-44F2-A128-570CCB948EAA}"/>
               </a:ext>
             </a:extLst>
           </p:cNvPr>
@@ -8151,7 +8151,7 @@
           <p:cNvPr id="3" name="">
             <a:extLst xmlns:a="http://schemas.openxmlformats.org/drawingml/2006/main">
               <a:ext uri="{FF2B5EF4-FFF2-40B4-BE49-F238E27FC236}">
-                <a16:creationId xmlns:a16="http://schemas.microsoft.com/office/drawing/2014/main" id="{BC8163B0-AF21-450C-B3AF-7469D6B8F91D}"/>
+                <a16:creationId xmlns:a16="http://schemas.microsoft.com/office/drawing/2014/main" id="{64C80354-2596-4B87-957E-C07A51642038}"/>
               </a:ext>
             </a:extLst>
           </p:cNvPr>
@@ -8162,8 +8162,8 @@
         </p:nvSpPr>
         <p:spPr>
           <a:xfrm xmlns:a="http://schemas.openxmlformats.org/drawingml/2006/main">
-            <a:off x="619125" y="1619250"/>
-            <a:ext cx="10572750" cy="771525"/>
+            <a:off x="619125" y="1581150"/>
+            <a:ext cx="10572750" cy="657225"/>
           </a:xfrm>
           <a:prstGeom xmlns:a="http://schemas.openxmlformats.org/drawingml/2006/main" prst="rect">
             <a:avLst/>
@@ -8178,7 +8178,7 @@
           <a:bodyPr xmlns:a="http://schemas.openxmlformats.org/drawingml/2006/main"/>
           <a:lstStyle xmlns:a="http://schemas.openxmlformats.org/drawingml/2006/main">
             <a:defPPr>
-              <a:defRPr sz="1875" b="0">
+              <a:defRPr sz="1725" b="0">
                 <a:solidFill>
                   <a:srgbClr val="F4F6FA"/>
                 </a:solidFill>
@@ -8188,7 +8188,7 @@
               </a:defRPr>
             </a:defPPr>
             <a:lvl1pPr>
-              <a:defRPr sz="1875" b="0">
+              <a:defRPr sz="1725" b="0">
                 <a:solidFill>
                   <a:srgbClr val="F4F6FA"/>
                 </a:solidFill>
@@ -8198,7 +8198,7 @@
               </a:defRPr>
             </a:lvl1pPr>
             <a:lvl2pPr>
-              <a:defRPr sz="1875" b="0">
+              <a:defRPr sz="1725" b="0">
                 <a:solidFill>
                   <a:srgbClr val="F4F6FA"/>
                 </a:solidFill>
@@ -8208,7 +8208,7 @@
               </a:defRPr>
             </a:lvl2pPr>
             <a:lvl3pPr>
-              <a:defRPr sz="1875" b="0">
+              <a:defRPr sz="1725" b="0">
                 <a:solidFill>
                   <a:srgbClr val="F4F6FA"/>
                 </a:solidFill>
@@ -8218,7 +8218,7 @@
               </a:defRPr>
             </a:lvl3pPr>
             <a:lvl4pPr>
-              <a:defRPr sz="1875" b="0">
+              <a:defRPr sz="1725" b="0">
                 <a:solidFill>
                   <a:srgbClr val="F4F6FA"/>
                 </a:solidFill>
@@ -8228,7 +8228,7 @@
               </a:defRPr>
             </a:lvl4pPr>
             <a:lvl5pPr>
-              <a:defRPr sz="1875" b="0">
+              <a:defRPr sz="1725" b="0">
                 <a:solidFill>
                   <a:srgbClr val="F4F6FA"/>
                 </a:solidFill>
@@ -8238,7 +8238,7 @@
               </a:defRPr>
             </a:lvl5pPr>
             <a:lvl6pPr>
-              <a:defRPr sz="1875" b="0">
+              <a:defRPr sz="1725" b="0">
                 <a:solidFill>
                   <a:srgbClr val="F4F6FA"/>
                 </a:solidFill>
@@ -8248,7 +8248,7 @@
               </a:defRPr>
             </a:lvl6pPr>
             <a:lvl7pPr>
-              <a:defRPr sz="1875" b="0">
+              <a:defRPr sz="1725" b="0">
                 <a:solidFill>
                   <a:srgbClr val="F4F6FA"/>
                 </a:solidFill>
@@ -8258,7 +8258,7 @@
               </a:defRPr>
             </a:lvl7pPr>
             <a:lvl8pPr>
-              <a:defRPr sz="1875" b="0">
+              <a:defRPr sz="1725" b="0">
                 <a:solidFill>
                   <a:srgbClr val="F4F6FA"/>
                 </a:solidFill>
@@ -8268,7 +8268,7 @@
               </a:defRPr>
             </a:lvl8pPr>
             <a:lvl9pPr>
-              <a:defRPr sz="1875" b="0">
+              <a:defRPr sz="1725" b="0">
                 <a:solidFill>
                   <a:srgbClr val="F4F6FA"/>
                 </a:solidFill>
@@ -8280,7 +8280,7 @@
           </a:lstStyle>
           <a:p xmlns:a="http://schemas.openxmlformats.org/drawingml/2006/main">
             <a:pPr>
-              <a:defRPr sz="1875" b="0">
+              <a:defRPr sz="1725" b="0">
                 <a:solidFill>
                   <a:srgbClr val="F4F6FA"/>
                 </a:solidFill>
@@ -8290,7 +8290,7 @@
               </a:defRPr>
             </a:pPr>
             <a:r>
-              <a:rPr sz="1875" b="0">
+              <a:rPr sz="1725" b="0">
                 <a:solidFill>
                   <a:srgbClr val="F4F6FA"/>
                 </a:solidFill>
@@ -8308,7 +8308,7 @@
           <p:cNvPr id="4" name="">
             <a:extLst xmlns:a="http://schemas.openxmlformats.org/drawingml/2006/main">
               <a:ext uri="{FF2B5EF4-FFF2-40B4-BE49-F238E27FC236}">
-                <a16:creationId xmlns:a16="http://schemas.microsoft.com/office/drawing/2014/main" id="{5DD68AA9-4354-45D1-A9F2-2C8D8AA9EE03}"/>
+                <a16:creationId xmlns:a16="http://schemas.microsoft.com/office/drawing/2014/main" id="{E1FE8C53-0FD6-4578-A603-C70B04EF7E2B}"/>
               </a:ext>
             </a:extLst>
           </p:cNvPr>
@@ -8319,8 +8319,8 @@
         </p:nvSpPr>
         <p:spPr>
           <a:xfrm xmlns:a="http://schemas.openxmlformats.org/drawingml/2006/main">
-            <a:off x="619125" y="2457450"/>
-            <a:ext cx="10572750" cy="771525"/>
+            <a:off x="619125" y="2305050"/>
+            <a:ext cx="10572750" cy="657225"/>
           </a:xfrm>
           <a:prstGeom xmlns:a="http://schemas.openxmlformats.org/drawingml/2006/main" prst="rect">
             <a:avLst/>
@@ -8335,7 +8335,7 @@
           <a:bodyPr xmlns:a="http://schemas.openxmlformats.org/drawingml/2006/main"/>
           <a:lstStyle xmlns:a="http://schemas.openxmlformats.org/drawingml/2006/main">
             <a:defPPr>
-              <a:defRPr sz="1875" b="0">
+              <a:defRPr sz="1725" b="0">
                 <a:solidFill>
                   <a:srgbClr val="B6C0D1"/>
                 </a:solidFill>
@@ -8345,7 +8345,7 @@
               </a:defRPr>
             </a:defPPr>
             <a:lvl1pPr>
-              <a:defRPr sz="1875" b="0">
+              <a:defRPr sz="1725" b="0">
                 <a:solidFill>
                   <a:srgbClr val="B6C0D1"/>
                 </a:solidFill>
@@ -8355,7 +8355,7 @@
               </a:defRPr>
             </a:lvl1pPr>
             <a:lvl2pPr>
-              <a:defRPr sz="1875" b="0">
+              <a:defRPr sz="1725" b="0">
                 <a:solidFill>
                   <a:srgbClr val="B6C0D1"/>
                 </a:solidFill>
@@ -8365,7 +8365,7 @@
               </a:defRPr>
             </a:lvl2pPr>
             <a:lvl3pPr>
-              <a:defRPr sz="1875" b="0">
+              <a:defRPr sz="1725" b="0">
                 <a:solidFill>
                   <a:srgbClr val="B6C0D1"/>
                 </a:solidFill>
@@ -8375,7 +8375,7 @@
               </a:defRPr>
             </a:lvl3pPr>
             <a:lvl4pPr>
-              <a:defRPr sz="1875" b="0">
+              <a:defRPr sz="1725" b="0">
                 <a:solidFill>
                   <a:srgbClr val="B6C0D1"/>
                 </a:solidFill>
@@ -8385,7 +8385,7 @@
               </a:defRPr>
             </a:lvl4pPr>
             <a:lvl5pPr>
-              <a:defRPr sz="1875" b="0">
+              <a:defRPr sz="1725" b="0">
                 <a:solidFill>
                   <a:srgbClr val="B6C0D1"/>
                 </a:solidFill>
@@ -8395,7 +8395,7 @@
               </a:defRPr>
             </a:lvl5pPr>
             <a:lvl6pPr>
-              <a:defRPr sz="1875" b="0">
+              <a:defRPr sz="1725" b="0">
                 <a:solidFill>
                   <a:srgbClr val="B6C0D1"/>
                 </a:solidFill>
@@ -8405,7 +8405,7 @@
               </a:defRPr>
             </a:lvl6pPr>
             <a:lvl7pPr>
-              <a:defRPr sz="1875" b="0">
+              <a:defRPr sz="1725" b="0">
                 <a:solidFill>
                   <a:srgbClr val="B6C0D1"/>
                 </a:solidFill>
@@ -8415,7 +8415,7 @@
               </a:defRPr>
             </a:lvl7pPr>
             <a:lvl8pPr>
-              <a:defRPr sz="1875" b="0">
+              <a:defRPr sz="1725" b="0">
                 <a:solidFill>
                   <a:srgbClr val="B6C0D1"/>
                 </a:solidFill>
@@ -8425,7 +8425,7 @@
               </a:defRPr>
             </a:lvl8pPr>
             <a:lvl9pPr>
-              <a:defRPr sz="1875" b="0">
+              <a:defRPr sz="1725" b="0">
                 <a:solidFill>
                   <a:srgbClr val="B6C0D1"/>
                 </a:solidFill>
@@ -8437,7 +8437,7 @@
           </a:lstStyle>
           <a:p xmlns:a="http://schemas.openxmlformats.org/drawingml/2006/main">
             <a:pPr>
-              <a:defRPr sz="1875" b="0">
+              <a:defRPr sz="1725" b="0">
                 <a:solidFill>
                   <a:srgbClr val="B6C0D1"/>
                 </a:solidFill>
@@ -8447,7 +8447,7 @@
               </a:defRPr>
             </a:pPr>
             <a:r>
-              <a:rPr sz="1875" b="0">
+              <a:rPr sz="1725" b="0">
                 <a:solidFill>
                   <a:srgbClr val="B6C0D1"/>
                 </a:solidFill>
@@ -8465,7 +8465,7 @@
           <p:cNvPr id="5" name="">
             <a:extLst xmlns:a="http://schemas.openxmlformats.org/drawingml/2006/main">
               <a:ext uri="{FF2B5EF4-FFF2-40B4-BE49-F238E27FC236}">
-                <a16:creationId xmlns:a16="http://schemas.microsoft.com/office/drawing/2014/main" id="{86555D36-16D4-4EC6-A153-CAFA23232B3B}"/>
+                <a16:creationId xmlns:a16="http://schemas.microsoft.com/office/drawing/2014/main" id="{6FFFD8A7-A97E-4ABC-A2AB-F68F8293E5CB}"/>
               </a:ext>
             </a:extLst>
           </p:cNvPr>
@@ -8476,8 +8476,8 @@
         </p:nvSpPr>
         <p:spPr>
           <a:xfrm xmlns:a="http://schemas.openxmlformats.org/drawingml/2006/main">
-            <a:off x="619125" y="3295650"/>
-            <a:ext cx="10572750" cy="771525"/>
+            <a:off x="619125" y="3028950"/>
+            <a:ext cx="10572750" cy="657225"/>
           </a:xfrm>
           <a:prstGeom xmlns:a="http://schemas.openxmlformats.org/drawingml/2006/main" prst="rect">
             <a:avLst/>
@@ -8492,7 +8492,7 @@
           <a:bodyPr xmlns:a="http://schemas.openxmlformats.org/drawingml/2006/main"/>
           <a:lstStyle xmlns:a="http://schemas.openxmlformats.org/drawingml/2006/main">
             <a:defPPr>
-              <a:defRPr sz="1875" b="0">
+              <a:defRPr sz="1725" b="0">
                 <a:solidFill>
                   <a:srgbClr val="B6C0D1"/>
                 </a:solidFill>
@@ -8502,7 +8502,7 @@
               </a:defRPr>
             </a:defPPr>
             <a:lvl1pPr>
-              <a:defRPr sz="1875" b="0">
+              <a:defRPr sz="1725" b="0">
                 <a:solidFill>
                   <a:srgbClr val="B6C0D1"/>
                 </a:solidFill>
@@ -8512,7 +8512,7 @@
               </a:defRPr>
             </a:lvl1pPr>
             <a:lvl2pPr>
-              <a:defRPr sz="1875" b="0">
+              <a:defRPr sz="1725" b="0">
                 <a:solidFill>
                   <a:srgbClr val="B6C0D1"/>
                 </a:solidFill>
@@ -8522,7 +8522,7 @@
               </a:defRPr>
             </a:lvl2pPr>
             <a:lvl3pPr>
-              <a:defRPr sz="1875" b="0">
+              <a:defRPr sz="1725" b="0">
                 <a:solidFill>
                   <a:srgbClr val="B6C0D1"/>
                 </a:solidFill>
@@ -8532,7 +8532,7 @@
               </a:defRPr>
             </a:lvl3pPr>
             <a:lvl4pPr>
-              <a:defRPr sz="1875" b="0">
+              <a:defRPr sz="1725" b="0">
                 <a:solidFill>
                   <a:srgbClr val="B6C0D1"/>
                 </a:solidFill>
@@ -8542,7 +8542,7 @@
               </a:defRPr>
             </a:lvl4pPr>
             <a:lvl5pPr>
-              <a:defRPr sz="1875" b="0">
+              <a:defRPr sz="1725" b="0">
                 <a:solidFill>
                   <a:srgbClr val="B6C0D1"/>
                 </a:solidFill>
@@ -8552,7 +8552,7 @@
               </a:defRPr>
             </a:lvl5pPr>
             <a:lvl6pPr>
-              <a:defRPr sz="1875" b="0">
+              <a:defRPr sz="1725" b="0">
                 <a:solidFill>
                   <a:srgbClr val="B6C0D1"/>
                 </a:solidFill>
@@ -8562,7 +8562,7 @@
               </a:defRPr>
             </a:lvl6pPr>
             <a:lvl7pPr>
-              <a:defRPr sz="1875" b="0">
+              <a:defRPr sz="1725" b="0">
                 <a:solidFill>
                   <a:srgbClr val="B6C0D1"/>
                 </a:solidFill>
@@ -8572,7 +8572,7 @@
               </a:defRPr>
             </a:lvl7pPr>
             <a:lvl8pPr>
-              <a:defRPr sz="1875" b="0">
+              <a:defRPr sz="1725" b="0">
                 <a:solidFill>
                   <a:srgbClr val="B6C0D1"/>
                 </a:solidFill>
@@ -8582,7 +8582,7 @@
               </a:defRPr>
             </a:lvl8pPr>
             <a:lvl9pPr>
-              <a:defRPr sz="1875" b="0">
+              <a:defRPr sz="1725" b="0">
                 <a:solidFill>
                   <a:srgbClr val="B6C0D1"/>
                 </a:solidFill>
@@ -8594,7 +8594,7 @@
           </a:lstStyle>
           <a:p xmlns:a="http://schemas.openxmlformats.org/drawingml/2006/main">
             <a:pPr>
-              <a:defRPr sz="1875" b="0">
+              <a:defRPr sz="1725" b="0">
                 <a:solidFill>
                   <a:srgbClr val="B6C0D1"/>
                 </a:solidFill>
@@ -8604,7 +8604,7 @@
               </a:defRPr>
             </a:pPr>
             <a:r>
-              <a:rPr sz="1875" b="0">
+              <a:rPr sz="1725" b="0">
                 <a:solidFill>
                   <a:srgbClr val="B6C0D1"/>
                 </a:solidFill>
@@ -8622,7 +8622,7 @@
           <p:cNvPr id="6" name="">
             <a:extLst xmlns:a="http://schemas.openxmlformats.org/drawingml/2006/main">
               <a:ext uri="{FF2B5EF4-FFF2-40B4-BE49-F238E27FC236}">
-                <a16:creationId xmlns:a16="http://schemas.microsoft.com/office/drawing/2014/main" id="{A0A22D8B-C9A4-4500-AEAD-2D5EA3C2BA4F}"/>
+                <a16:creationId xmlns:a16="http://schemas.microsoft.com/office/drawing/2014/main" id="{4CC023DB-0162-4D88-A1FC-43932983CA6A}"/>
               </a:ext>
             </a:extLst>
           </p:cNvPr>
@@ -8633,8 +8633,8 @@
         </p:nvSpPr>
         <p:spPr>
           <a:xfrm xmlns:a="http://schemas.openxmlformats.org/drawingml/2006/main">
-            <a:off x="619125" y="4133850"/>
-            <a:ext cx="10572750" cy="771525"/>
+            <a:off x="619125" y="3752850"/>
+            <a:ext cx="10572750" cy="657225"/>
           </a:xfrm>
           <a:prstGeom xmlns:a="http://schemas.openxmlformats.org/drawingml/2006/main" prst="rect">
             <a:avLst/>
@@ -8649,7 +8649,7 @@
           <a:bodyPr xmlns:a="http://schemas.openxmlformats.org/drawingml/2006/main"/>
           <a:lstStyle xmlns:a="http://schemas.openxmlformats.org/drawingml/2006/main">
             <a:defPPr>
-              <a:defRPr sz="1875" b="0">
+              <a:defRPr sz="1725" b="0">
                 <a:solidFill>
                   <a:srgbClr val="B6C0D1"/>
                 </a:solidFill>
@@ -8659,7 +8659,7 @@
               </a:defRPr>
             </a:defPPr>
             <a:lvl1pPr>
-              <a:defRPr sz="1875" b="0">
+              <a:defRPr sz="1725" b="0">
                 <a:solidFill>
                   <a:srgbClr val="B6C0D1"/>
                 </a:solidFill>
@@ -8669,7 +8669,7 @@
               </a:defRPr>
             </a:lvl1pPr>
             <a:lvl2pPr>
-              <a:defRPr sz="1875" b="0">
+              <a:defRPr sz="1725" b="0">
                 <a:solidFill>
                   <a:srgbClr val="B6C0D1"/>
                 </a:solidFill>
@@ -8679,7 +8679,7 @@
               </a:defRPr>
             </a:lvl2pPr>
             <a:lvl3pPr>
-              <a:defRPr sz="1875" b="0">
+              <a:defRPr sz="1725" b="0">
                 <a:solidFill>
                   <a:srgbClr val="B6C0D1"/>
                 </a:solidFill>
@@ -8689,7 +8689,7 @@
               </a:defRPr>
             </a:lvl3pPr>
             <a:lvl4pPr>
-              <a:defRPr sz="1875" b="0">
+              <a:defRPr sz="1725" b="0">
                 <a:solidFill>
                   <a:srgbClr val="B6C0D1"/>
                 </a:solidFill>
@@ -8699,7 +8699,7 @@
               </a:defRPr>
             </a:lvl4pPr>
             <a:lvl5pPr>
-              <a:defRPr sz="1875" b="0">
+              <a:defRPr sz="1725" b="0">
                 <a:solidFill>
                   <a:srgbClr val="B6C0D1"/>
                 </a:solidFill>
@@ -8709,7 +8709,7 @@
               </a:defRPr>
             </a:lvl5pPr>
             <a:lvl6pPr>
-              <a:defRPr sz="1875" b="0">
+              <a:defRPr sz="1725" b="0">
                 <a:solidFill>
                   <a:srgbClr val="B6C0D1"/>
                 </a:solidFill>
@@ -8719,7 +8719,7 @@
               </a:defRPr>
             </a:lvl6pPr>
             <a:lvl7pPr>
-              <a:defRPr sz="1875" b="0">
+              <a:defRPr sz="1725" b="0">
                 <a:solidFill>
                   <a:srgbClr val="B6C0D1"/>
                 </a:solidFill>
@@ -8729,7 +8729,7 @@
               </a:defRPr>
             </a:lvl7pPr>
             <a:lvl8pPr>
-              <a:defRPr sz="1875" b="0">
+              <a:defRPr sz="1725" b="0">
                 <a:solidFill>
                   <a:srgbClr val="B6C0D1"/>
                 </a:solidFill>
@@ -8739,7 +8739,7 @@
               </a:defRPr>
             </a:lvl8pPr>
             <a:lvl9pPr>
-              <a:defRPr sz="1875" b="0">
+              <a:defRPr sz="1725" b="0">
                 <a:solidFill>
                   <a:srgbClr val="B6C0D1"/>
                 </a:solidFill>
@@ -8751,7 +8751,7 @@
           </a:lstStyle>
           <a:p xmlns:a="http://schemas.openxmlformats.org/drawingml/2006/main">
             <a:pPr>
-              <a:defRPr sz="1875" b="0">
+              <a:defRPr sz="1725" b="0">
                 <a:solidFill>
                   <a:srgbClr val="B6C0D1"/>
                 </a:solidFill>
@@ -8761,7 +8761,7 @@
               </a:defRPr>
             </a:pPr>
             <a:r>
-              <a:rPr sz="1875" b="0">
+              <a:rPr sz="1725" b="0">
                 <a:solidFill>
                   <a:srgbClr val="B6C0D1"/>
                 </a:solidFill>
@@ -8779,7 +8779,7 @@
           <p:cNvPr id="7" name="">
             <a:extLst xmlns:a="http://schemas.openxmlformats.org/drawingml/2006/main">
               <a:ext uri="{FF2B5EF4-FFF2-40B4-BE49-F238E27FC236}">
-                <a16:creationId xmlns:a16="http://schemas.microsoft.com/office/drawing/2014/main" id="{A6C36C63-1DFD-48A9-B136-86105758D974}"/>
+                <a16:creationId xmlns:a16="http://schemas.microsoft.com/office/drawing/2014/main" id="{E4B50B49-076C-4250-ADA0-F06F21948DED}"/>
               </a:ext>
             </a:extLst>
           </p:cNvPr>
@@ -8790,8 +8790,8 @@
         </p:nvSpPr>
         <p:spPr>
           <a:xfrm xmlns:a="http://schemas.openxmlformats.org/drawingml/2006/main">
-            <a:off x="619125" y="4972050"/>
-            <a:ext cx="10572750" cy="771525"/>
+            <a:off x="619125" y="4476750"/>
+            <a:ext cx="10572750" cy="657225"/>
           </a:xfrm>
           <a:prstGeom xmlns:a="http://schemas.openxmlformats.org/drawingml/2006/main" prst="rect">
             <a:avLst/>
@@ -8806,7 +8806,7 @@
           <a:bodyPr xmlns:a="http://schemas.openxmlformats.org/drawingml/2006/main"/>
           <a:lstStyle xmlns:a="http://schemas.openxmlformats.org/drawingml/2006/main">
             <a:defPPr>
-              <a:defRPr sz="1875" b="0">
+              <a:defRPr sz="1725" b="0">
                 <a:solidFill>
                   <a:srgbClr val="B6C0D1"/>
                 </a:solidFill>
@@ -8816,7 +8816,7 @@
               </a:defRPr>
             </a:defPPr>
             <a:lvl1pPr>
-              <a:defRPr sz="1875" b="0">
+              <a:defRPr sz="1725" b="0">
                 <a:solidFill>
                   <a:srgbClr val="B6C0D1"/>
                 </a:solidFill>
@@ -8826,7 +8826,7 @@
               </a:defRPr>
             </a:lvl1pPr>
             <a:lvl2pPr>
-              <a:defRPr sz="1875" b="0">
+              <a:defRPr sz="1725" b="0">
                 <a:solidFill>
                   <a:srgbClr val="B6C0D1"/>
                 </a:solidFill>
@@ -8836,7 +8836,7 @@
               </a:defRPr>
             </a:lvl2pPr>
             <a:lvl3pPr>
-              <a:defRPr sz="1875" b="0">
+              <a:defRPr sz="1725" b="0">
                 <a:solidFill>
                   <a:srgbClr val="B6C0D1"/>
                 </a:solidFill>
@@ -8846,7 +8846,7 @@
               </a:defRPr>
             </a:lvl3pPr>
             <a:lvl4pPr>
-              <a:defRPr sz="1875" b="0">
+              <a:defRPr sz="1725" b="0">
                 <a:solidFill>
                   <a:srgbClr val="B6C0D1"/>
                 </a:solidFill>
@@ -8856,7 +8856,7 @@
               </a:defRPr>
             </a:lvl4pPr>
             <a:lvl5pPr>
-              <a:defRPr sz="1875" b="0">
+              <a:defRPr sz="1725" b="0">
                 <a:solidFill>
                   <a:srgbClr val="B6C0D1"/>
                 </a:solidFill>
@@ -8866,7 +8866,7 @@
               </a:defRPr>
             </a:lvl5pPr>
             <a:lvl6pPr>
-              <a:defRPr sz="1875" b="0">
+              <a:defRPr sz="1725" b="0">
                 <a:solidFill>
                   <a:srgbClr val="B6C0D1"/>
                 </a:solidFill>
@@ -8876,7 +8876,7 @@
               </a:defRPr>
             </a:lvl6pPr>
             <a:lvl7pPr>
-              <a:defRPr sz="1875" b="0">
+              <a:defRPr sz="1725" b="0">
                 <a:solidFill>
                   <a:srgbClr val="B6C0D1"/>
                 </a:solidFill>
@@ -8886,7 +8886,7 @@
               </a:defRPr>
             </a:lvl7pPr>
             <a:lvl8pPr>
-              <a:defRPr sz="1875" b="0">
+              <a:defRPr sz="1725" b="0">
                 <a:solidFill>
                   <a:srgbClr val="B6C0D1"/>
                 </a:solidFill>
@@ -8896,7 +8896,7 @@
               </a:defRPr>
             </a:lvl8pPr>
             <a:lvl9pPr>
-              <a:defRPr sz="1875" b="0">
+              <a:defRPr sz="1725" b="0">
                 <a:solidFill>
                   <a:srgbClr val="B6C0D1"/>
                 </a:solidFill>
@@ -8908,7 +8908,7 @@
           </a:lstStyle>
           <a:p xmlns:a="http://schemas.openxmlformats.org/drawingml/2006/main">
             <a:pPr>
-              <a:defRPr sz="1875" b="0">
+              <a:defRPr sz="1725" b="0">
                 <a:solidFill>
                   <a:srgbClr val="B6C0D1"/>
                 </a:solidFill>
@@ -8918,7 +8918,7 @@
               </a:defRPr>
             </a:pPr>
             <a:r>
-              <a:rPr sz="1875" b="0">
+              <a:rPr sz="1725" b="0">
                 <a:solidFill>
                   <a:srgbClr val="B6C0D1"/>
                 </a:solidFill>
@@ -8927,6 +8927,163 @@
                 <a:cs typeface="DejaVu Sans"/>
               </a:rPr>
               <a:t>Range, battery drain and live AI remain untested.</a:t>
+            </a:r>
+          </a:p>
+        </p:txBody>
+      </p:sp>
+      <p:sp>
+        <p:nvSpPr>
+          <p:cNvPr id="8" name="">
+            <a:extLst xmlns:a="http://schemas.openxmlformats.org/drawingml/2006/main">
+              <a:ext uri="{FF2B5EF4-FFF2-40B4-BE49-F238E27FC236}">
+                <a16:creationId xmlns:a16="http://schemas.microsoft.com/office/drawing/2014/main" id="{EF0C1A69-1236-4890-A2DD-6ED7F090A7AB}"/>
+              </a:ext>
+            </a:extLst>
+          </p:cNvPr>
+          <p:cNvSpPr>
+            <a:spLocks xmlns:a="http://schemas.openxmlformats.org/drawingml/2006/main" noGrp="1"/>
+          </p:cNvSpPr>
+          <p:nvPr/>
+        </p:nvSpPr>
+        <p:spPr>
+          <a:xfrm xmlns:a="http://schemas.openxmlformats.org/drawingml/2006/main">
+            <a:off x="619125" y="5200650"/>
+            <a:ext cx="10572750" cy="657225"/>
+          </a:xfrm>
+          <a:prstGeom xmlns:a="http://schemas.openxmlformats.org/drawingml/2006/main" prst="rect">
+            <a:avLst/>
+          </a:prstGeom>
+          <a:noFill xmlns:a="http://schemas.openxmlformats.org/drawingml/2006/main"/>
+          <a:ln xmlns:a="http://schemas.openxmlformats.org/drawingml/2006/main" w="0">
+            <a:noFill/>
+            <a:prstDash val="solid"/>
+          </a:ln>
+        </p:spPr>
+        <p:txBody>
+          <a:bodyPr xmlns:a="http://schemas.openxmlformats.org/drawingml/2006/main"/>
+          <a:lstStyle xmlns:a="http://schemas.openxmlformats.org/drawingml/2006/main">
+            <a:defPPr>
+              <a:defRPr sz="1725" b="0">
+                <a:solidFill>
+                  <a:srgbClr val="B6C0D1"/>
+                </a:solidFill>
+                <a:latin typeface="DejaVu Sans"/>
+                <a:ea typeface="DejaVu Sans"/>
+                <a:cs typeface="DejaVu Sans"/>
+              </a:defRPr>
+            </a:defPPr>
+            <a:lvl1pPr>
+              <a:defRPr sz="1725" b="0">
+                <a:solidFill>
+                  <a:srgbClr val="B6C0D1"/>
+                </a:solidFill>
+                <a:latin typeface="DejaVu Sans"/>
+                <a:ea typeface="DejaVu Sans"/>
+                <a:cs typeface="DejaVu Sans"/>
+              </a:defRPr>
+            </a:lvl1pPr>
+            <a:lvl2pPr>
+              <a:defRPr sz="1725" b="0">
+                <a:solidFill>
+                  <a:srgbClr val="B6C0D1"/>
+                </a:solidFill>
+                <a:latin typeface="DejaVu Sans"/>
+                <a:ea typeface="DejaVu Sans"/>
+                <a:cs typeface="DejaVu Sans"/>
+              </a:defRPr>
+            </a:lvl2pPr>
+            <a:lvl3pPr>
+              <a:defRPr sz="1725" b="0">
+                <a:solidFill>
+                  <a:srgbClr val="B6C0D1"/>
+                </a:solidFill>
+                <a:latin typeface="DejaVu Sans"/>
+                <a:ea typeface="DejaVu Sans"/>
+                <a:cs typeface="DejaVu Sans"/>
+              </a:defRPr>
+            </a:lvl3pPr>
+            <a:lvl4pPr>
+              <a:defRPr sz="1725" b="0">
+                <a:solidFill>
+                  <a:srgbClr val="B6C0D1"/>
+                </a:solidFill>
+                <a:latin typeface="DejaVu Sans"/>
+                <a:ea typeface="DejaVu Sans"/>
+                <a:cs typeface="DejaVu Sans"/>
+              </a:defRPr>
+            </a:lvl4pPr>
+            <a:lvl5pPr>
+              <a:defRPr sz="1725" b="0">
+                <a:solidFill>
+                  <a:srgbClr val="B6C0D1"/>
+                </a:solidFill>
+                <a:latin typeface="DejaVu Sans"/>
+                <a:ea typeface="DejaVu Sans"/>
+                <a:cs typeface="DejaVu Sans"/>
+              </a:defRPr>
+            </a:lvl5pPr>
+            <a:lvl6pPr>
+              <a:defRPr sz="1725" b="0">
+                <a:solidFill>
+                  <a:srgbClr val="B6C0D1"/>
+                </a:solidFill>
+                <a:latin typeface="DejaVu Sans"/>
+                <a:ea typeface="DejaVu Sans"/>
+                <a:cs typeface="DejaVu Sans"/>
+              </a:defRPr>
+            </a:lvl6pPr>
+            <a:lvl7pPr>
+              <a:defRPr sz="1725" b="0">
+                <a:solidFill>
+                  <a:srgbClr val="B6C0D1"/>
+                </a:solidFill>
+                <a:latin typeface="DejaVu Sans"/>
+                <a:ea typeface="DejaVu Sans"/>
+                <a:cs typeface="DejaVu Sans"/>
+              </a:defRPr>
+            </a:lvl7pPr>
+            <a:lvl8pPr>
+              <a:defRPr sz="1725" b="0">
+                <a:solidFill>
+                  <a:srgbClr val="B6C0D1"/>
+                </a:solidFill>
+                <a:latin typeface="DejaVu Sans"/>
+                <a:ea typeface="DejaVu Sans"/>
+                <a:cs typeface="DejaVu Sans"/>
+              </a:defRPr>
+            </a:lvl8pPr>
+            <a:lvl9pPr>
+              <a:defRPr sz="1725" b="0">
+                <a:solidFill>
+                  <a:srgbClr val="B6C0D1"/>
+                </a:solidFill>
+                <a:latin typeface="DejaVu Sans"/>
+                <a:ea typeface="DejaVu Sans"/>
+                <a:cs typeface="DejaVu Sans"/>
+              </a:defRPr>
+            </a:lvl9pPr>
+          </a:lstStyle>
+          <a:p xmlns:a="http://schemas.openxmlformats.org/drawingml/2006/main">
+            <a:pPr>
+              <a:defRPr sz="1725" b="0">
+                <a:solidFill>
+                  <a:srgbClr val="B6C0D1"/>
+                </a:solidFill>
+                <a:latin typeface="DejaVu Sans"/>
+                <a:ea typeface="DejaVu Sans"/>
+                <a:cs typeface="DejaVu Sans"/>
+              </a:defRPr>
+            </a:pPr>
+            <a:r>
+              <a:rPr sz="1725" b="0">
+                <a:solidFill>
+                  <a:srgbClr val="B6C0D1"/>
+                </a:solidFill>
+                <a:latin typeface="DejaVu Sans"/>
+                <a:ea typeface="DejaVu Sans"/>
+                <a:cs typeface="DejaVu Sans"/>
+              </a:rPr>
+              <a:t>SOS is readable by phones holding the group code. There has been no independent security review and no forward secrecy.</a:t>
             </a:r>
           </a:p>
         </p:txBody>
@@ -8934,7 +9091,7 @@
     </p:spTree>
     <p:extLst>
       <p:ext uri="{BB962C8B-B14F-4D97-AF65-F5344CB8AC3E}">
-        <p14:creationId xmlns:p14="http://schemas.microsoft.com/office/powerpoint/2010/main" val="1162727454"/>
+        <p14:creationId xmlns:p14="http://schemas.microsoft.com/office/powerpoint/2010/main" val="1069436529"/>
       </p:ext>
     </p:extLst>
   </p:cSld>
@@ -8965,7 +9122,7 @@
           <p:cNvPr id="4" name="">
             <a:extLst xmlns:a="http://schemas.openxmlformats.org/drawingml/2006/main">
               <a:ext uri="{FF2B5EF4-FFF2-40B4-BE49-F238E27FC236}">
-                <a16:creationId xmlns:a16="http://schemas.microsoft.com/office/drawing/2014/main" id="{57E85F53-FE8E-4B56-A5DC-96AC6CD5A351}"/>
+                <a16:creationId xmlns:a16="http://schemas.microsoft.com/office/drawing/2014/main" id="{0620621B-964B-4E1A-AE38-773DAF3CDAF2}"/>
               </a:ext>
             </a:extLst>
           </p:cNvPr>
@@ -9122,7 +9279,7 @@
           <p:cNvPr id="2" name="">
             <a:extLst xmlns:a="http://schemas.openxmlformats.org/drawingml/2006/main">
               <a:ext uri="{FF2B5EF4-FFF2-40B4-BE49-F238E27FC236}">
-                <a16:creationId xmlns:a16="http://schemas.microsoft.com/office/drawing/2014/main" id="{2514CC53-039A-48A2-9695-17C74FDB23C8}"/>
+                <a16:creationId xmlns:a16="http://schemas.microsoft.com/office/drawing/2014/main" id="{8165187A-437D-4714-8690-36A39C2E42C0}"/>
               </a:ext>
             </a:extLst>
           </p:cNvPr>
@@ -9279,7 +9436,7 @@
           <p:cNvPr id="3" name="">
             <a:extLst xmlns:a="http://schemas.openxmlformats.org/drawingml/2006/main">
               <a:ext uri="{FF2B5EF4-FFF2-40B4-BE49-F238E27FC236}">
-                <a16:creationId xmlns:a16="http://schemas.microsoft.com/office/drawing/2014/main" id="{71669BA5-6F66-4D45-9F3E-57E98C0990A3}"/>
+                <a16:creationId xmlns:a16="http://schemas.microsoft.com/office/drawing/2014/main" id="{A40737B6-F92C-45B4-A384-71CFFB9712D9}"/>
               </a:ext>
             </a:extLst>
           </p:cNvPr>
@@ -9797,7 +9954,7 @@
     </p:spTree>
     <p:extLst>
       <p:ext uri="{BB962C8B-B14F-4D97-AF65-F5344CB8AC3E}">
-        <p14:creationId xmlns:p14="http://schemas.microsoft.com/office/powerpoint/2010/main" val="1034682430"/>
+        <p14:creationId xmlns:p14="http://schemas.microsoft.com/office/powerpoint/2010/main" val="442873041"/>
       </p:ext>
     </p:extLst>
   </p:cSld>

</xml_diff>